<commit_message>
Add Digital продюсер Иманбаева to Marcom across all outputs
Add the missing position (Иманбаева Аяулым Маратовна, Digital продюсер,
1 000 162 ₸) to Marcom's «Промо / Контент» block in the Excel source, the
PowerPoint deck, and the self-updating HTML. Marcom is now 14 people;
department ФОТ and the grand total (44 050 321 ₸) recompute accordingly.

Co-Authored-By: Claude Opus 4.8 <noreply@anthropic.com>
Claude-Session: https://claude.ai/code/session_015FvdqNtbbJPjugTChUgZkw
</commit_message>
<xml_diff>
--- a/Структура маркетинга — отделы и ФОТ.pptx
+++ b/Структура маркетинга — отделы и ФОТ.pptx
@@ -1487,7 +1487,7 @@
                 <a:ea typeface="Arial" pitchFamily="34" charset="-122"/>
                 <a:cs typeface="Arial" pitchFamily="34" charset="-120"/>
               </a:rPr>
-              <a:t>13</a:t>
+              <a:t>14</a:t>
             </a:r>
             <a:endParaRPr lang="en-US" sz="2900" dirty="0"/>
           </a:p>
@@ -1618,7 +1618,7 @@
                 <a:ea typeface="Arial" pitchFamily="34" charset="-122"/>
                 <a:cs typeface="Arial" pitchFamily="34" charset="-120"/>
               </a:rPr>
-              <a:t>14 676 401 ₸</a:t>
+              <a:t>15 676 563 ₸</a:t>
             </a:r>
             <a:endParaRPr lang="en-US" sz="1200" dirty="0"/>
           </a:p>
@@ -2396,7 +2396,7 @@
                 <a:ea typeface="Arial" pitchFamily="34" charset="-122"/>
                 <a:cs typeface="Arial" pitchFamily="34" charset="-120"/>
               </a:rPr>
-              <a:t>43 050 159 ₸</a:t>
+              <a:t>44 050 321 ₸</a:t>
             </a:r>
             <a:endParaRPr lang="en-US" sz="2600" dirty="0"/>
           </a:p>
@@ -2570,7 +2570,7 @@
                 <a:ea typeface="Arial" pitchFamily="34" charset="-122"/>
                 <a:cs typeface="Arial" pitchFamily="34" charset="-120"/>
               </a:rPr>
-              <a:t>14 676 401 ₸</a:t>
+              <a:t>15 676 563 ₸</a:t>
             </a:r>
             <a:endParaRPr lang="en-US" sz="1900" dirty="0"/>
           </a:p>
@@ -2590,7 +2590,7 @@
                 <a:ea typeface="Arial" pitchFamily="34" charset="-122"/>
                 <a:cs typeface="Arial" pitchFamily="34" charset="-120"/>
               </a:rPr>
-              <a:t>ФОТ отдела · 13 чел. · оклады/мес</a:t>
+              <a:t>ФОТ отдела · 14 чел. · оклады/мес</a:t>
             </a:r>
             <a:endParaRPr lang="en-US" sz="1900" dirty="0"/>
           </a:p>
@@ -3408,69 +3408,7 @@
         </p:nvSpPr>
         <p:spPr>
           <a:xfrm>
-            <a:off x="6094476" y="1792224"/>
-            <a:ext cx="0" cy="54864"/>
-          </a:xfrm>
-          <a:prstGeom prst="line">
-            <a:avLst/>
-          </a:prstGeom>
-          <a:noFill/>
-          <a:ln w="12700">
-            <a:solidFill>
-              <a:srgbClr val="C7D8EE"/>
-            </a:solidFill>
-            <a:prstDash val="solid"/>
-          </a:ln>
-        </p:spPr>
-      </p:sp>
-      <p:sp>
-        <p:nvSpPr>
-          <p:cNvPr id="22" name="Text 20"/>
-          <p:cNvSpPr/>
-          <p:nvPr/>
-        </p:nvSpPr>
-        <p:spPr>
-          <a:xfrm>
-            <a:off x="4337304" y="1847088"/>
-            <a:ext cx="3514344" cy="292608"/>
-          </a:xfrm>
-          <a:prstGeom prst="rect">
-            <a:avLst/>
-          </a:prstGeom>
-          <a:noFill/>
-          <a:ln/>
-        </p:spPr>
-        <p:txBody>
-          <a:bodyPr wrap="square" lIns="0" tIns="0" rIns="0" bIns="0" rtlCol="0" anchor="ctr"/>
-          <a:lstStyle/>
-          <a:p>
-            <a:pPr algn="ctr" indent="0" marL="0">
-              <a:buNone/>
-            </a:pPr>
-            <a:r>
-              <a:rPr lang="en-US" sz="1200" b="1" dirty="0">
-                <a:solidFill>
-                  <a:srgbClr val="2E5C8A"/>
-                </a:solidFill>
-                <a:latin typeface="Arial" pitchFamily="34" charset="0"/>
-                <a:ea typeface="Arial" pitchFamily="34" charset="-122"/>
-                <a:cs typeface="Arial" pitchFamily="34" charset="-120"/>
-              </a:rPr>
-              <a:t>SMM  (gen · original · sport)</a:t>
-            </a:r>
-            <a:endParaRPr lang="en-US" sz="1200" dirty="0"/>
-          </a:p>
-        </p:txBody>
-      </p:sp>
-      <p:sp>
-        <p:nvSpPr>
-          <p:cNvPr id="23" name="Shape 21"/>
-          <p:cNvSpPr/>
-          <p:nvPr/>
-        </p:nvSpPr>
-        <p:spPr>
-          <a:xfrm>
-            <a:off x="4337304" y="2194560"/>
+            <a:off x="457200" y="5737860"/>
             <a:ext cx="3514344" cy="640080"/>
           </a:xfrm>
           <a:prstGeom prst="roundRect">
@@ -3498,14 +3436,119 @@
       </p:sp>
       <p:sp>
         <p:nvSpPr>
+          <p:cNvPr id="22" name="Text 20"/>
+          <p:cNvSpPr/>
+          <p:nvPr/>
+        </p:nvSpPr>
+        <p:spPr>
+          <a:xfrm>
+            <a:off x="530352" y="5783580"/>
+            <a:ext cx="3368040" cy="548640"/>
+          </a:xfrm>
+          <a:prstGeom prst="rect">
+            <a:avLst/>
+          </a:prstGeom>
+          <a:noFill/>
+          <a:ln/>
+        </p:spPr>
+        <p:txBody>
+          <a:bodyPr wrap="square" lIns="0" tIns="0" rIns="0" bIns="0" rtlCol="0" anchor="ctr"/>
+          <a:lstStyle/>
+          <a:p>
+            <a:pPr algn="ctr" indent="0" marL="0">
+              <a:lnSpc>
+                <a:spcPct val="100000"/>
+              </a:lnSpc>
+              <a:buNone/>
+            </a:pPr>
+            <a:r>
+              <a:rPr lang="en-US" sz="1050" b="1" dirty="0">
+                <a:solidFill>
+                  <a:srgbClr val="1F2A37"/>
+                </a:solidFill>
+                <a:latin typeface="Arial" pitchFamily="34" charset="0"/>
+                <a:ea typeface="Arial" pitchFamily="34" charset="-122"/>
+                <a:cs typeface="Arial" pitchFamily="34" charset="-120"/>
+              </a:rPr>
+              <a:t>Promo · Аяулым</a:t>
+            </a:r>
+            <a:endParaRPr lang="en-US" sz="1050" dirty="0"/>
+          </a:p>
+          <a:p>
+            <a:pPr algn="ctr" indent="0" marL="0">
+              <a:lnSpc>
+                <a:spcPct val="100000"/>
+              </a:lnSpc>
+              <a:buNone/>
+            </a:pPr>
+            <a:r>
+              <a:rPr lang="en-US" sz="800" i="1" dirty="0">
+                <a:solidFill>
+                  <a:srgbClr val="5B6B7C"/>
+                </a:solidFill>
+                <a:latin typeface="Arial" pitchFamily="34" charset="0"/>
+                <a:ea typeface="Arial" pitchFamily="34" charset="-122"/>
+                <a:cs typeface="Arial" pitchFamily="34" charset="-120"/>
+              </a:rPr>
+              <a:t>Иманбаева Аяулым Маратовна</a:t>
+            </a:r>
+            <a:endParaRPr lang="en-US" sz="1050" dirty="0"/>
+          </a:p>
+          <a:p>
+            <a:pPr algn="ctr" indent="0" marL="0">
+              <a:lnSpc>
+                <a:spcPct val="100000"/>
+              </a:lnSpc>
+              <a:buNone/>
+            </a:pPr>
+            <a:r>
+              <a:rPr lang="en-US" sz="1100" b="1" dirty="0">
+                <a:solidFill>
+                  <a:srgbClr val="0F6E4F"/>
+                </a:solidFill>
+                <a:latin typeface="Arial" pitchFamily="34" charset="0"/>
+                <a:ea typeface="Arial" pitchFamily="34" charset="-122"/>
+                <a:cs typeface="Arial" pitchFamily="34" charset="-120"/>
+              </a:rPr>
+              <a:t>1 000 162 ₸</a:t>
+            </a:r>
+            <a:endParaRPr lang="en-US" sz="1050" dirty="0"/>
+          </a:p>
+        </p:txBody>
+      </p:sp>
+      <p:sp>
+        <p:nvSpPr>
+          <p:cNvPr id="23" name="Shape 21"/>
+          <p:cNvSpPr/>
+          <p:nvPr/>
+        </p:nvSpPr>
+        <p:spPr>
+          <a:xfrm>
+            <a:off x="6094476" y="1792224"/>
+            <a:ext cx="0" cy="54864"/>
+          </a:xfrm>
+          <a:prstGeom prst="line">
+            <a:avLst/>
+          </a:prstGeom>
+          <a:noFill/>
+          <a:ln w="12700">
+            <a:solidFill>
+              <a:srgbClr val="C7D8EE"/>
+            </a:solidFill>
+            <a:prstDash val="solid"/>
+          </a:ln>
+        </p:spPr>
+      </p:sp>
+      <p:sp>
+        <p:nvSpPr>
           <p:cNvPr id="24" name="Text 22"/>
           <p:cNvSpPr/>
           <p:nvPr/>
         </p:nvSpPr>
         <p:spPr>
           <a:xfrm>
-            <a:off x="4410456" y="2240280"/>
-            <a:ext cx="3368040" cy="548640"/>
+            <a:off x="4337304" y="1847088"/>
+            <a:ext cx="3514344" cy="292608"/>
           </a:xfrm>
           <a:prstGeom prst="rect">
             <a:avLst/>
@@ -3518,63 +3561,20 @@
           <a:lstStyle/>
           <a:p>
             <a:pPr algn="ctr" indent="0" marL="0">
-              <a:lnSpc>
-                <a:spcPct val="100000"/>
-              </a:lnSpc>
-              <a:buNone/>
-            </a:pPr>
-            <a:r>
-              <a:rPr lang="en-US" sz="1050" b="1" dirty="0">
-                <a:solidFill>
-                  <a:srgbClr val="1F2A37"/>
-                </a:solidFill>
-                <a:latin typeface="Arial" pitchFamily="34" charset="0"/>
-                <a:ea typeface="Arial" pitchFamily="34" charset="-122"/>
-                <a:cs typeface="Arial" pitchFamily="34" charset="-120"/>
-              </a:rPr>
-              <a:t>Head of SMM · Мария</a:t>
-            </a:r>
-            <a:endParaRPr lang="en-US" sz="1050" dirty="0"/>
-          </a:p>
-          <a:p>
-            <a:pPr algn="ctr" indent="0" marL="0">
-              <a:lnSpc>
-                <a:spcPct val="100000"/>
-              </a:lnSpc>
-              <a:buNone/>
-            </a:pPr>
-            <a:r>
-              <a:rPr lang="en-US" sz="800" i="1" dirty="0">
-                <a:solidFill>
-                  <a:srgbClr val="5B6B7C"/>
-                </a:solidFill>
-                <a:latin typeface="Arial" pitchFamily="34" charset="0"/>
-                <a:ea typeface="Arial" pitchFamily="34" charset="-122"/>
-                <a:cs typeface="Arial" pitchFamily="34" charset="-120"/>
-              </a:rPr>
-              <a:t>Коренькова Мария Николаевна</a:t>
-            </a:r>
-            <a:endParaRPr lang="en-US" sz="1050" dirty="0"/>
-          </a:p>
-          <a:p>
-            <a:pPr algn="ctr" indent="0" marL="0">
-              <a:lnSpc>
-                <a:spcPct val="100000"/>
-              </a:lnSpc>
-              <a:buNone/>
-            </a:pPr>
-            <a:r>
-              <a:rPr lang="en-US" sz="1100" b="1" dirty="0">
-                <a:solidFill>
-                  <a:srgbClr val="0F6E4F"/>
-                </a:solidFill>
-                <a:latin typeface="Arial" pitchFamily="34" charset="0"/>
-                <a:ea typeface="Arial" pitchFamily="34" charset="-122"/>
-                <a:cs typeface="Arial" pitchFamily="34" charset="-120"/>
-              </a:rPr>
-              <a:t>1 625 032 ₸</a:t>
-            </a:r>
-            <a:endParaRPr lang="en-US" sz="1050" dirty="0"/>
+              <a:buNone/>
+            </a:pPr>
+            <a:r>
+              <a:rPr lang="en-US" sz="1200" b="1" dirty="0">
+                <a:solidFill>
+                  <a:srgbClr val="2E5C8A"/>
+                </a:solidFill>
+                <a:latin typeface="Arial" pitchFamily="34" charset="0"/>
+                <a:ea typeface="Arial" pitchFamily="34" charset="-122"/>
+                <a:cs typeface="Arial" pitchFamily="34" charset="-120"/>
+              </a:rPr>
+              <a:t>SMM  (gen · original · sport)</a:t>
+            </a:r>
+            <a:endParaRPr lang="en-US" sz="1200" dirty="0"/>
           </a:p>
         </p:txBody>
       </p:sp>
@@ -3586,7 +3586,7 @@
         </p:nvSpPr>
         <p:spPr>
           <a:xfrm>
-            <a:off x="4337304" y="2903220"/>
+            <a:off x="4337304" y="2194560"/>
             <a:ext cx="3514344" cy="640080"/>
           </a:xfrm>
           <a:prstGeom prst="roundRect">
@@ -3620,7 +3620,7 @@
         </p:nvSpPr>
         <p:spPr>
           <a:xfrm>
-            <a:off x="4410456" y="2948940"/>
+            <a:off x="4410456" y="2240280"/>
             <a:ext cx="3368040" cy="548640"/>
           </a:xfrm>
           <a:prstGeom prst="rect">
@@ -3648,7 +3648,7 @@
                 <a:ea typeface="Arial" pitchFamily="34" charset="-122"/>
                 <a:cs typeface="Arial" pitchFamily="34" charset="-120"/>
               </a:rPr>
-              <a:t>SMM Original</a:t>
+              <a:t>Head of SMM · Мария</a:t>
             </a:r>
             <a:endParaRPr lang="en-US" sz="1050" dirty="0"/>
           </a:p>
@@ -3668,7 +3668,7 @@
                 <a:ea typeface="Arial" pitchFamily="34" charset="-122"/>
                 <a:cs typeface="Arial" pitchFamily="34" charset="-120"/>
               </a:rPr>
-              <a:t>SMM менеджер · имя н/д</a:t>
+              <a:t>Коренькова Мария Николаевна</a:t>
             </a:r>
             <a:endParaRPr lang="en-US" sz="1050" dirty="0"/>
           </a:p>
@@ -3682,13 +3682,13 @@
             <a:r>
               <a:rPr lang="en-US" sz="1100" b="1" dirty="0">
                 <a:solidFill>
-                  <a:srgbClr val="B45309"/>
-                </a:solidFill>
-                <a:latin typeface="Arial" pitchFamily="34" charset="0"/>
-                <a:ea typeface="Arial" pitchFamily="34" charset="-122"/>
-                <a:cs typeface="Arial" pitchFamily="34" charset="-120"/>
-              </a:rPr>
-              <a:t>867 456 ₸  *</a:t>
+                  <a:srgbClr val="0F6E4F"/>
+                </a:solidFill>
+                <a:latin typeface="Arial" pitchFamily="34" charset="0"/>
+                <a:ea typeface="Arial" pitchFamily="34" charset="-122"/>
+                <a:cs typeface="Arial" pitchFamily="34" charset="-120"/>
+              </a:rPr>
+              <a:t>1 625 032 ₸</a:t>
             </a:r>
             <a:endParaRPr lang="en-US" sz="1050" dirty="0"/>
           </a:p>
@@ -3702,7 +3702,7 @@
         </p:nvSpPr>
         <p:spPr>
           <a:xfrm>
-            <a:off x="4337304" y="3611880"/>
+            <a:off x="4337304" y="2903220"/>
             <a:ext cx="3514344" cy="640080"/>
           </a:xfrm>
           <a:prstGeom prst="roundRect">
@@ -3736,7 +3736,7 @@
         </p:nvSpPr>
         <p:spPr>
           <a:xfrm>
-            <a:off x="4410456" y="3657600"/>
+            <a:off x="4410456" y="2948940"/>
             <a:ext cx="3368040" cy="548640"/>
           </a:xfrm>
           <a:prstGeom prst="rect">
@@ -3764,7 +3764,7 @@
                 <a:ea typeface="Arial" pitchFamily="34" charset="-122"/>
                 <a:cs typeface="Arial" pitchFamily="34" charset="-120"/>
               </a:rPr>
-              <a:t>SMM Gen</a:t>
+              <a:t>SMM Original</a:t>
             </a:r>
             <a:endParaRPr lang="en-US" sz="1050" dirty="0"/>
           </a:p>
@@ -3818,7 +3818,7 @@
         </p:nvSpPr>
         <p:spPr>
           <a:xfrm>
-            <a:off x="4337304" y="4320540"/>
+            <a:off x="4337304" y="3611880"/>
             <a:ext cx="3514344" cy="640080"/>
           </a:xfrm>
           <a:prstGeom prst="roundRect">
@@ -3852,7 +3852,7 @@
         </p:nvSpPr>
         <p:spPr>
           <a:xfrm>
-            <a:off x="4410456" y="4366260"/>
+            <a:off x="4410456" y="3657600"/>
             <a:ext cx="3368040" cy="548640"/>
           </a:xfrm>
           <a:prstGeom prst="rect">
@@ -3880,7 +3880,7 @@
                 <a:ea typeface="Arial" pitchFamily="34" charset="-122"/>
                 <a:cs typeface="Arial" pitchFamily="34" charset="-120"/>
               </a:rPr>
-              <a:t>SMM Sport</a:t>
+              <a:t>SMM Gen</a:t>
             </a:r>
             <a:endParaRPr lang="en-US" sz="1050" dirty="0"/>
           </a:p>
@@ -3934,7 +3934,7 @@
         </p:nvSpPr>
         <p:spPr>
           <a:xfrm>
-            <a:off x="4337304" y="5029200"/>
+            <a:off x="4337304" y="4320540"/>
             <a:ext cx="3514344" cy="640080"/>
           </a:xfrm>
           <a:prstGeom prst="roundRect">
@@ -3968,7 +3968,7 @@
         </p:nvSpPr>
         <p:spPr>
           <a:xfrm>
-            <a:off x="4410456" y="5074920"/>
+            <a:off x="4410456" y="4366260"/>
             <a:ext cx="3368040" cy="548640"/>
           </a:xfrm>
           <a:prstGeom prst="rect">
@@ -3996,7 +3996,7 @@
                 <a:ea typeface="Arial" pitchFamily="34" charset="-122"/>
                 <a:cs typeface="Arial" pitchFamily="34" charset="-120"/>
               </a:rPr>
-              <a:t>SMM Original</a:t>
+              <a:t>SMM Sport</a:t>
             </a:r>
             <a:endParaRPr lang="en-US" sz="1050" dirty="0"/>
           </a:p>
@@ -4050,7 +4050,7 @@
         </p:nvSpPr>
         <p:spPr>
           <a:xfrm>
-            <a:off x="4337304" y="5737860"/>
+            <a:off x="4337304" y="5029200"/>
             <a:ext cx="3514344" cy="640080"/>
           </a:xfrm>
           <a:prstGeom prst="roundRect">
@@ -4084,7 +4084,7 @@
         </p:nvSpPr>
         <p:spPr>
           <a:xfrm>
-            <a:off x="4410456" y="5783580"/>
+            <a:off x="4410456" y="5074920"/>
             <a:ext cx="3368040" cy="548640"/>
           </a:xfrm>
           <a:prstGeom prst="rect">
@@ -4112,7 +4112,7 @@
                 <a:ea typeface="Arial" pitchFamily="34" charset="-122"/>
                 <a:cs typeface="Arial" pitchFamily="34" charset="-120"/>
               </a:rPr>
-              <a:t>Telegram редактор Sport</a:t>
+              <a:t>SMM Original</a:t>
             </a:r>
             <a:endParaRPr lang="en-US" sz="1050" dirty="0"/>
           </a:p>
@@ -4132,7 +4132,7 @@
                 <a:ea typeface="Arial" pitchFamily="34" charset="-122"/>
                 <a:cs typeface="Arial" pitchFamily="34" charset="-120"/>
               </a:rPr>
-              <a:t>Куричев Иван Николаевич</a:t>
+              <a:t>SMM менеджер · имя н/д</a:t>
             </a:r>
             <a:endParaRPr lang="en-US" sz="1050" dirty="0"/>
           </a:p>
@@ -4146,13 +4146,13 @@
             <a:r>
               <a:rPr lang="en-US" sz="1100" b="1" dirty="0">
                 <a:solidFill>
-                  <a:srgbClr val="0F6E4F"/>
-                </a:solidFill>
-                <a:latin typeface="Arial" pitchFamily="34" charset="0"/>
-                <a:ea typeface="Arial" pitchFamily="34" charset="-122"/>
-                <a:cs typeface="Arial" pitchFamily="34" charset="-120"/>
-              </a:rPr>
-              <a:t>513 920 ₸</a:t>
+                  <a:srgbClr val="B45309"/>
+                </a:solidFill>
+                <a:latin typeface="Arial" pitchFamily="34" charset="0"/>
+                <a:ea typeface="Arial" pitchFamily="34" charset="-122"/>
+                <a:cs typeface="Arial" pitchFamily="34" charset="-120"/>
+              </a:rPr>
+              <a:t>867 456 ₸  *</a:t>
             </a:r>
             <a:endParaRPr lang="en-US" sz="1050" dirty="0"/>
           </a:p>
@@ -4166,69 +4166,7 @@
         </p:nvSpPr>
         <p:spPr>
           <a:xfrm>
-            <a:off x="9974580" y="1792224"/>
-            <a:ext cx="0" cy="54864"/>
-          </a:xfrm>
-          <a:prstGeom prst="line">
-            <a:avLst/>
-          </a:prstGeom>
-          <a:noFill/>
-          <a:ln w="12700">
-            <a:solidFill>
-              <a:srgbClr val="C7D8EE"/>
-            </a:solidFill>
-            <a:prstDash val="solid"/>
-          </a:ln>
-        </p:spPr>
-      </p:sp>
-      <p:sp>
-        <p:nvSpPr>
-          <p:cNvPr id="36" name="Text 34"/>
-          <p:cNvSpPr/>
-          <p:nvPr/>
-        </p:nvSpPr>
-        <p:spPr>
-          <a:xfrm>
-            <a:off x="8217408" y="1847088"/>
-            <a:ext cx="3514344" cy="292608"/>
-          </a:xfrm>
-          <a:prstGeom prst="rect">
-            <a:avLst/>
-          </a:prstGeom>
-          <a:noFill/>
-          <a:ln/>
-        </p:spPr>
-        <p:txBody>
-          <a:bodyPr wrap="square" lIns="0" tIns="0" rIns="0" bIns="0" rtlCol="0" anchor="ctr"/>
-          <a:lstStyle/>
-          <a:p>
-            <a:pPr algn="ctr" indent="0" marL="0">
-              <a:buNone/>
-            </a:pPr>
-            <a:r>
-              <a:rPr lang="en-US" sz="1200" b="1" dirty="0">
-                <a:solidFill>
-                  <a:srgbClr val="2E5C8A"/>
-                </a:solidFill>
-                <a:latin typeface="Arial" pitchFamily="34" charset="0"/>
-                <a:ea typeface="Arial" pitchFamily="34" charset="-122"/>
-                <a:cs typeface="Arial" pitchFamily="34" charset="-120"/>
-              </a:rPr>
-              <a:t>PR</a:t>
-            </a:r>
-            <a:endParaRPr lang="en-US" sz="1200" dirty="0"/>
-          </a:p>
-        </p:txBody>
-      </p:sp>
-      <p:sp>
-        <p:nvSpPr>
-          <p:cNvPr id="37" name="Shape 35"/>
-          <p:cNvSpPr/>
-          <p:nvPr/>
-        </p:nvSpPr>
-        <p:spPr>
-          <a:xfrm>
-            <a:off x="8217408" y="2194560"/>
+            <a:off x="4337304" y="5737860"/>
             <a:ext cx="3514344" cy="640080"/>
           </a:xfrm>
           <a:prstGeom prst="roundRect">
@@ -4256,7 +4194,185 @@
       </p:sp>
       <p:sp>
         <p:nvSpPr>
+          <p:cNvPr id="36" name="Text 34"/>
+          <p:cNvSpPr/>
+          <p:nvPr/>
+        </p:nvSpPr>
+        <p:spPr>
+          <a:xfrm>
+            <a:off x="4410456" y="5783580"/>
+            <a:ext cx="3368040" cy="548640"/>
+          </a:xfrm>
+          <a:prstGeom prst="rect">
+            <a:avLst/>
+          </a:prstGeom>
+          <a:noFill/>
+          <a:ln/>
+        </p:spPr>
+        <p:txBody>
+          <a:bodyPr wrap="square" lIns="0" tIns="0" rIns="0" bIns="0" rtlCol="0" anchor="ctr"/>
+          <a:lstStyle/>
+          <a:p>
+            <a:pPr algn="ctr" indent="0" marL="0">
+              <a:lnSpc>
+                <a:spcPct val="100000"/>
+              </a:lnSpc>
+              <a:buNone/>
+            </a:pPr>
+            <a:r>
+              <a:rPr lang="en-US" sz="1050" b="1" dirty="0">
+                <a:solidFill>
+                  <a:srgbClr val="1F2A37"/>
+                </a:solidFill>
+                <a:latin typeface="Arial" pitchFamily="34" charset="0"/>
+                <a:ea typeface="Arial" pitchFamily="34" charset="-122"/>
+                <a:cs typeface="Arial" pitchFamily="34" charset="-120"/>
+              </a:rPr>
+              <a:t>Telegram редактор Sport</a:t>
+            </a:r>
+            <a:endParaRPr lang="en-US" sz="1050" dirty="0"/>
+          </a:p>
+          <a:p>
+            <a:pPr algn="ctr" indent="0" marL="0">
+              <a:lnSpc>
+                <a:spcPct val="100000"/>
+              </a:lnSpc>
+              <a:buNone/>
+            </a:pPr>
+            <a:r>
+              <a:rPr lang="en-US" sz="800" i="1" dirty="0">
+                <a:solidFill>
+                  <a:srgbClr val="5B6B7C"/>
+                </a:solidFill>
+                <a:latin typeface="Arial" pitchFamily="34" charset="0"/>
+                <a:ea typeface="Arial" pitchFamily="34" charset="-122"/>
+                <a:cs typeface="Arial" pitchFamily="34" charset="-120"/>
+              </a:rPr>
+              <a:t>Куричев Иван Николаевич</a:t>
+            </a:r>
+            <a:endParaRPr lang="en-US" sz="1050" dirty="0"/>
+          </a:p>
+          <a:p>
+            <a:pPr algn="ctr" indent="0" marL="0">
+              <a:lnSpc>
+                <a:spcPct val="100000"/>
+              </a:lnSpc>
+              <a:buNone/>
+            </a:pPr>
+            <a:r>
+              <a:rPr lang="en-US" sz="1100" b="1" dirty="0">
+                <a:solidFill>
+                  <a:srgbClr val="0F6E4F"/>
+                </a:solidFill>
+                <a:latin typeface="Arial" pitchFamily="34" charset="0"/>
+                <a:ea typeface="Arial" pitchFamily="34" charset="-122"/>
+                <a:cs typeface="Arial" pitchFamily="34" charset="-120"/>
+              </a:rPr>
+              <a:t>513 920 ₸</a:t>
+            </a:r>
+            <a:endParaRPr lang="en-US" sz="1050" dirty="0"/>
+          </a:p>
+        </p:txBody>
+      </p:sp>
+      <p:sp>
+        <p:nvSpPr>
+          <p:cNvPr id="37" name="Shape 35"/>
+          <p:cNvSpPr/>
+          <p:nvPr/>
+        </p:nvSpPr>
+        <p:spPr>
+          <a:xfrm>
+            <a:off x="9974580" y="1792224"/>
+            <a:ext cx="0" cy="54864"/>
+          </a:xfrm>
+          <a:prstGeom prst="line">
+            <a:avLst/>
+          </a:prstGeom>
+          <a:noFill/>
+          <a:ln w="12700">
+            <a:solidFill>
+              <a:srgbClr val="C7D8EE"/>
+            </a:solidFill>
+            <a:prstDash val="solid"/>
+          </a:ln>
+        </p:spPr>
+      </p:sp>
+      <p:sp>
+        <p:nvSpPr>
           <p:cNvPr id="38" name="Text 36"/>
+          <p:cNvSpPr/>
+          <p:nvPr/>
+        </p:nvSpPr>
+        <p:spPr>
+          <a:xfrm>
+            <a:off x="8217408" y="1847088"/>
+            <a:ext cx="3514344" cy="292608"/>
+          </a:xfrm>
+          <a:prstGeom prst="rect">
+            <a:avLst/>
+          </a:prstGeom>
+          <a:noFill/>
+          <a:ln/>
+        </p:spPr>
+        <p:txBody>
+          <a:bodyPr wrap="square" lIns="0" tIns="0" rIns="0" bIns="0" rtlCol="0" anchor="ctr"/>
+          <a:lstStyle/>
+          <a:p>
+            <a:pPr algn="ctr" indent="0" marL="0">
+              <a:buNone/>
+            </a:pPr>
+            <a:r>
+              <a:rPr lang="en-US" sz="1200" b="1" dirty="0">
+                <a:solidFill>
+                  <a:srgbClr val="2E5C8A"/>
+                </a:solidFill>
+                <a:latin typeface="Arial" pitchFamily="34" charset="0"/>
+                <a:ea typeface="Arial" pitchFamily="34" charset="-122"/>
+                <a:cs typeface="Arial" pitchFamily="34" charset="-120"/>
+              </a:rPr>
+              <a:t>PR</a:t>
+            </a:r>
+            <a:endParaRPr lang="en-US" sz="1200" dirty="0"/>
+          </a:p>
+        </p:txBody>
+      </p:sp>
+      <p:sp>
+        <p:nvSpPr>
+          <p:cNvPr id="39" name="Shape 37"/>
+          <p:cNvSpPr/>
+          <p:nvPr/>
+        </p:nvSpPr>
+        <p:spPr>
+          <a:xfrm>
+            <a:off x="8217408" y="2194560"/>
+            <a:ext cx="3514344" cy="640080"/>
+          </a:xfrm>
+          <a:prstGeom prst="roundRect">
+            <a:avLst>
+              <a:gd name="adj" fmla="val 8571"/>
+            </a:avLst>
+          </a:prstGeom>
+          <a:solidFill>
+            <a:srgbClr val="EAF1FB"/>
+          </a:solidFill>
+          <a:ln w="12700">
+            <a:solidFill>
+              <a:srgbClr val="C7D8EE"/>
+            </a:solidFill>
+            <a:prstDash val="solid"/>
+          </a:ln>
+          <a:effectLst>
+            <a:outerShdw sx="100000" sy="100000" kx="0" ky="0" algn="bl" rotWithShape="0" blurRad="50800" dist="25400" dir="5400000">
+              <a:srgbClr val="9AA7B4">
+                <a:alpha val="28000"/>
+              </a:srgbClr>
+            </a:outerShdw>
+          </a:effectLst>
+        </p:spPr>
+      </p:sp>
+      <p:sp>
+        <p:nvSpPr>
+          <p:cNvPr id="40" name="Text 38"/>
           <p:cNvSpPr/>
           <p:nvPr/>
         </p:nvSpPr>
@@ -9060,7 +9176,7 @@
                 <a:ea typeface="Arial" pitchFamily="34" charset="-122"/>
                 <a:cs typeface="Arial" pitchFamily="34" charset="-120"/>
               </a:rPr>
-              <a:t>ФОТ отдела = сумма должностных окладов (тотал) всех позиций отдела, включая руководителя. Суммы взяты из Excel; руководители и senior-роли — из отдельного блока стоимостей. Итог по 4 отделам: 43 050 159 ₸ в месяц.</a:t>
+              <a:t>ФОТ отдела = сумма должностных окладов (тотал) всех позиций отдела, включая руководителя. Суммы взяты из Excel; руководители и senior-роли — из отдельного блока стоимостей. Итог по 4 отделам: 44 050 321 ₸ в месяц.</a:t>
             </a:r>
             <a:endParaRPr lang="en-US" sz="1200" dirty="0"/>
           </a:p>

</xml_diff>

<commit_message>
Match original screens: split by direction + real монтажёр names
Rework Marcom and Продакшн layouts to mirror the source screenshots:
- Marcom: Контент in two columns, SMM split into parallel Originals/Gen/
  Sport columns under Head of SMM, PR on the right.
- Продакшн: Design branch (Graph + Motion columns) under Senior art and
  Video production branch under Senior production.
Fill the four Мобилограф/монтажёр boxes with the real production
videographers and their salaries (Асанов 1 000 162, Шаймардан 751 000,
Жұмағали 804 324, Боровков/Sport 523 000), dropping the max-cost
placeholder. Продакшн ФОТ recomputes to 12 930 047 ₸; grand total
41 133 731 ₸. Applied across Excel, PowerPoint and the HTML presentation.

Co-Authored-By: Claude Opus 4.8 <noreply@anthropic.com>
Claude-Session: https://claude.ai/code/session_015FvdqNtbbJPjugTChUgZkw
</commit_message>
<xml_diff>
--- a/Структура маркетинга — отделы и ФОТ.pptx
+++ b/Структура маркетинга — отделы и ФОТ.pptx
@@ -2070,7 +2070,7 @@
                 <a:ea typeface="Arial" pitchFamily="34" charset="-122"/>
                 <a:cs typeface="Arial" pitchFamily="34" charset="-120"/>
               </a:rPr>
-              <a:t>15 846 637 ₸</a:t>
+              <a:t>12 930 047 ₸</a:t>
             </a:r>
             <a:endParaRPr lang="en-US" sz="1200" dirty="0"/>
           </a:p>
@@ -2396,7 +2396,7 @@
                 <a:ea typeface="Arial" pitchFamily="34" charset="-122"/>
                 <a:cs typeface="Arial" pitchFamily="34" charset="-120"/>
               </a:rPr>
-              <a:t>44 050 321 ₸</a:t>
+              <a:t>41 133 731 ₸</a:t>
             </a:r>
             <a:endParaRPr lang="en-US" sz="2600" dirty="0"/>
           </a:p>
@@ -2604,12 +2604,12 @@
         </p:nvSpPr>
         <p:spPr>
           <a:xfrm>
-            <a:off x="3991356" y="1005840"/>
-            <a:ext cx="4206240" cy="731520"/>
+            <a:off x="4448556" y="1060704"/>
+            <a:ext cx="3291840" cy="658368"/>
           </a:xfrm>
           <a:prstGeom prst="roundRect">
             <a:avLst>
-              <a:gd name="adj" fmla="val 7500"/>
+              <a:gd name="adj" fmla="val 8333"/>
             </a:avLst>
           </a:prstGeom>
           <a:solidFill>
@@ -2638,8 +2638,8 @@
         </p:nvSpPr>
         <p:spPr>
           <a:xfrm>
-            <a:off x="4064508" y="1051560"/>
-            <a:ext cx="4059936" cy="640080"/>
+            <a:off x="4521708" y="1106424"/>
+            <a:ext cx="3145536" cy="566928"/>
           </a:xfrm>
           <a:prstGeom prst="rect">
             <a:avLst/>
@@ -2720,8 +2720,8 @@
         </p:nvSpPr>
         <p:spPr>
           <a:xfrm>
-            <a:off x="6094476" y="1737360"/>
-            <a:ext cx="0" cy="54864"/>
+            <a:off x="6094476" y="1719072"/>
+            <a:ext cx="0" cy="91440"/>
           </a:xfrm>
           <a:prstGeom prst="line">
             <a:avLst/>
@@ -2743,8 +2743,8 @@
         </p:nvSpPr>
         <p:spPr>
           <a:xfrm>
-            <a:off x="2214372" y="1792224"/>
-            <a:ext cx="7760208" cy="0"/>
+            <a:off x="2203704" y="1810512"/>
+            <a:ext cx="8618220" cy="0"/>
           </a:xfrm>
           <a:prstGeom prst="line">
             <a:avLst/>
@@ -2766,8 +2766,8 @@
         </p:nvSpPr>
         <p:spPr>
           <a:xfrm>
-            <a:off x="2214372" y="1792224"/>
-            <a:ext cx="0" cy="54864"/>
+            <a:off x="2203704" y="1810512"/>
+            <a:ext cx="0" cy="146304"/>
           </a:xfrm>
           <a:prstGeom prst="line">
             <a:avLst/>
@@ -2783,14 +2783,60 @@
       </p:sp>
       <p:sp>
         <p:nvSpPr>
-          <p:cNvPr id="10" name="Text 8"/>
-          <p:cNvSpPr/>
-          <p:nvPr/>
-        </p:nvSpPr>
-        <p:spPr>
-          <a:xfrm>
-            <a:off x="457200" y="1847088"/>
-            <a:ext cx="3514344" cy="292608"/>
+          <p:cNvPr id="10" name="Shape 8"/>
+          <p:cNvSpPr/>
+          <p:nvPr/>
+        </p:nvSpPr>
+        <p:spPr>
+          <a:xfrm>
+            <a:off x="6963156" y="1810512"/>
+            <a:ext cx="0" cy="146304"/>
+          </a:xfrm>
+          <a:prstGeom prst="line">
+            <a:avLst/>
+          </a:prstGeom>
+          <a:noFill/>
+          <a:ln w="12700">
+            <a:solidFill>
+              <a:srgbClr val="C7D8EE"/>
+            </a:solidFill>
+            <a:prstDash val="solid"/>
+          </a:ln>
+        </p:spPr>
+      </p:sp>
+      <p:sp>
+        <p:nvSpPr>
+          <p:cNvPr id="11" name="Shape 9"/>
+          <p:cNvSpPr/>
+          <p:nvPr/>
+        </p:nvSpPr>
+        <p:spPr>
+          <a:xfrm>
+            <a:off x="10821924" y="1810512"/>
+            <a:ext cx="0" cy="146304"/>
+          </a:xfrm>
+          <a:prstGeom prst="line">
+            <a:avLst/>
+          </a:prstGeom>
+          <a:noFill/>
+          <a:ln w="12700">
+            <a:solidFill>
+              <a:srgbClr val="C7D8EE"/>
+            </a:solidFill>
+            <a:prstDash val="solid"/>
+          </a:ln>
+        </p:spPr>
+      </p:sp>
+      <p:sp>
+        <p:nvSpPr>
+          <p:cNvPr id="12" name="Text 10"/>
+          <p:cNvSpPr/>
+          <p:nvPr/>
+        </p:nvSpPr>
+        <p:spPr>
+          <a:xfrm>
+            <a:off x="457200" y="1956816"/>
+            <a:ext cx="3493008" cy="292608"/>
           </a:xfrm>
           <a:prstGeom prst="rect">
             <a:avLst/>
@@ -2814,7 +2860,7 @@
                 <a:ea typeface="Arial" pitchFamily="34" charset="-122"/>
                 <a:cs typeface="Arial" pitchFamily="34" charset="-120"/>
               </a:rPr>
-              <a:t>Промо / Контент  (original · sport)</a:t>
+              <a:t>Контент  (original · sport)</a:t>
             </a:r>
             <a:endParaRPr lang="en-US" sz="1200" dirty="0"/>
           </a:p>
@@ -2822,18 +2868,96 @@
       </p:sp>
       <p:sp>
         <p:nvSpPr>
-          <p:cNvPr id="11" name="Shape 9"/>
-          <p:cNvSpPr/>
-          <p:nvPr/>
-        </p:nvSpPr>
-        <p:spPr>
-          <a:xfrm>
-            <a:off x="457200" y="2194560"/>
-            <a:ext cx="3514344" cy="640080"/>
+          <p:cNvPr id="13" name="Text 11"/>
+          <p:cNvSpPr/>
+          <p:nvPr/>
+        </p:nvSpPr>
+        <p:spPr>
+          <a:xfrm>
+            <a:off x="4315968" y="1956816"/>
+            <a:ext cx="5294376" cy="292608"/>
+          </a:xfrm>
+          <a:prstGeom prst="rect">
+            <a:avLst/>
+          </a:prstGeom>
+          <a:noFill/>
+          <a:ln/>
+        </p:spPr>
+        <p:txBody>
+          <a:bodyPr wrap="square" lIns="0" tIns="0" rIns="0" bIns="0" rtlCol="0" anchor="ctr"/>
+          <a:lstStyle/>
+          <a:p>
+            <a:pPr algn="ctr" indent="0" marL="0">
+              <a:buNone/>
+            </a:pPr>
+            <a:r>
+              <a:rPr lang="en-US" sz="1200" b="1" dirty="0">
+                <a:solidFill>
+                  <a:srgbClr val="2E5C8A"/>
+                </a:solidFill>
+                <a:latin typeface="Arial" pitchFamily="34" charset="0"/>
+                <a:ea typeface="Arial" pitchFamily="34" charset="-122"/>
+                <a:cs typeface="Arial" pitchFamily="34" charset="-120"/>
+              </a:rPr>
+              <a:t>SMM  (gen · original · sport)</a:t>
+            </a:r>
+            <a:endParaRPr lang="en-US" sz="1200" dirty="0"/>
+          </a:p>
+        </p:txBody>
+      </p:sp>
+      <p:sp>
+        <p:nvSpPr>
+          <p:cNvPr id="14" name="Text 12"/>
+          <p:cNvSpPr/>
+          <p:nvPr/>
+        </p:nvSpPr>
+        <p:spPr>
+          <a:xfrm>
+            <a:off x="9976104" y="1956816"/>
+            <a:ext cx="1691640" cy="292608"/>
+          </a:xfrm>
+          <a:prstGeom prst="rect">
+            <a:avLst/>
+          </a:prstGeom>
+          <a:noFill/>
+          <a:ln/>
+        </p:spPr>
+        <p:txBody>
+          <a:bodyPr wrap="square" lIns="0" tIns="0" rIns="0" bIns="0" rtlCol="0" anchor="ctr"/>
+          <a:lstStyle/>
+          <a:p>
+            <a:pPr algn="ctr" indent="0" marL="0">
+              <a:buNone/>
+            </a:pPr>
+            <a:r>
+              <a:rPr lang="en-US" sz="1200" b="1" dirty="0">
+                <a:solidFill>
+                  <a:srgbClr val="2E5C8A"/>
+                </a:solidFill>
+                <a:latin typeface="Arial" pitchFamily="34" charset="0"/>
+                <a:ea typeface="Arial" pitchFamily="34" charset="-122"/>
+                <a:cs typeface="Arial" pitchFamily="34" charset="-120"/>
+              </a:rPr>
+              <a:t>PR</a:t>
+            </a:r>
+            <a:endParaRPr lang="en-US" sz="1200" dirty="0"/>
+          </a:p>
+        </p:txBody>
+      </p:sp>
+      <p:sp>
+        <p:nvSpPr>
+          <p:cNvPr id="15" name="Shape 13"/>
+          <p:cNvSpPr/>
+          <p:nvPr/>
+        </p:nvSpPr>
+        <p:spPr>
+          <a:xfrm>
+            <a:off x="457200" y="2340864"/>
+            <a:ext cx="1691640" cy="932688"/>
           </a:xfrm>
           <a:prstGeom prst="roundRect">
             <a:avLst>
-              <a:gd name="adj" fmla="val 8571"/>
+              <a:gd name="adj" fmla="val 5882"/>
             </a:avLst>
           </a:prstGeom>
           <a:solidFill>
@@ -2856,14 +2980,14 @@
       </p:sp>
       <p:sp>
         <p:nvSpPr>
-          <p:cNvPr id="12" name="Text 10"/>
-          <p:cNvSpPr/>
-          <p:nvPr/>
-        </p:nvSpPr>
-        <p:spPr>
-          <a:xfrm>
-            <a:off x="530352" y="2240280"/>
-            <a:ext cx="3368040" cy="548640"/>
+          <p:cNvPr id="16" name="Text 14"/>
+          <p:cNvSpPr/>
+          <p:nvPr/>
+        </p:nvSpPr>
+        <p:spPr>
+          <a:xfrm>
+            <a:off x="530352" y="2386584"/>
+            <a:ext cx="1545336" cy="841248"/>
           </a:xfrm>
           <a:prstGeom prst="rect">
             <a:avLst/>
@@ -2882,7 +3006,7 @@
               <a:buNone/>
             </a:pPr>
             <a:r>
-              <a:rPr lang="en-US" sz="1050" b="1" dirty="0">
+              <a:rPr lang="en-US" sz="945" b="1" dirty="0">
                 <a:solidFill>
                   <a:srgbClr val="1F2A37"/>
                 </a:solidFill>
@@ -2892,17 +3016,17 @@
               </a:rPr>
               <a:t>Senior Promo Original · Аида А</a:t>
             </a:r>
-            <a:endParaRPr lang="en-US" sz="1050" dirty="0"/>
-          </a:p>
-          <a:p>
-            <a:pPr algn="ctr" indent="0" marL="0">
-              <a:lnSpc>
-                <a:spcPct val="100000"/>
-              </a:lnSpc>
-              <a:buNone/>
-            </a:pPr>
-            <a:r>
-              <a:rPr lang="en-US" sz="800" i="1" dirty="0">
+            <a:endParaRPr lang="en-US" sz="945" dirty="0"/>
+          </a:p>
+          <a:p>
+            <a:pPr algn="ctr" indent="0" marL="0">
+              <a:lnSpc>
+                <a:spcPct val="100000"/>
+              </a:lnSpc>
+              <a:buNone/>
+            </a:pPr>
+            <a:r>
+              <a:rPr lang="en-US" sz="720" i="1" dirty="0">
                 <a:solidFill>
                   <a:srgbClr val="5B6B7C"/>
                 </a:solidFill>
@@ -2912,17 +3036,17 @@
               </a:rPr>
               <a:t>Әлішбай Аида Шералықызы</a:t>
             </a:r>
-            <a:endParaRPr lang="en-US" sz="1050" dirty="0"/>
-          </a:p>
-          <a:p>
-            <a:pPr algn="ctr" indent="0" marL="0">
-              <a:lnSpc>
-                <a:spcPct val="100000"/>
-              </a:lnSpc>
-              <a:buNone/>
-            </a:pPr>
-            <a:r>
-              <a:rPr lang="en-US" sz="1100" b="1" dirty="0">
+            <a:endParaRPr lang="en-US" sz="945" dirty="0"/>
+          </a:p>
+          <a:p>
+            <a:pPr algn="ctr" indent="0" marL="0">
+              <a:lnSpc>
+                <a:spcPct val="100000"/>
+              </a:lnSpc>
+              <a:buNone/>
+            </a:pPr>
+            <a:r>
+              <a:rPr lang="en-US" sz="990" b="1" dirty="0">
                 <a:solidFill>
                   <a:srgbClr val="0F6E4F"/>
                 </a:solidFill>
@@ -2932,24 +3056,24 @@
               </a:rPr>
               <a:t>1 247 076 ₸</a:t>
             </a:r>
-            <a:endParaRPr lang="en-US" sz="1050" dirty="0"/>
-          </a:p>
-        </p:txBody>
-      </p:sp>
-      <p:sp>
-        <p:nvSpPr>
-          <p:cNvPr id="13" name="Shape 11"/>
-          <p:cNvSpPr/>
-          <p:nvPr/>
-        </p:nvSpPr>
-        <p:spPr>
-          <a:xfrm>
-            <a:off x="457200" y="2903220"/>
-            <a:ext cx="3514344" cy="640080"/>
+            <a:endParaRPr lang="en-US" sz="945" dirty="0"/>
+          </a:p>
+        </p:txBody>
+      </p:sp>
+      <p:sp>
+        <p:nvSpPr>
+          <p:cNvPr id="17" name="Shape 15"/>
+          <p:cNvSpPr/>
+          <p:nvPr/>
+        </p:nvSpPr>
+        <p:spPr>
+          <a:xfrm>
+            <a:off x="457200" y="3364992"/>
+            <a:ext cx="1691640" cy="932688"/>
           </a:xfrm>
           <a:prstGeom prst="roundRect">
             <a:avLst>
-              <a:gd name="adj" fmla="val 8571"/>
+              <a:gd name="adj" fmla="val 5882"/>
             </a:avLst>
           </a:prstGeom>
           <a:solidFill>
@@ -2972,14 +3096,14 @@
       </p:sp>
       <p:sp>
         <p:nvSpPr>
-          <p:cNvPr id="14" name="Text 12"/>
-          <p:cNvSpPr/>
-          <p:nvPr/>
-        </p:nvSpPr>
-        <p:spPr>
-          <a:xfrm>
-            <a:off x="530352" y="2948940"/>
-            <a:ext cx="3368040" cy="548640"/>
+          <p:cNvPr id="18" name="Text 16"/>
+          <p:cNvSpPr/>
+          <p:nvPr/>
+        </p:nvSpPr>
+        <p:spPr>
+          <a:xfrm>
+            <a:off x="530352" y="3410712"/>
+            <a:ext cx="1545336" cy="841248"/>
           </a:xfrm>
           <a:prstGeom prst="rect">
             <a:avLst/>
@@ -2998,7 +3122,7 @@
               <a:buNone/>
             </a:pPr>
             <a:r>
-              <a:rPr lang="en-US" sz="1050" b="1" dirty="0">
+              <a:rPr lang="en-US" sz="945" b="1" dirty="0">
                 <a:solidFill>
                   <a:srgbClr val="1F2A37"/>
                 </a:solidFill>
@@ -3006,19 +3130,19 @@
                 <a:ea typeface="Arial" pitchFamily="34" charset="-122"/>
                 <a:cs typeface="Arial" pitchFamily="34" charset="-120"/>
               </a:rPr>
-              <a:t>Promo · Александр К</a:t>
-            </a:r>
-            <a:endParaRPr lang="en-US" sz="1050" dirty="0"/>
-          </a:p>
-          <a:p>
-            <a:pPr algn="ctr" indent="0" marL="0">
-              <a:lnSpc>
-                <a:spcPct val="100000"/>
-              </a:lnSpc>
-              <a:buNone/>
-            </a:pPr>
-            <a:r>
-              <a:rPr lang="en-US" sz="800" i="1" dirty="0">
+              <a:t>Promo · Райлана</a:t>
+            </a:r>
+            <a:endParaRPr lang="en-US" sz="945" dirty="0"/>
+          </a:p>
+          <a:p>
+            <a:pPr algn="ctr" indent="0" marL="0">
+              <a:lnSpc>
+                <a:spcPct val="100000"/>
+              </a:lnSpc>
+              <a:buNone/>
+            </a:pPr>
+            <a:r>
+              <a:rPr lang="en-US" sz="720" i="1" dirty="0">
                 <a:solidFill>
                   <a:srgbClr val="5B6B7C"/>
                 </a:solidFill>
@@ -3026,19 +3150,19 @@
                 <a:ea typeface="Arial" pitchFamily="34" charset="-122"/>
                 <a:cs typeface="Arial" pitchFamily="34" charset="-120"/>
               </a:rPr>
-              <a:t>Казачков Александр</a:t>
-            </a:r>
-            <a:endParaRPr lang="en-US" sz="1050" dirty="0"/>
-          </a:p>
-          <a:p>
-            <a:pPr algn="ctr" indent="0" marL="0">
-              <a:lnSpc>
-                <a:spcPct val="100000"/>
-              </a:lnSpc>
-              <a:buNone/>
-            </a:pPr>
-            <a:r>
-              <a:rPr lang="en-US" sz="1100" b="1" dirty="0">
+              <a:t>Жанибекова Райлана Нурлановна</a:t>
+            </a:r>
+            <a:endParaRPr lang="en-US" sz="945" dirty="0"/>
+          </a:p>
+          <a:p>
+            <a:pPr algn="ctr" indent="0" marL="0">
+              <a:lnSpc>
+                <a:spcPct val="100000"/>
+              </a:lnSpc>
+              <a:buNone/>
+            </a:pPr>
+            <a:r>
+              <a:rPr lang="en-US" sz="990" b="1" dirty="0">
                 <a:solidFill>
                   <a:srgbClr val="0F6E4F"/>
                 </a:solidFill>
@@ -3046,26 +3170,26 @@
                 <a:ea typeface="Arial" pitchFamily="34" charset="-122"/>
                 <a:cs typeface="Arial" pitchFamily="34" charset="-120"/>
               </a:rPr>
-              <a:t>800 000 ₸</a:t>
-            </a:r>
-            <a:endParaRPr lang="en-US" sz="1050" dirty="0"/>
-          </a:p>
-        </p:txBody>
-      </p:sp>
-      <p:sp>
-        <p:nvSpPr>
-          <p:cNvPr id="15" name="Shape 13"/>
-          <p:cNvSpPr/>
-          <p:nvPr/>
-        </p:nvSpPr>
-        <p:spPr>
-          <a:xfrm>
-            <a:off x="457200" y="3611880"/>
-            <a:ext cx="3514344" cy="640080"/>
+              <a:t>1 000 162 ₸</a:t>
+            </a:r>
+            <a:endParaRPr lang="en-US" sz="945" dirty="0"/>
+          </a:p>
+        </p:txBody>
+      </p:sp>
+      <p:sp>
+        <p:nvSpPr>
+          <p:cNvPr id="19" name="Shape 17"/>
+          <p:cNvSpPr/>
+          <p:nvPr/>
+        </p:nvSpPr>
+        <p:spPr>
+          <a:xfrm>
+            <a:off x="457200" y="4389120"/>
+            <a:ext cx="1691640" cy="932688"/>
           </a:xfrm>
           <a:prstGeom prst="roundRect">
             <a:avLst>
-              <a:gd name="adj" fmla="val 8571"/>
+              <a:gd name="adj" fmla="val 5882"/>
             </a:avLst>
           </a:prstGeom>
           <a:solidFill>
@@ -3088,14 +3212,14 @@
       </p:sp>
       <p:sp>
         <p:nvSpPr>
-          <p:cNvPr id="16" name="Text 14"/>
-          <p:cNvSpPr/>
-          <p:nvPr/>
-        </p:nvSpPr>
-        <p:spPr>
-          <a:xfrm>
-            <a:off x="530352" y="3657600"/>
-            <a:ext cx="3368040" cy="548640"/>
+          <p:cNvPr id="20" name="Text 18"/>
+          <p:cNvSpPr/>
+          <p:nvPr/>
+        </p:nvSpPr>
+        <p:spPr>
+          <a:xfrm>
+            <a:off x="530352" y="4434840"/>
+            <a:ext cx="1545336" cy="841248"/>
           </a:xfrm>
           <a:prstGeom prst="rect">
             <a:avLst/>
@@ -3114,7 +3238,7 @@
               <a:buNone/>
             </a:pPr>
             <a:r>
-              <a:rPr lang="en-US" sz="1050" b="1" dirty="0">
+              <a:rPr lang="en-US" sz="945" b="1" dirty="0">
                 <a:solidFill>
                   <a:srgbClr val="1F2A37"/>
                 </a:solidFill>
@@ -3122,19 +3246,19 @@
                 <a:ea typeface="Arial" pitchFamily="34" charset="-122"/>
                 <a:cs typeface="Arial" pitchFamily="34" charset="-120"/>
               </a:rPr>
-              <a:t>Promo · Райлана</a:t>
-            </a:r>
-            <a:endParaRPr lang="en-US" sz="1050" dirty="0"/>
-          </a:p>
-          <a:p>
-            <a:pPr algn="ctr" indent="0" marL="0">
-              <a:lnSpc>
-                <a:spcPct val="100000"/>
-              </a:lnSpc>
-              <a:buNone/>
-            </a:pPr>
-            <a:r>
-              <a:rPr lang="en-US" sz="800" i="1" dirty="0">
+              <a:t>Promo · Чолпон</a:t>
+            </a:r>
+            <a:endParaRPr lang="en-US" sz="945" dirty="0"/>
+          </a:p>
+          <a:p>
+            <a:pPr algn="ctr" indent="0" marL="0">
+              <a:lnSpc>
+                <a:spcPct val="100000"/>
+              </a:lnSpc>
+              <a:buNone/>
+            </a:pPr>
+            <a:r>
+              <a:rPr lang="en-US" sz="720" i="1" dirty="0">
                 <a:solidFill>
                   <a:srgbClr val="5B6B7C"/>
                 </a:solidFill>
@@ -3142,19 +3266,19 @@
                 <a:ea typeface="Arial" pitchFamily="34" charset="-122"/>
                 <a:cs typeface="Arial" pitchFamily="34" charset="-120"/>
               </a:rPr>
-              <a:t>Жанибекова Райлана Нурлановна</a:t>
-            </a:r>
-            <a:endParaRPr lang="en-US" sz="1050" dirty="0"/>
-          </a:p>
-          <a:p>
-            <a:pPr algn="ctr" indent="0" marL="0">
-              <a:lnSpc>
-                <a:spcPct val="100000"/>
-              </a:lnSpc>
-              <a:buNone/>
-            </a:pPr>
-            <a:r>
-              <a:rPr lang="en-US" sz="1100" b="1" dirty="0">
+              <a:t>Эркинова Чолпон</a:t>
+            </a:r>
+            <a:endParaRPr lang="en-US" sz="945" dirty="0"/>
+          </a:p>
+          <a:p>
+            <a:pPr algn="ctr" indent="0" marL="0">
+              <a:lnSpc>
+                <a:spcPct val="100000"/>
+              </a:lnSpc>
+              <a:buNone/>
+            </a:pPr>
+            <a:r>
+              <a:rPr lang="en-US" sz="990" b="1" dirty="0">
                 <a:solidFill>
                   <a:srgbClr val="0F6E4F"/>
                 </a:solidFill>
@@ -3162,26 +3286,26 @@
                 <a:ea typeface="Arial" pitchFamily="34" charset="-122"/>
                 <a:cs typeface="Arial" pitchFamily="34" charset="-120"/>
               </a:rPr>
-              <a:t>1 000 162 ₸</a:t>
-            </a:r>
-            <a:endParaRPr lang="en-US" sz="1050" dirty="0"/>
-          </a:p>
-        </p:txBody>
-      </p:sp>
-      <p:sp>
-        <p:nvSpPr>
-          <p:cNvPr id="17" name="Shape 15"/>
-          <p:cNvSpPr/>
-          <p:nvPr/>
-        </p:nvSpPr>
-        <p:spPr>
-          <a:xfrm>
-            <a:off x="457200" y="4320540"/>
-            <a:ext cx="3514344" cy="640080"/>
+              <a:t>1 025 642 ₸</a:t>
+            </a:r>
+            <a:endParaRPr lang="en-US" sz="945" dirty="0"/>
+          </a:p>
+        </p:txBody>
+      </p:sp>
+      <p:sp>
+        <p:nvSpPr>
+          <p:cNvPr id="21" name="Shape 19"/>
+          <p:cNvSpPr/>
+          <p:nvPr/>
+        </p:nvSpPr>
+        <p:spPr>
+          <a:xfrm>
+            <a:off x="2258568" y="2340864"/>
+            <a:ext cx="1691640" cy="932688"/>
           </a:xfrm>
           <a:prstGeom prst="roundRect">
             <a:avLst>
-              <a:gd name="adj" fmla="val 8571"/>
+              <a:gd name="adj" fmla="val 5882"/>
             </a:avLst>
           </a:prstGeom>
           <a:solidFill>
@@ -3204,14 +3328,14 @@
       </p:sp>
       <p:sp>
         <p:nvSpPr>
-          <p:cNvPr id="18" name="Text 16"/>
-          <p:cNvSpPr/>
-          <p:nvPr/>
-        </p:nvSpPr>
-        <p:spPr>
-          <a:xfrm>
-            <a:off x="530352" y="4366260"/>
-            <a:ext cx="3368040" cy="548640"/>
+          <p:cNvPr id="22" name="Text 20"/>
+          <p:cNvSpPr/>
+          <p:nvPr/>
+        </p:nvSpPr>
+        <p:spPr>
+          <a:xfrm>
+            <a:off x="2331720" y="2386584"/>
+            <a:ext cx="1545336" cy="841248"/>
           </a:xfrm>
           <a:prstGeom prst="rect">
             <a:avLst/>
@@ -3230,7 +3354,7 @@
               <a:buNone/>
             </a:pPr>
             <a:r>
-              <a:rPr lang="en-US" sz="1050" b="1" dirty="0">
+              <a:rPr lang="en-US" sz="945" b="1" dirty="0">
                 <a:solidFill>
                   <a:srgbClr val="1F2A37"/>
                 </a:solidFill>
@@ -3238,19 +3362,19 @@
                 <a:ea typeface="Arial" pitchFamily="34" charset="-122"/>
                 <a:cs typeface="Arial" pitchFamily="34" charset="-120"/>
               </a:rPr>
-              <a:t>Promo · Яков</a:t>
-            </a:r>
-            <a:endParaRPr lang="en-US" sz="1050" dirty="0"/>
-          </a:p>
-          <a:p>
-            <a:pPr algn="ctr" indent="0" marL="0">
-              <a:lnSpc>
-                <a:spcPct val="100000"/>
-              </a:lnSpc>
-              <a:buNone/>
-            </a:pPr>
-            <a:r>
-              <a:rPr lang="en-US" sz="800" i="1" dirty="0">
+              <a:t>Promo · Александр К</a:t>
+            </a:r>
+            <a:endParaRPr lang="en-US" sz="945" dirty="0"/>
+          </a:p>
+          <a:p>
+            <a:pPr algn="ctr" indent="0" marL="0">
+              <a:lnSpc>
+                <a:spcPct val="100000"/>
+              </a:lnSpc>
+              <a:buNone/>
+            </a:pPr>
+            <a:r>
+              <a:rPr lang="en-US" sz="720" i="1" dirty="0">
                 <a:solidFill>
                   <a:srgbClr val="5B6B7C"/>
                 </a:solidFill>
@@ -3258,19 +3382,19 @@
                 <a:ea typeface="Arial" pitchFamily="34" charset="-122"/>
                 <a:cs typeface="Arial" pitchFamily="34" charset="-120"/>
               </a:rPr>
-              <a:t>Сорокин Яков Андреевич</a:t>
-            </a:r>
-            <a:endParaRPr lang="en-US" sz="1050" dirty="0"/>
-          </a:p>
-          <a:p>
-            <a:pPr algn="ctr" indent="0" marL="0">
-              <a:lnSpc>
-                <a:spcPct val="100000"/>
-              </a:lnSpc>
-              <a:buNone/>
-            </a:pPr>
-            <a:r>
-              <a:rPr lang="en-US" sz="1100" b="1" dirty="0">
+              <a:t>Казачков Александр</a:t>
+            </a:r>
+            <a:endParaRPr lang="en-US" sz="945" dirty="0"/>
+          </a:p>
+          <a:p>
+            <a:pPr algn="ctr" indent="0" marL="0">
+              <a:lnSpc>
+                <a:spcPct val="100000"/>
+              </a:lnSpc>
+              <a:buNone/>
+            </a:pPr>
+            <a:r>
+              <a:rPr lang="en-US" sz="990" b="1" dirty="0">
                 <a:solidFill>
                   <a:srgbClr val="0F6E4F"/>
                 </a:solidFill>
@@ -3278,26 +3402,26 @@
                 <a:ea typeface="Arial" pitchFamily="34" charset="-122"/>
                 <a:cs typeface="Arial" pitchFamily="34" charset="-120"/>
               </a:rPr>
-              <a:t>614 931 ₸</a:t>
-            </a:r>
-            <a:endParaRPr lang="en-US" sz="1050" dirty="0"/>
-          </a:p>
-        </p:txBody>
-      </p:sp>
-      <p:sp>
-        <p:nvSpPr>
-          <p:cNvPr id="19" name="Shape 17"/>
-          <p:cNvSpPr/>
-          <p:nvPr/>
-        </p:nvSpPr>
-        <p:spPr>
-          <a:xfrm>
-            <a:off x="457200" y="5029200"/>
-            <a:ext cx="3514344" cy="640080"/>
+              <a:t>800 000 ₸</a:t>
+            </a:r>
+            <a:endParaRPr lang="en-US" sz="945" dirty="0"/>
+          </a:p>
+        </p:txBody>
+      </p:sp>
+      <p:sp>
+        <p:nvSpPr>
+          <p:cNvPr id="23" name="Shape 21"/>
+          <p:cNvSpPr/>
+          <p:nvPr/>
+        </p:nvSpPr>
+        <p:spPr>
+          <a:xfrm>
+            <a:off x="2258568" y="3364992"/>
+            <a:ext cx="1691640" cy="932688"/>
           </a:xfrm>
           <a:prstGeom prst="roundRect">
             <a:avLst>
-              <a:gd name="adj" fmla="val 8571"/>
+              <a:gd name="adj" fmla="val 5882"/>
             </a:avLst>
           </a:prstGeom>
           <a:solidFill>
@@ -3320,14 +3444,14 @@
       </p:sp>
       <p:sp>
         <p:nvSpPr>
-          <p:cNvPr id="20" name="Text 18"/>
-          <p:cNvSpPr/>
-          <p:nvPr/>
-        </p:nvSpPr>
-        <p:spPr>
-          <a:xfrm>
-            <a:off x="530352" y="5074920"/>
-            <a:ext cx="3368040" cy="548640"/>
+          <p:cNvPr id="24" name="Text 22"/>
+          <p:cNvSpPr/>
+          <p:nvPr/>
+        </p:nvSpPr>
+        <p:spPr>
+          <a:xfrm>
+            <a:off x="2331720" y="3410712"/>
+            <a:ext cx="1545336" cy="841248"/>
           </a:xfrm>
           <a:prstGeom prst="rect">
             <a:avLst/>
@@ -3346,7 +3470,7 @@
               <a:buNone/>
             </a:pPr>
             <a:r>
-              <a:rPr lang="en-US" sz="1050" b="1" dirty="0">
+              <a:rPr lang="en-US" sz="945" b="1" dirty="0">
                 <a:solidFill>
                   <a:srgbClr val="1F2A37"/>
                 </a:solidFill>
@@ -3354,19 +3478,19 @@
                 <a:ea typeface="Arial" pitchFamily="34" charset="-122"/>
                 <a:cs typeface="Arial" pitchFamily="34" charset="-120"/>
               </a:rPr>
-              <a:t>Promo · Чолпон</a:t>
-            </a:r>
-            <a:endParaRPr lang="en-US" sz="1050" dirty="0"/>
-          </a:p>
-          <a:p>
-            <a:pPr algn="ctr" indent="0" marL="0">
-              <a:lnSpc>
-                <a:spcPct val="100000"/>
-              </a:lnSpc>
-              <a:buNone/>
-            </a:pPr>
-            <a:r>
-              <a:rPr lang="en-US" sz="800" i="1" dirty="0">
+              <a:t>Promo · Яков</a:t>
+            </a:r>
+            <a:endParaRPr lang="en-US" sz="945" dirty="0"/>
+          </a:p>
+          <a:p>
+            <a:pPr algn="ctr" indent="0" marL="0">
+              <a:lnSpc>
+                <a:spcPct val="100000"/>
+              </a:lnSpc>
+              <a:buNone/>
+            </a:pPr>
+            <a:r>
+              <a:rPr lang="en-US" sz="720" i="1" dirty="0">
                 <a:solidFill>
                   <a:srgbClr val="5B6B7C"/>
                 </a:solidFill>
@@ -3374,19 +3498,19 @@
                 <a:ea typeface="Arial" pitchFamily="34" charset="-122"/>
                 <a:cs typeface="Arial" pitchFamily="34" charset="-120"/>
               </a:rPr>
-              <a:t>Эркинова Чолпон</a:t>
-            </a:r>
-            <a:endParaRPr lang="en-US" sz="1050" dirty="0"/>
-          </a:p>
-          <a:p>
-            <a:pPr algn="ctr" indent="0" marL="0">
-              <a:lnSpc>
-                <a:spcPct val="100000"/>
-              </a:lnSpc>
-              <a:buNone/>
-            </a:pPr>
-            <a:r>
-              <a:rPr lang="en-US" sz="1100" b="1" dirty="0">
+              <a:t>Сорокин Яков Андреевич</a:t>
+            </a:r>
+            <a:endParaRPr lang="en-US" sz="945" dirty="0"/>
+          </a:p>
+          <a:p>
+            <a:pPr algn="ctr" indent="0" marL="0">
+              <a:lnSpc>
+                <a:spcPct val="100000"/>
+              </a:lnSpc>
+              <a:buNone/>
+            </a:pPr>
+            <a:r>
+              <a:rPr lang="en-US" sz="990" b="1" dirty="0">
                 <a:solidFill>
                   <a:srgbClr val="0F6E4F"/>
                 </a:solidFill>
@@ -3394,26 +3518,26 @@
                 <a:ea typeface="Arial" pitchFamily="34" charset="-122"/>
                 <a:cs typeface="Arial" pitchFamily="34" charset="-120"/>
               </a:rPr>
-              <a:t>1 025 642 ₸</a:t>
-            </a:r>
-            <a:endParaRPr lang="en-US" sz="1050" dirty="0"/>
-          </a:p>
-        </p:txBody>
-      </p:sp>
-      <p:sp>
-        <p:nvSpPr>
-          <p:cNvPr id="21" name="Shape 19"/>
-          <p:cNvSpPr/>
-          <p:nvPr/>
-        </p:nvSpPr>
-        <p:spPr>
-          <a:xfrm>
-            <a:off x="457200" y="5737860"/>
-            <a:ext cx="3514344" cy="640080"/>
+              <a:t>614 931 ₸</a:t>
+            </a:r>
+            <a:endParaRPr lang="en-US" sz="945" dirty="0"/>
+          </a:p>
+        </p:txBody>
+      </p:sp>
+      <p:sp>
+        <p:nvSpPr>
+          <p:cNvPr id="25" name="Shape 23"/>
+          <p:cNvSpPr/>
+          <p:nvPr/>
+        </p:nvSpPr>
+        <p:spPr>
+          <a:xfrm>
+            <a:off x="2258568" y="4389120"/>
+            <a:ext cx="1691640" cy="932688"/>
           </a:xfrm>
           <a:prstGeom prst="roundRect">
             <a:avLst>
-              <a:gd name="adj" fmla="val 8571"/>
+              <a:gd name="adj" fmla="val 5882"/>
             </a:avLst>
           </a:prstGeom>
           <a:solidFill>
@@ -3436,14 +3560,14 @@
       </p:sp>
       <p:sp>
         <p:nvSpPr>
-          <p:cNvPr id="22" name="Text 20"/>
-          <p:cNvSpPr/>
-          <p:nvPr/>
-        </p:nvSpPr>
-        <p:spPr>
-          <a:xfrm>
-            <a:off x="530352" y="5783580"/>
-            <a:ext cx="3368040" cy="548640"/>
+          <p:cNvPr id="26" name="Text 24"/>
+          <p:cNvSpPr/>
+          <p:nvPr/>
+        </p:nvSpPr>
+        <p:spPr>
+          <a:xfrm>
+            <a:off x="2331720" y="4434840"/>
+            <a:ext cx="1545336" cy="841248"/>
           </a:xfrm>
           <a:prstGeom prst="rect">
             <a:avLst/>
@@ -3462,7 +3586,7 @@
               <a:buNone/>
             </a:pPr>
             <a:r>
-              <a:rPr lang="en-US" sz="1050" b="1" dirty="0">
+              <a:rPr lang="en-US" sz="945" b="1" dirty="0">
                 <a:solidFill>
                   <a:srgbClr val="1F2A37"/>
                 </a:solidFill>
@@ -3472,17 +3596,17 @@
               </a:rPr>
               <a:t>Promo · Аяулым</a:t>
             </a:r>
-            <a:endParaRPr lang="en-US" sz="1050" dirty="0"/>
-          </a:p>
-          <a:p>
-            <a:pPr algn="ctr" indent="0" marL="0">
-              <a:lnSpc>
-                <a:spcPct val="100000"/>
-              </a:lnSpc>
-              <a:buNone/>
-            </a:pPr>
-            <a:r>
-              <a:rPr lang="en-US" sz="800" i="1" dirty="0">
+            <a:endParaRPr lang="en-US" sz="945" dirty="0"/>
+          </a:p>
+          <a:p>
+            <a:pPr algn="ctr" indent="0" marL="0">
+              <a:lnSpc>
+                <a:spcPct val="100000"/>
+              </a:lnSpc>
+              <a:buNone/>
+            </a:pPr>
+            <a:r>
+              <a:rPr lang="en-US" sz="720" i="1" dirty="0">
                 <a:solidFill>
                   <a:srgbClr val="5B6B7C"/>
                 </a:solidFill>
@@ -3492,17 +3616,17 @@
               </a:rPr>
               <a:t>Иманбаева Аяулым Маратовна</a:t>
             </a:r>
-            <a:endParaRPr lang="en-US" sz="1050" dirty="0"/>
-          </a:p>
-          <a:p>
-            <a:pPr algn="ctr" indent="0" marL="0">
-              <a:lnSpc>
-                <a:spcPct val="100000"/>
-              </a:lnSpc>
-              <a:buNone/>
-            </a:pPr>
-            <a:r>
-              <a:rPr lang="en-US" sz="1100" b="1" dirty="0">
+            <a:endParaRPr lang="en-US" sz="945" dirty="0"/>
+          </a:p>
+          <a:p>
+            <a:pPr algn="ctr" indent="0" marL="0">
+              <a:lnSpc>
+                <a:spcPct val="100000"/>
+              </a:lnSpc>
+              <a:buNone/>
+            </a:pPr>
+            <a:r>
+              <a:rPr lang="en-US" sz="990" b="1" dirty="0">
                 <a:solidFill>
                   <a:srgbClr val="0F6E4F"/>
                 </a:solidFill>
@@ -3512,20 +3636,253 @@
               </a:rPr>
               <a:t>1 000 162 ₸</a:t>
             </a:r>
-            <a:endParaRPr lang="en-US" sz="1050" dirty="0"/>
-          </a:p>
-        </p:txBody>
-      </p:sp>
-      <p:sp>
-        <p:nvSpPr>
-          <p:cNvPr id="23" name="Shape 21"/>
-          <p:cNvSpPr/>
-          <p:nvPr/>
-        </p:nvSpPr>
-        <p:spPr>
-          <a:xfrm>
-            <a:off x="6094476" y="1792224"/>
-            <a:ext cx="0" cy="54864"/>
+            <a:endParaRPr lang="en-US" sz="945" dirty="0"/>
+          </a:p>
+        </p:txBody>
+      </p:sp>
+      <p:sp>
+        <p:nvSpPr>
+          <p:cNvPr id="27" name="Shape 25"/>
+          <p:cNvSpPr/>
+          <p:nvPr/>
+        </p:nvSpPr>
+        <p:spPr>
+          <a:xfrm>
+            <a:off x="5728716" y="2340864"/>
+            <a:ext cx="2468880" cy="676656"/>
+          </a:xfrm>
+          <a:prstGeom prst="roundRect">
+            <a:avLst>
+              <a:gd name="adj" fmla="val 8108"/>
+            </a:avLst>
+          </a:prstGeom>
+          <a:solidFill>
+            <a:srgbClr val="2E5C8A"/>
+          </a:solidFill>
+          <a:ln w="12700">
+            <a:solidFill>
+              <a:srgbClr val="2E5C8A"/>
+            </a:solidFill>
+            <a:prstDash val="solid"/>
+          </a:ln>
+          <a:effectLst>
+            <a:outerShdw sx="100000" sy="100000" kx="0" ky="0" algn="bl" rotWithShape="0" blurRad="50800" dist="25400" dir="5400000">
+              <a:srgbClr val="9AA7B4">
+                <a:alpha val="28000"/>
+              </a:srgbClr>
+            </a:outerShdw>
+          </a:effectLst>
+        </p:spPr>
+      </p:sp>
+      <p:sp>
+        <p:nvSpPr>
+          <p:cNvPr id="28" name="Text 26"/>
+          <p:cNvSpPr/>
+          <p:nvPr/>
+        </p:nvSpPr>
+        <p:spPr>
+          <a:xfrm>
+            <a:off x="5801868" y="2386584"/>
+            <a:ext cx="2322576" cy="585216"/>
+          </a:xfrm>
+          <a:prstGeom prst="rect">
+            <a:avLst/>
+          </a:prstGeom>
+          <a:noFill/>
+          <a:ln/>
+        </p:spPr>
+        <p:txBody>
+          <a:bodyPr wrap="square" lIns="0" tIns="0" rIns="0" bIns="0" rtlCol="0" anchor="ctr"/>
+          <a:lstStyle/>
+          <a:p>
+            <a:pPr algn="ctr" indent="0" marL="0">
+              <a:lnSpc>
+                <a:spcPct val="100000"/>
+              </a:lnSpc>
+              <a:buNone/>
+            </a:pPr>
+            <a:r>
+              <a:rPr lang="en-US" sz="1140" b="1" dirty="0">
+                <a:solidFill>
+                  <a:srgbClr val="FFFFFF"/>
+                </a:solidFill>
+                <a:latin typeface="Arial" pitchFamily="34" charset="0"/>
+                <a:ea typeface="Arial" pitchFamily="34" charset="-122"/>
+                <a:cs typeface="Arial" pitchFamily="34" charset="-120"/>
+              </a:rPr>
+              <a:t>Head of SMM · Мария</a:t>
+            </a:r>
+            <a:endParaRPr lang="en-US" sz="1140" dirty="0"/>
+          </a:p>
+          <a:p>
+            <a:pPr algn="ctr" indent="0" marL="0">
+              <a:lnSpc>
+                <a:spcPct val="100000"/>
+              </a:lnSpc>
+              <a:buNone/>
+            </a:pPr>
+            <a:r>
+              <a:rPr lang="en-US" sz="760" i="1" dirty="0">
+                <a:solidFill>
+                  <a:srgbClr val="DCE6F5"/>
+                </a:solidFill>
+                <a:latin typeface="Arial" pitchFamily="34" charset="0"/>
+                <a:ea typeface="Arial" pitchFamily="34" charset="-122"/>
+                <a:cs typeface="Arial" pitchFamily="34" charset="-120"/>
+              </a:rPr>
+              <a:t>Коренькова Мария Николаевна</a:t>
+            </a:r>
+            <a:endParaRPr lang="en-US" sz="1140" dirty="0"/>
+          </a:p>
+          <a:p>
+            <a:pPr algn="ctr" indent="0" marL="0">
+              <a:lnSpc>
+                <a:spcPct val="100000"/>
+              </a:lnSpc>
+              <a:buNone/>
+            </a:pPr>
+            <a:r>
+              <a:rPr lang="en-US" sz="1140" b="1" dirty="0">
+                <a:solidFill>
+                  <a:srgbClr val="FFFFFF"/>
+                </a:solidFill>
+                <a:latin typeface="Arial" pitchFamily="34" charset="0"/>
+                <a:ea typeface="Arial" pitchFamily="34" charset="-122"/>
+                <a:cs typeface="Arial" pitchFamily="34" charset="-120"/>
+              </a:rPr>
+              <a:t>1 625 032 ₸</a:t>
+            </a:r>
+            <a:endParaRPr lang="en-US" sz="1140" dirty="0"/>
+          </a:p>
+        </p:txBody>
+      </p:sp>
+      <p:sp>
+        <p:nvSpPr>
+          <p:cNvPr id="29" name="Text 27"/>
+          <p:cNvSpPr/>
+          <p:nvPr/>
+        </p:nvSpPr>
+        <p:spPr>
+          <a:xfrm>
+            <a:off x="4315968" y="3090672"/>
+            <a:ext cx="1691640" cy="201168"/>
+          </a:xfrm>
+          <a:prstGeom prst="rect">
+            <a:avLst/>
+          </a:prstGeom>
+          <a:noFill/>
+          <a:ln/>
+        </p:spPr>
+        <p:txBody>
+          <a:bodyPr wrap="square" lIns="0" tIns="0" rIns="0" bIns="0" rtlCol="0" anchor="ctr"/>
+          <a:lstStyle/>
+          <a:p>
+            <a:pPr algn="ctr" indent="0" marL="0">
+              <a:buNone/>
+            </a:pPr>
+            <a:r>
+              <a:rPr lang="en-US" sz="900" b="1" dirty="0">
+                <a:solidFill>
+                  <a:srgbClr val="5B6B7C"/>
+                </a:solidFill>
+                <a:latin typeface="Arial" pitchFamily="34" charset="0"/>
+                <a:ea typeface="Arial" pitchFamily="34" charset="-122"/>
+                <a:cs typeface="Arial" pitchFamily="34" charset="-120"/>
+              </a:rPr>
+              <a:t>Originals</a:t>
+            </a:r>
+            <a:endParaRPr lang="en-US" sz="900" dirty="0"/>
+          </a:p>
+        </p:txBody>
+      </p:sp>
+      <p:sp>
+        <p:nvSpPr>
+          <p:cNvPr id="30" name="Text 28"/>
+          <p:cNvSpPr/>
+          <p:nvPr/>
+        </p:nvSpPr>
+        <p:spPr>
+          <a:xfrm>
+            <a:off x="6117336" y="3090672"/>
+            <a:ext cx="1691640" cy="201168"/>
+          </a:xfrm>
+          <a:prstGeom prst="rect">
+            <a:avLst/>
+          </a:prstGeom>
+          <a:noFill/>
+          <a:ln/>
+        </p:spPr>
+        <p:txBody>
+          <a:bodyPr wrap="square" lIns="0" tIns="0" rIns="0" bIns="0" rtlCol="0" anchor="ctr"/>
+          <a:lstStyle/>
+          <a:p>
+            <a:pPr algn="ctr" indent="0" marL="0">
+              <a:buNone/>
+            </a:pPr>
+            <a:r>
+              <a:rPr lang="en-US" sz="900" b="1" dirty="0">
+                <a:solidFill>
+                  <a:srgbClr val="5B6B7C"/>
+                </a:solidFill>
+                <a:latin typeface="Arial" pitchFamily="34" charset="0"/>
+                <a:ea typeface="Arial" pitchFamily="34" charset="-122"/>
+                <a:cs typeface="Arial" pitchFamily="34" charset="-120"/>
+              </a:rPr>
+              <a:t>Gen</a:t>
+            </a:r>
+            <a:endParaRPr lang="en-US" sz="900" dirty="0"/>
+          </a:p>
+        </p:txBody>
+      </p:sp>
+      <p:sp>
+        <p:nvSpPr>
+          <p:cNvPr id="31" name="Text 29"/>
+          <p:cNvSpPr/>
+          <p:nvPr/>
+        </p:nvSpPr>
+        <p:spPr>
+          <a:xfrm>
+            <a:off x="7918704" y="3090672"/>
+            <a:ext cx="1691640" cy="201168"/>
+          </a:xfrm>
+          <a:prstGeom prst="rect">
+            <a:avLst/>
+          </a:prstGeom>
+          <a:noFill/>
+          <a:ln/>
+        </p:spPr>
+        <p:txBody>
+          <a:bodyPr wrap="square" lIns="0" tIns="0" rIns="0" bIns="0" rtlCol="0" anchor="ctr"/>
+          <a:lstStyle/>
+          <a:p>
+            <a:pPr algn="ctr" indent="0" marL="0">
+              <a:buNone/>
+            </a:pPr>
+            <a:r>
+              <a:rPr lang="en-US" sz="900" b="1" dirty="0">
+                <a:solidFill>
+                  <a:srgbClr val="5B6B7C"/>
+                </a:solidFill>
+                <a:latin typeface="Arial" pitchFamily="34" charset="0"/>
+                <a:ea typeface="Arial" pitchFamily="34" charset="-122"/>
+                <a:cs typeface="Arial" pitchFamily="34" charset="-120"/>
+              </a:rPr>
+              <a:t>Sport</a:t>
+            </a:r>
+            <a:endParaRPr lang="en-US" sz="900" dirty="0"/>
+          </a:p>
+        </p:txBody>
+      </p:sp>
+      <p:sp>
+        <p:nvSpPr>
+          <p:cNvPr id="32" name="Shape 30"/>
+          <p:cNvSpPr/>
+          <p:nvPr/>
+        </p:nvSpPr>
+        <p:spPr>
+          <a:xfrm>
+            <a:off x="6963156" y="3017520"/>
+            <a:ext cx="0" cy="128016"/>
           </a:xfrm>
           <a:prstGeom prst="line">
             <a:avLst/>
@@ -3541,57 +3898,110 @@
       </p:sp>
       <p:sp>
         <p:nvSpPr>
-          <p:cNvPr id="24" name="Text 22"/>
-          <p:cNvSpPr/>
-          <p:nvPr/>
-        </p:nvSpPr>
-        <p:spPr>
-          <a:xfrm>
-            <a:off x="4337304" y="1847088"/>
-            <a:ext cx="3514344" cy="292608"/>
-          </a:xfrm>
-          <a:prstGeom prst="rect">
-            <a:avLst/>
-          </a:prstGeom>
-          <a:noFill/>
-          <a:ln/>
-        </p:spPr>
-        <p:txBody>
-          <a:bodyPr wrap="square" lIns="0" tIns="0" rIns="0" bIns="0" rtlCol="0" anchor="ctr"/>
-          <a:lstStyle/>
-          <a:p>
-            <a:pPr algn="ctr" indent="0" marL="0">
-              <a:buNone/>
-            </a:pPr>
-            <a:r>
-              <a:rPr lang="en-US" sz="1200" b="1" dirty="0">
-                <a:solidFill>
-                  <a:srgbClr val="2E5C8A"/>
-                </a:solidFill>
-                <a:latin typeface="Arial" pitchFamily="34" charset="0"/>
-                <a:ea typeface="Arial" pitchFamily="34" charset="-122"/>
-                <a:cs typeface="Arial" pitchFamily="34" charset="-120"/>
-              </a:rPr>
-              <a:t>SMM  (gen · original · sport)</a:t>
-            </a:r>
-            <a:endParaRPr lang="en-US" sz="1200" dirty="0"/>
-          </a:p>
-        </p:txBody>
-      </p:sp>
-      <p:sp>
-        <p:nvSpPr>
-          <p:cNvPr id="25" name="Shape 23"/>
-          <p:cNvSpPr/>
-          <p:nvPr/>
-        </p:nvSpPr>
-        <p:spPr>
-          <a:xfrm>
-            <a:off x="4337304" y="2194560"/>
-            <a:ext cx="3514344" cy="640080"/>
+          <p:cNvPr id="33" name="Shape 31"/>
+          <p:cNvSpPr/>
+          <p:nvPr/>
+        </p:nvSpPr>
+        <p:spPr>
+          <a:xfrm>
+            <a:off x="5161788" y="3145536"/>
+            <a:ext cx="3602736" cy="0"/>
+          </a:xfrm>
+          <a:prstGeom prst="line">
+            <a:avLst/>
+          </a:prstGeom>
+          <a:noFill/>
+          <a:ln w="12700">
+            <a:solidFill>
+              <a:srgbClr val="C7D8EE"/>
+            </a:solidFill>
+            <a:prstDash val="solid"/>
+          </a:ln>
+        </p:spPr>
+      </p:sp>
+      <p:sp>
+        <p:nvSpPr>
+          <p:cNvPr id="34" name="Shape 32"/>
+          <p:cNvSpPr/>
+          <p:nvPr/>
+        </p:nvSpPr>
+        <p:spPr>
+          <a:xfrm>
+            <a:off x="5161788" y="3145536"/>
+            <a:ext cx="0" cy="182880"/>
+          </a:xfrm>
+          <a:prstGeom prst="line">
+            <a:avLst/>
+          </a:prstGeom>
+          <a:noFill/>
+          <a:ln w="12700">
+            <a:solidFill>
+              <a:srgbClr val="C7D8EE"/>
+            </a:solidFill>
+            <a:prstDash val="solid"/>
+          </a:ln>
+        </p:spPr>
+      </p:sp>
+      <p:sp>
+        <p:nvSpPr>
+          <p:cNvPr id="35" name="Shape 33"/>
+          <p:cNvSpPr/>
+          <p:nvPr/>
+        </p:nvSpPr>
+        <p:spPr>
+          <a:xfrm>
+            <a:off x="6963156" y="3145536"/>
+            <a:ext cx="0" cy="182880"/>
+          </a:xfrm>
+          <a:prstGeom prst="line">
+            <a:avLst/>
+          </a:prstGeom>
+          <a:noFill/>
+          <a:ln w="12700">
+            <a:solidFill>
+              <a:srgbClr val="C7D8EE"/>
+            </a:solidFill>
+            <a:prstDash val="solid"/>
+          </a:ln>
+        </p:spPr>
+      </p:sp>
+      <p:sp>
+        <p:nvSpPr>
+          <p:cNvPr id="36" name="Shape 34"/>
+          <p:cNvSpPr/>
+          <p:nvPr/>
+        </p:nvSpPr>
+        <p:spPr>
+          <a:xfrm>
+            <a:off x="8764524" y="3145536"/>
+            <a:ext cx="0" cy="182880"/>
+          </a:xfrm>
+          <a:prstGeom prst="line">
+            <a:avLst/>
+          </a:prstGeom>
+          <a:noFill/>
+          <a:ln w="12700">
+            <a:solidFill>
+              <a:srgbClr val="C7D8EE"/>
+            </a:solidFill>
+            <a:prstDash val="solid"/>
+          </a:ln>
+        </p:spPr>
+      </p:sp>
+      <p:sp>
+        <p:nvSpPr>
+          <p:cNvPr id="37" name="Shape 35"/>
+          <p:cNvSpPr/>
+          <p:nvPr/>
+        </p:nvSpPr>
+        <p:spPr>
+          <a:xfrm>
+            <a:off x="4315968" y="3328416"/>
+            <a:ext cx="1691640" cy="859536"/>
           </a:xfrm>
           <a:prstGeom prst="roundRect">
             <a:avLst>
-              <a:gd name="adj" fmla="val 8571"/>
+              <a:gd name="adj" fmla="val 6383"/>
             </a:avLst>
           </a:prstGeom>
           <a:solidFill>
@@ -3614,14 +4024,14 @@
       </p:sp>
       <p:sp>
         <p:nvSpPr>
-          <p:cNvPr id="26" name="Text 24"/>
-          <p:cNvSpPr/>
-          <p:nvPr/>
-        </p:nvSpPr>
-        <p:spPr>
-          <a:xfrm>
-            <a:off x="4410456" y="2240280"/>
-            <a:ext cx="3368040" cy="548640"/>
+          <p:cNvPr id="38" name="Text 36"/>
+          <p:cNvSpPr/>
+          <p:nvPr/>
+        </p:nvSpPr>
+        <p:spPr>
+          <a:xfrm>
+            <a:off x="4389120" y="3374136"/>
+            <a:ext cx="1545336" cy="768096"/>
           </a:xfrm>
           <a:prstGeom prst="rect">
             <a:avLst/>
@@ -3640,7 +4050,7 @@
               <a:buNone/>
             </a:pPr>
             <a:r>
-              <a:rPr lang="en-US" sz="1050" b="1" dirty="0">
+              <a:rPr lang="en-US" sz="945" b="1" dirty="0">
                 <a:solidFill>
                   <a:srgbClr val="1F2A37"/>
                 </a:solidFill>
@@ -3648,19 +4058,19 @@
                 <a:ea typeface="Arial" pitchFamily="34" charset="-122"/>
                 <a:cs typeface="Arial" pitchFamily="34" charset="-120"/>
               </a:rPr>
-              <a:t>Head of SMM · Мария</a:t>
-            </a:r>
-            <a:endParaRPr lang="en-US" sz="1050" dirty="0"/>
-          </a:p>
-          <a:p>
-            <a:pPr algn="ctr" indent="0" marL="0">
-              <a:lnSpc>
-                <a:spcPct val="100000"/>
-              </a:lnSpc>
-              <a:buNone/>
-            </a:pPr>
-            <a:r>
-              <a:rPr lang="en-US" sz="800" i="1" dirty="0">
+              <a:t>SMM Original</a:t>
+            </a:r>
+            <a:endParaRPr lang="en-US" sz="945" dirty="0"/>
+          </a:p>
+          <a:p>
+            <a:pPr algn="ctr" indent="0" marL="0">
+              <a:lnSpc>
+                <a:spcPct val="100000"/>
+              </a:lnSpc>
+              <a:buNone/>
+            </a:pPr>
+            <a:r>
+              <a:rPr lang="en-US" sz="720" i="1" dirty="0">
                 <a:solidFill>
                   <a:srgbClr val="5B6B7C"/>
                 </a:solidFill>
@@ -3668,46 +4078,46 @@
                 <a:ea typeface="Arial" pitchFamily="34" charset="-122"/>
                 <a:cs typeface="Arial" pitchFamily="34" charset="-120"/>
               </a:rPr>
-              <a:t>Коренькова Мария Николаевна</a:t>
-            </a:r>
-            <a:endParaRPr lang="en-US" sz="1050" dirty="0"/>
-          </a:p>
-          <a:p>
-            <a:pPr algn="ctr" indent="0" marL="0">
-              <a:lnSpc>
-                <a:spcPct val="100000"/>
-              </a:lnSpc>
-              <a:buNone/>
-            </a:pPr>
-            <a:r>
-              <a:rPr lang="en-US" sz="1100" b="1" dirty="0">
-                <a:solidFill>
-                  <a:srgbClr val="0F6E4F"/>
-                </a:solidFill>
-                <a:latin typeface="Arial" pitchFamily="34" charset="0"/>
-                <a:ea typeface="Arial" pitchFamily="34" charset="-122"/>
-                <a:cs typeface="Arial" pitchFamily="34" charset="-120"/>
-              </a:rPr>
-              <a:t>1 625 032 ₸</a:t>
-            </a:r>
-            <a:endParaRPr lang="en-US" sz="1050" dirty="0"/>
-          </a:p>
-        </p:txBody>
-      </p:sp>
-      <p:sp>
-        <p:nvSpPr>
-          <p:cNvPr id="27" name="Shape 25"/>
-          <p:cNvSpPr/>
-          <p:nvPr/>
-        </p:nvSpPr>
-        <p:spPr>
-          <a:xfrm>
-            <a:off x="4337304" y="2903220"/>
-            <a:ext cx="3514344" cy="640080"/>
+              <a:t>SMM менеджер · имя н/д</a:t>
+            </a:r>
+            <a:endParaRPr lang="en-US" sz="945" dirty="0"/>
+          </a:p>
+          <a:p>
+            <a:pPr algn="ctr" indent="0" marL="0">
+              <a:lnSpc>
+                <a:spcPct val="100000"/>
+              </a:lnSpc>
+              <a:buNone/>
+            </a:pPr>
+            <a:r>
+              <a:rPr lang="en-US" sz="990" b="1" dirty="0">
+                <a:solidFill>
+                  <a:srgbClr val="B45309"/>
+                </a:solidFill>
+                <a:latin typeface="Arial" pitchFamily="34" charset="0"/>
+                <a:ea typeface="Arial" pitchFamily="34" charset="-122"/>
+                <a:cs typeface="Arial" pitchFamily="34" charset="-120"/>
+              </a:rPr>
+              <a:t>867 456 ₸  *</a:t>
+            </a:r>
+            <a:endParaRPr lang="en-US" sz="945" dirty="0"/>
+          </a:p>
+        </p:txBody>
+      </p:sp>
+      <p:sp>
+        <p:nvSpPr>
+          <p:cNvPr id="39" name="Shape 37"/>
+          <p:cNvSpPr/>
+          <p:nvPr/>
+        </p:nvSpPr>
+        <p:spPr>
+          <a:xfrm>
+            <a:off x="4315968" y="4279392"/>
+            <a:ext cx="1691640" cy="859536"/>
           </a:xfrm>
           <a:prstGeom prst="roundRect">
             <a:avLst>
-              <a:gd name="adj" fmla="val 8571"/>
+              <a:gd name="adj" fmla="val 6383"/>
             </a:avLst>
           </a:prstGeom>
           <a:solidFill>
@@ -3730,14 +4140,14 @@
       </p:sp>
       <p:sp>
         <p:nvSpPr>
-          <p:cNvPr id="28" name="Text 26"/>
-          <p:cNvSpPr/>
-          <p:nvPr/>
-        </p:nvSpPr>
-        <p:spPr>
-          <a:xfrm>
-            <a:off x="4410456" y="2948940"/>
-            <a:ext cx="3368040" cy="548640"/>
+          <p:cNvPr id="40" name="Text 38"/>
+          <p:cNvSpPr/>
+          <p:nvPr/>
+        </p:nvSpPr>
+        <p:spPr>
+          <a:xfrm>
+            <a:off x="4389120" y="4325112"/>
+            <a:ext cx="1545336" cy="768096"/>
           </a:xfrm>
           <a:prstGeom prst="rect">
             <a:avLst/>
@@ -3756,7 +4166,7 @@
               <a:buNone/>
             </a:pPr>
             <a:r>
-              <a:rPr lang="en-US" sz="1050" b="1" dirty="0">
+              <a:rPr lang="en-US" sz="945" b="1" dirty="0">
                 <a:solidFill>
                   <a:srgbClr val="1F2A37"/>
                 </a:solidFill>
@@ -3766,17 +4176,17 @@
               </a:rPr>
               <a:t>SMM Original</a:t>
             </a:r>
-            <a:endParaRPr lang="en-US" sz="1050" dirty="0"/>
-          </a:p>
-          <a:p>
-            <a:pPr algn="ctr" indent="0" marL="0">
-              <a:lnSpc>
-                <a:spcPct val="100000"/>
-              </a:lnSpc>
-              <a:buNone/>
-            </a:pPr>
-            <a:r>
-              <a:rPr lang="en-US" sz="800" i="1" dirty="0">
+            <a:endParaRPr lang="en-US" sz="945" dirty="0"/>
+          </a:p>
+          <a:p>
+            <a:pPr algn="ctr" indent="0" marL="0">
+              <a:lnSpc>
+                <a:spcPct val="100000"/>
+              </a:lnSpc>
+              <a:buNone/>
+            </a:pPr>
+            <a:r>
+              <a:rPr lang="en-US" sz="720" i="1" dirty="0">
                 <a:solidFill>
                   <a:srgbClr val="5B6B7C"/>
                 </a:solidFill>
@@ -3786,17 +4196,17 @@
               </a:rPr>
               <a:t>SMM менеджер · имя н/д</a:t>
             </a:r>
-            <a:endParaRPr lang="en-US" sz="1050" dirty="0"/>
-          </a:p>
-          <a:p>
-            <a:pPr algn="ctr" indent="0" marL="0">
-              <a:lnSpc>
-                <a:spcPct val="100000"/>
-              </a:lnSpc>
-              <a:buNone/>
-            </a:pPr>
-            <a:r>
-              <a:rPr lang="en-US" sz="1100" b="1" dirty="0">
+            <a:endParaRPr lang="en-US" sz="945" dirty="0"/>
+          </a:p>
+          <a:p>
+            <a:pPr algn="ctr" indent="0" marL="0">
+              <a:lnSpc>
+                <a:spcPct val="100000"/>
+              </a:lnSpc>
+              <a:buNone/>
+            </a:pPr>
+            <a:r>
+              <a:rPr lang="en-US" sz="990" b="1" dirty="0">
                 <a:solidFill>
                   <a:srgbClr val="B45309"/>
                 </a:solidFill>
@@ -3806,24 +4216,24 @@
               </a:rPr>
               <a:t>867 456 ₸  *</a:t>
             </a:r>
-            <a:endParaRPr lang="en-US" sz="1050" dirty="0"/>
-          </a:p>
-        </p:txBody>
-      </p:sp>
-      <p:sp>
-        <p:nvSpPr>
-          <p:cNvPr id="29" name="Shape 27"/>
-          <p:cNvSpPr/>
-          <p:nvPr/>
-        </p:nvSpPr>
-        <p:spPr>
-          <a:xfrm>
-            <a:off x="4337304" y="3611880"/>
-            <a:ext cx="3514344" cy="640080"/>
+            <a:endParaRPr lang="en-US" sz="945" dirty="0"/>
+          </a:p>
+        </p:txBody>
+      </p:sp>
+      <p:sp>
+        <p:nvSpPr>
+          <p:cNvPr id="41" name="Shape 39"/>
+          <p:cNvSpPr/>
+          <p:nvPr/>
+        </p:nvSpPr>
+        <p:spPr>
+          <a:xfrm>
+            <a:off x="6117336" y="3328416"/>
+            <a:ext cx="1691640" cy="859536"/>
           </a:xfrm>
           <a:prstGeom prst="roundRect">
             <a:avLst>
-              <a:gd name="adj" fmla="val 8571"/>
+              <a:gd name="adj" fmla="val 6383"/>
             </a:avLst>
           </a:prstGeom>
           <a:solidFill>
@@ -3846,14 +4256,14 @@
       </p:sp>
       <p:sp>
         <p:nvSpPr>
-          <p:cNvPr id="30" name="Text 28"/>
-          <p:cNvSpPr/>
-          <p:nvPr/>
-        </p:nvSpPr>
-        <p:spPr>
-          <a:xfrm>
-            <a:off x="4410456" y="3657600"/>
-            <a:ext cx="3368040" cy="548640"/>
+          <p:cNvPr id="42" name="Text 40"/>
+          <p:cNvSpPr/>
+          <p:nvPr/>
+        </p:nvSpPr>
+        <p:spPr>
+          <a:xfrm>
+            <a:off x="6190488" y="3374136"/>
+            <a:ext cx="1545336" cy="768096"/>
           </a:xfrm>
           <a:prstGeom prst="rect">
             <a:avLst/>
@@ -3872,7 +4282,7 @@
               <a:buNone/>
             </a:pPr>
             <a:r>
-              <a:rPr lang="en-US" sz="1050" b="1" dirty="0">
+              <a:rPr lang="en-US" sz="945" b="1" dirty="0">
                 <a:solidFill>
                   <a:srgbClr val="1F2A37"/>
                 </a:solidFill>
@@ -3882,17 +4292,17 @@
               </a:rPr>
               <a:t>SMM Gen</a:t>
             </a:r>
-            <a:endParaRPr lang="en-US" sz="1050" dirty="0"/>
-          </a:p>
-          <a:p>
-            <a:pPr algn="ctr" indent="0" marL="0">
-              <a:lnSpc>
-                <a:spcPct val="100000"/>
-              </a:lnSpc>
-              <a:buNone/>
-            </a:pPr>
-            <a:r>
-              <a:rPr lang="en-US" sz="800" i="1" dirty="0">
+            <a:endParaRPr lang="en-US" sz="945" dirty="0"/>
+          </a:p>
+          <a:p>
+            <a:pPr algn="ctr" indent="0" marL="0">
+              <a:lnSpc>
+                <a:spcPct val="100000"/>
+              </a:lnSpc>
+              <a:buNone/>
+            </a:pPr>
+            <a:r>
+              <a:rPr lang="en-US" sz="720" i="1" dirty="0">
                 <a:solidFill>
                   <a:srgbClr val="5B6B7C"/>
                 </a:solidFill>
@@ -3902,17 +4312,17 @@
               </a:rPr>
               <a:t>SMM менеджер · имя н/д</a:t>
             </a:r>
-            <a:endParaRPr lang="en-US" sz="1050" dirty="0"/>
-          </a:p>
-          <a:p>
-            <a:pPr algn="ctr" indent="0" marL="0">
-              <a:lnSpc>
-                <a:spcPct val="100000"/>
-              </a:lnSpc>
-              <a:buNone/>
-            </a:pPr>
-            <a:r>
-              <a:rPr lang="en-US" sz="1100" b="1" dirty="0">
+            <a:endParaRPr lang="en-US" sz="945" dirty="0"/>
+          </a:p>
+          <a:p>
+            <a:pPr algn="ctr" indent="0" marL="0">
+              <a:lnSpc>
+                <a:spcPct val="100000"/>
+              </a:lnSpc>
+              <a:buNone/>
+            </a:pPr>
+            <a:r>
+              <a:rPr lang="en-US" sz="990" b="1" dirty="0">
                 <a:solidFill>
                   <a:srgbClr val="B45309"/>
                 </a:solidFill>
@@ -3922,24 +4332,24 @@
               </a:rPr>
               <a:t>867 456 ₸  *</a:t>
             </a:r>
-            <a:endParaRPr lang="en-US" sz="1050" dirty="0"/>
-          </a:p>
-        </p:txBody>
-      </p:sp>
-      <p:sp>
-        <p:nvSpPr>
-          <p:cNvPr id="31" name="Shape 29"/>
-          <p:cNvSpPr/>
-          <p:nvPr/>
-        </p:nvSpPr>
-        <p:spPr>
-          <a:xfrm>
-            <a:off x="4337304" y="4320540"/>
-            <a:ext cx="3514344" cy="640080"/>
+            <a:endParaRPr lang="en-US" sz="945" dirty="0"/>
+          </a:p>
+        </p:txBody>
+      </p:sp>
+      <p:sp>
+        <p:nvSpPr>
+          <p:cNvPr id="43" name="Shape 41"/>
+          <p:cNvSpPr/>
+          <p:nvPr/>
+        </p:nvSpPr>
+        <p:spPr>
+          <a:xfrm>
+            <a:off x="7918704" y="3328416"/>
+            <a:ext cx="1691640" cy="859536"/>
           </a:xfrm>
           <a:prstGeom prst="roundRect">
             <a:avLst>
-              <a:gd name="adj" fmla="val 8571"/>
+              <a:gd name="adj" fmla="val 6383"/>
             </a:avLst>
           </a:prstGeom>
           <a:solidFill>
@@ -3962,14 +4372,14 @@
       </p:sp>
       <p:sp>
         <p:nvSpPr>
-          <p:cNvPr id="32" name="Text 30"/>
-          <p:cNvSpPr/>
-          <p:nvPr/>
-        </p:nvSpPr>
-        <p:spPr>
-          <a:xfrm>
-            <a:off x="4410456" y="4366260"/>
-            <a:ext cx="3368040" cy="548640"/>
+          <p:cNvPr id="44" name="Text 42"/>
+          <p:cNvSpPr/>
+          <p:nvPr/>
+        </p:nvSpPr>
+        <p:spPr>
+          <a:xfrm>
+            <a:off x="7991856" y="3374136"/>
+            <a:ext cx="1545336" cy="768096"/>
           </a:xfrm>
           <a:prstGeom prst="rect">
             <a:avLst/>
@@ -3988,7 +4398,7 @@
               <a:buNone/>
             </a:pPr>
             <a:r>
-              <a:rPr lang="en-US" sz="1050" b="1" dirty="0">
+              <a:rPr lang="en-US" sz="945" b="1" dirty="0">
                 <a:solidFill>
                   <a:srgbClr val="1F2A37"/>
                 </a:solidFill>
@@ -3998,17 +4408,17 @@
               </a:rPr>
               <a:t>SMM Sport</a:t>
             </a:r>
-            <a:endParaRPr lang="en-US" sz="1050" dirty="0"/>
-          </a:p>
-          <a:p>
-            <a:pPr algn="ctr" indent="0" marL="0">
-              <a:lnSpc>
-                <a:spcPct val="100000"/>
-              </a:lnSpc>
-              <a:buNone/>
-            </a:pPr>
-            <a:r>
-              <a:rPr lang="en-US" sz="800" i="1" dirty="0">
+            <a:endParaRPr lang="en-US" sz="945" dirty="0"/>
+          </a:p>
+          <a:p>
+            <a:pPr algn="ctr" indent="0" marL="0">
+              <a:lnSpc>
+                <a:spcPct val="100000"/>
+              </a:lnSpc>
+              <a:buNone/>
+            </a:pPr>
+            <a:r>
+              <a:rPr lang="en-US" sz="720" i="1" dirty="0">
                 <a:solidFill>
                   <a:srgbClr val="5B6B7C"/>
                 </a:solidFill>
@@ -4018,17 +4428,17 @@
               </a:rPr>
               <a:t>SMM менеджер · имя н/д</a:t>
             </a:r>
-            <a:endParaRPr lang="en-US" sz="1050" dirty="0"/>
-          </a:p>
-          <a:p>
-            <a:pPr algn="ctr" indent="0" marL="0">
-              <a:lnSpc>
-                <a:spcPct val="100000"/>
-              </a:lnSpc>
-              <a:buNone/>
-            </a:pPr>
-            <a:r>
-              <a:rPr lang="en-US" sz="1100" b="1" dirty="0">
+            <a:endParaRPr lang="en-US" sz="945" dirty="0"/>
+          </a:p>
+          <a:p>
+            <a:pPr algn="ctr" indent="0" marL="0">
+              <a:lnSpc>
+                <a:spcPct val="100000"/>
+              </a:lnSpc>
+              <a:buNone/>
+            </a:pPr>
+            <a:r>
+              <a:rPr lang="en-US" sz="990" b="1" dirty="0">
                 <a:solidFill>
                   <a:srgbClr val="B45309"/>
                 </a:solidFill>
@@ -4038,24 +4448,24 @@
               </a:rPr>
               <a:t>867 456 ₸  *</a:t>
             </a:r>
-            <a:endParaRPr lang="en-US" sz="1050" dirty="0"/>
-          </a:p>
-        </p:txBody>
-      </p:sp>
-      <p:sp>
-        <p:nvSpPr>
-          <p:cNvPr id="33" name="Shape 31"/>
-          <p:cNvSpPr/>
-          <p:nvPr/>
-        </p:nvSpPr>
-        <p:spPr>
-          <a:xfrm>
-            <a:off x="4337304" y="5029200"/>
-            <a:ext cx="3514344" cy="640080"/>
+            <a:endParaRPr lang="en-US" sz="945" dirty="0"/>
+          </a:p>
+        </p:txBody>
+      </p:sp>
+      <p:sp>
+        <p:nvSpPr>
+          <p:cNvPr id="45" name="Shape 43"/>
+          <p:cNvSpPr/>
+          <p:nvPr/>
+        </p:nvSpPr>
+        <p:spPr>
+          <a:xfrm>
+            <a:off x="7918704" y="4279392"/>
+            <a:ext cx="1691640" cy="859536"/>
           </a:xfrm>
           <a:prstGeom prst="roundRect">
             <a:avLst>
-              <a:gd name="adj" fmla="val 8571"/>
+              <a:gd name="adj" fmla="val 6383"/>
             </a:avLst>
           </a:prstGeom>
           <a:solidFill>
@@ -4078,14 +4488,14 @@
       </p:sp>
       <p:sp>
         <p:nvSpPr>
-          <p:cNvPr id="34" name="Text 32"/>
-          <p:cNvSpPr/>
-          <p:nvPr/>
-        </p:nvSpPr>
-        <p:spPr>
-          <a:xfrm>
-            <a:off x="4410456" y="5074920"/>
-            <a:ext cx="3368040" cy="548640"/>
+          <p:cNvPr id="46" name="Text 44"/>
+          <p:cNvSpPr/>
+          <p:nvPr/>
+        </p:nvSpPr>
+        <p:spPr>
+          <a:xfrm>
+            <a:off x="7991856" y="4325112"/>
+            <a:ext cx="1545336" cy="768096"/>
           </a:xfrm>
           <a:prstGeom prst="rect">
             <a:avLst/>
@@ -4104,7 +4514,7 @@
               <a:buNone/>
             </a:pPr>
             <a:r>
-              <a:rPr lang="en-US" sz="1050" b="1" dirty="0">
+              <a:rPr lang="en-US" sz="945" b="1" dirty="0">
                 <a:solidFill>
                   <a:srgbClr val="1F2A37"/>
                 </a:solidFill>
@@ -4112,19 +4522,19 @@
                 <a:ea typeface="Arial" pitchFamily="34" charset="-122"/>
                 <a:cs typeface="Arial" pitchFamily="34" charset="-120"/>
               </a:rPr>
-              <a:t>SMM Original</a:t>
-            </a:r>
-            <a:endParaRPr lang="en-US" sz="1050" dirty="0"/>
-          </a:p>
-          <a:p>
-            <a:pPr algn="ctr" indent="0" marL="0">
-              <a:lnSpc>
-                <a:spcPct val="100000"/>
-              </a:lnSpc>
-              <a:buNone/>
-            </a:pPr>
-            <a:r>
-              <a:rPr lang="en-US" sz="800" i="1" dirty="0">
+              <a:t>Telegram редактор Sport</a:t>
+            </a:r>
+            <a:endParaRPr lang="en-US" sz="945" dirty="0"/>
+          </a:p>
+          <a:p>
+            <a:pPr algn="ctr" indent="0" marL="0">
+              <a:lnSpc>
+                <a:spcPct val="100000"/>
+              </a:lnSpc>
+              <a:buNone/>
+            </a:pPr>
+            <a:r>
+              <a:rPr lang="en-US" sz="720" i="1" dirty="0">
                 <a:solidFill>
                   <a:srgbClr val="5B6B7C"/>
                 </a:solidFill>
@@ -4132,46 +4542,46 @@
                 <a:ea typeface="Arial" pitchFamily="34" charset="-122"/>
                 <a:cs typeface="Arial" pitchFamily="34" charset="-120"/>
               </a:rPr>
-              <a:t>SMM менеджер · имя н/д</a:t>
-            </a:r>
-            <a:endParaRPr lang="en-US" sz="1050" dirty="0"/>
-          </a:p>
-          <a:p>
-            <a:pPr algn="ctr" indent="0" marL="0">
-              <a:lnSpc>
-                <a:spcPct val="100000"/>
-              </a:lnSpc>
-              <a:buNone/>
-            </a:pPr>
-            <a:r>
-              <a:rPr lang="en-US" sz="1100" b="1" dirty="0">
-                <a:solidFill>
-                  <a:srgbClr val="B45309"/>
-                </a:solidFill>
-                <a:latin typeface="Arial" pitchFamily="34" charset="0"/>
-                <a:ea typeface="Arial" pitchFamily="34" charset="-122"/>
-                <a:cs typeface="Arial" pitchFamily="34" charset="-120"/>
-              </a:rPr>
-              <a:t>867 456 ₸  *</a:t>
-            </a:r>
-            <a:endParaRPr lang="en-US" sz="1050" dirty="0"/>
-          </a:p>
-        </p:txBody>
-      </p:sp>
-      <p:sp>
-        <p:nvSpPr>
-          <p:cNvPr id="35" name="Shape 33"/>
-          <p:cNvSpPr/>
-          <p:nvPr/>
-        </p:nvSpPr>
-        <p:spPr>
-          <a:xfrm>
-            <a:off x="4337304" y="5737860"/>
-            <a:ext cx="3514344" cy="640080"/>
+              <a:t>Куричев Иван Николаевич</a:t>
+            </a:r>
+            <a:endParaRPr lang="en-US" sz="945" dirty="0"/>
+          </a:p>
+          <a:p>
+            <a:pPr algn="ctr" indent="0" marL="0">
+              <a:lnSpc>
+                <a:spcPct val="100000"/>
+              </a:lnSpc>
+              <a:buNone/>
+            </a:pPr>
+            <a:r>
+              <a:rPr lang="en-US" sz="990" b="1" dirty="0">
+                <a:solidFill>
+                  <a:srgbClr val="0F6E4F"/>
+                </a:solidFill>
+                <a:latin typeface="Arial" pitchFamily="34" charset="0"/>
+                <a:ea typeface="Arial" pitchFamily="34" charset="-122"/>
+                <a:cs typeface="Arial" pitchFamily="34" charset="-120"/>
+              </a:rPr>
+              <a:t>513 920 ₸</a:t>
+            </a:r>
+            <a:endParaRPr lang="en-US" sz="945" dirty="0"/>
+          </a:p>
+        </p:txBody>
+      </p:sp>
+      <p:sp>
+        <p:nvSpPr>
+          <p:cNvPr id="47" name="Shape 45"/>
+          <p:cNvSpPr/>
+          <p:nvPr/>
+        </p:nvSpPr>
+        <p:spPr>
+          <a:xfrm>
+            <a:off x="9976104" y="2340864"/>
+            <a:ext cx="1691640" cy="932688"/>
           </a:xfrm>
           <a:prstGeom prst="roundRect">
             <a:avLst>
-              <a:gd name="adj" fmla="val 8571"/>
+              <a:gd name="adj" fmla="val 5882"/>
             </a:avLst>
           </a:prstGeom>
           <a:solidFill>
@@ -4194,14 +4604,14 @@
       </p:sp>
       <p:sp>
         <p:nvSpPr>
-          <p:cNvPr id="36" name="Text 34"/>
-          <p:cNvSpPr/>
-          <p:nvPr/>
-        </p:nvSpPr>
-        <p:spPr>
-          <a:xfrm>
-            <a:off x="4410456" y="5783580"/>
-            <a:ext cx="3368040" cy="548640"/>
+          <p:cNvPr id="48" name="Text 46"/>
+          <p:cNvSpPr/>
+          <p:nvPr/>
+        </p:nvSpPr>
+        <p:spPr>
+          <a:xfrm>
+            <a:off x="10049256" y="2386584"/>
+            <a:ext cx="1545336" cy="841248"/>
           </a:xfrm>
           <a:prstGeom prst="rect">
             <a:avLst/>
@@ -4220,7 +4630,7 @@
               <a:buNone/>
             </a:pPr>
             <a:r>
-              <a:rPr lang="en-US" sz="1050" b="1" dirty="0">
+              <a:rPr lang="en-US" sz="945" b="1" dirty="0">
                 <a:solidFill>
                   <a:srgbClr val="1F2A37"/>
                 </a:solidFill>
@@ -4228,19 +4638,19 @@
                 <a:ea typeface="Arial" pitchFamily="34" charset="-122"/>
                 <a:cs typeface="Arial" pitchFamily="34" charset="-120"/>
               </a:rPr>
-              <a:t>Telegram редактор Sport</a:t>
-            </a:r>
-            <a:endParaRPr lang="en-US" sz="1050" dirty="0"/>
-          </a:p>
-          <a:p>
-            <a:pPr algn="ctr" indent="0" marL="0">
-              <a:lnSpc>
-                <a:spcPct val="100000"/>
-              </a:lnSpc>
-              <a:buNone/>
-            </a:pPr>
-            <a:r>
-              <a:rPr lang="en-US" sz="800" i="1" dirty="0">
+              <a:t>Pr manager · Аружан</a:t>
+            </a:r>
+            <a:endParaRPr lang="en-US" sz="945" dirty="0"/>
+          </a:p>
+          <a:p>
+            <a:pPr algn="ctr" indent="0" marL="0">
+              <a:lnSpc>
+                <a:spcPct val="100000"/>
+              </a:lnSpc>
+              <a:buNone/>
+            </a:pPr>
+            <a:r>
+              <a:rPr lang="en-US" sz="720" i="1" dirty="0">
                 <a:solidFill>
                   <a:srgbClr val="5B6B7C"/>
                 </a:solidFill>
@@ -4248,19 +4658,19 @@
                 <a:ea typeface="Arial" pitchFamily="34" charset="-122"/>
                 <a:cs typeface="Arial" pitchFamily="34" charset="-120"/>
               </a:rPr>
-              <a:t>Куричев Иван Николаевич</a:t>
-            </a:r>
-            <a:endParaRPr lang="en-US" sz="1050" dirty="0"/>
-          </a:p>
-          <a:p>
-            <a:pPr algn="ctr" indent="0" marL="0">
-              <a:lnSpc>
-                <a:spcPct val="100000"/>
-              </a:lnSpc>
-              <a:buNone/>
-            </a:pPr>
-            <a:r>
-              <a:rPr lang="en-US" sz="1100" b="1" dirty="0">
+              <a:t>PR менеджер</a:t>
+            </a:r>
+            <a:endParaRPr lang="en-US" sz="945" dirty="0"/>
+          </a:p>
+          <a:p>
+            <a:pPr algn="ctr" indent="0" marL="0">
+              <a:lnSpc>
+                <a:spcPct val="100000"/>
+              </a:lnSpc>
+              <a:buNone/>
+            </a:pPr>
+            <a:r>
+              <a:rPr lang="en-US" sz="990" b="1" dirty="0">
                 <a:solidFill>
                   <a:srgbClr val="0F6E4F"/>
                 </a:solidFill>
@@ -4268,187 +4678,9 @@
                 <a:ea typeface="Arial" pitchFamily="34" charset="-122"/>
                 <a:cs typeface="Arial" pitchFamily="34" charset="-120"/>
               </a:rPr>
-              <a:t>513 920 ₸</a:t>
-            </a:r>
-            <a:endParaRPr lang="en-US" sz="1050" dirty="0"/>
-          </a:p>
-        </p:txBody>
-      </p:sp>
-      <p:sp>
-        <p:nvSpPr>
-          <p:cNvPr id="37" name="Shape 35"/>
-          <p:cNvSpPr/>
-          <p:nvPr/>
-        </p:nvSpPr>
-        <p:spPr>
-          <a:xfrm>
-            <a:off x="9974580" y="1792224"/>
-            <a:ext cx="0" cy="54864"/>
-          </a:xfrm>
-          <a:prstGeom prst="line">
-            <a:avLst/>
-          </a:prstGeom>
-          <a:noFill/>
-          <a:ln w="12700">
-            <a:solidFill>
-              <a:srgbClr val="C7D8EE"/>
-            </a:solidFill>
-            <a:prstDash val="solid"/>
-          </a:ln>
-        </p:spPr>
-      </p:sp>
-      <p:sp>
-        <p:nvSpPr>
-          <p:cNvPr id="38" name="Text 36"/>
-          <p:cNvSpPr/>
-          <p:nvPr/>
-        </p:nvSpPr>
-        <p:spPr>
-          <a:xfrm>
-            <a:off x="8217408" y="1847088"/>
-            <a:ext cx="3514344" cy="292608"/>
-          </a:xfrm>
-          <a:prstGeom prst="rect">
-            <a:avLst/>
-          </a:prstGeom>
-          <a:noFill/>
-          <a:ln/>
-        </p:spPr>
-        <p:txBody>
-          <a:bodyPr wrap="square" lIns="0" tIns="0" rIns="0" bIns="0" rtlCol="0" anchor="ctr"/>
-          <a:lstStyle/>
-          <a:p>
-            <a:pPr algn="ctr" indent="0" marL="0">
-              <a:buNone/>
-            </a:pPr>
-            <a:r>
-              <a:rPr lang="en-US" sz="1200" b="1" dirty="0">
-                <a:solidFill>
-                  <a:srgbClr val="2E5C8A"/>
-                </a:solidFill>
-                <a:latin typeface="Arial" pitchFamily="34" charset="0"/>
-                <a:ea typeface="Arial" pitchFamily="34" charset="-122"/>
-                <a:cs typeface="Arial" pitchFamily="34" charset="-120"/>
-              </a:rPr>
-              <a:t>PR</a:t>
-            </a:r>
-            <a:endParaRPr lang="en-US" sz="1200" dirty="0"/>
-          </a:p>
-        </p:txBody>
-      </p:sp>
-      <p:sp>
-        <p:nvSpPr>
-          <p:cNvPr id="39" name="Shape 37"/>
-          <p:cNvSpPr/>
-          <p:nvPr/>
-        </p:nvSpPr>
-        <p:spPr>
-          <a:xfrm>
-            <a:off x="8217408" y="2194560"/>
-            <a:ext cx="3514344" cy="640080"/>
-          </a:xfrm>
-          <a:prstGeom prst="roundRect">
-            <a:avLst>
-              <a:gd name="adj" fmla="val 8571"/>
-            </a:avLst>
-          </a:prstGeom>
-          <a:solidFill>
-            <a:srgbClr val="EAF1FB"/>
-          </a:solidFill>
-          <a:ln w="12700">
-            <a:solidFill>
-              <a:srgbClr val="C7D8EE"/>
-            </a:solidFill>
-            <a:prstDash val="solid"/>
-          </a:ln>
-          <a:effectLst>
-            <a:outerShdw sx="100000" sy="100000" kx="0" ky="0" algn="bl" rotWithShape="0" blurRad="50800" dist="25400" dir="5400000">
-              <a:srgbClr val="9AA7B4">
-                <a:alpha val="28000"/>
-              </a:srgbClr>
-            </a:outerShdw>
-          </a:effectLst>
-        </p:spPr>
-      </p:sp>
-      <p:sp>
-        <p:nvSpPr>
-          <p:cNvPr id="40" name="Text 38"/>
-          <p:cNvSpPr/>
-          <p:nvPr/>
-        </p:nvSpPr>
-        <p:spPr>
-          <a:xfrm>
-            <a:off x="8290560" y="2240280"/>
-            <a:ext cx="3368040" cy="548640"/>
-          </a:xfrm>
-          <a:prstGeom prst="rect">
-            <a:avLst/>
-          </a:prstGeom>
-          <a:noFill/>
-          <a:ln/>
-        </p:spPr>
-        <p:txBody>
-          <a:bodyPr wrap="square" lIns="0" tIns="0" rIns="0" bIns="0" rtlCol="0" anchor="ctr"/>
-          <a:lstStyle/>
-          <a:p>
-            <a:pPr algn="ctr" indent="0" marL="0">
-              <a:lnSpc>
-                <a:spcPct val="100000"/>
-              </a:lnSpc>
-              <a:buNone/>
-            </a:pPr>
-            <a:r>
-              <a:rPr lang="en-US" sz="1050" b="1" dirty="0">
-                <a:solidFill>
-                  <a:srgbClr val="1F2A37"/>
-                </a:solidFill>
-                <a:latin typeface="Arial" pitchFamily="34" charset="0"/>
-                <a:ea typeface="Arial" pitchFamily="34" charset="-122"/>
-                <a:cs typeface="Arial" pitchFamily="34" charset="-120"/>
-              </a:rPr>
-              <a:t>Pr manager · Аружан</a:t>
-            </a:r>
-            <a:endParaRPr lang="en-US" sz="1050" dirty="0"/>
-          </a:p>
-          <a:p>
-            <a:pPr algn="ctr" indent="0" marL="0">
-              <a:lnSpc>
-                <a:spcPct val="100000"/>
-              </a:lnSpc>
-              <a:buNone/>
-            </a:pPr>
-            <a:r>
-              <a:rPr lang="en-US" sz="800" i="1" dirty="0">
-                <a:solidFill>
-                  <a:srgbClr val="5B6B7C"/>
-                </a:solidFill>
-                <a:latin typeface="Arial" pitchFamily="34" charset="0"/>
-                <a:ea typeface="Arial" pitchFamily="34" charset="-122"/>
-                <a:cs typeface="Arial" pitchFamily="34" charset="-120"/>
-              </a:rPr>
-              <a:t>PR менеджер</a:t>
-            </a:r>
-            <a:endParaRPr lang="en-US" sz="1050" dirty="0"/>
-          </a:p>
-          <a:p>
-            <a:pPr algn="ctr" indent="0" marL="0">
-              <a:lnSpc>
-                <a:spcPct val="100000"/>
-              </a:lnSpc>
-              <a:buNone/>
-            </a:pPr>
-            <a:r>
-              <a:rPr lang="en-US" sz="1100" b="1" dirty="0">
-                <a:solidFill>
-                  <a:srgbClr val="0F6E4F"/>
-                </a:solidFill>
-                <a:latin typeface="Arial" pitchFamily="34" charset="0"/>
-                <a:ea typeface="Arial" pitchFamily="34" charset="-122"/>
-                <a:cs typeface="Arial" pitchFamily="34" charset="-120"/>
-              </a:rPr>
               <a:t>1 212 314 ₸</a:t>
             </a:r>
-            <a:endParaRPr lang="en-US" sz="1050" dirty="0"/>
+            <a:endParaRPr lang="en-US" sz="945" dirty="0"/>
           </a:p>
         </p:txBody>
       </p:sp>
@@ -5593,7 +5825,7 @@
                 <a:ea typeface="Arial" pitchFamily="34" charset="-122"/>
                 <a:cs typeface="Arial" pitchFamily="34" charset="-120"/>
               </a:rPr>
-              <a:t>15 846 637 ₸</a:t>
+              <a:t>12 930 047 ₸</a:t>
             </a:r>
             <a:endParaRPr lang="en-US" sz="1900" dirty="0"/>
           </a:p>
@@ -5627,12 +5859,12 @@
         </p:nvSpPr>
         <p:spPr>
           <a:xfrm>
-            <a:off x="3899916" y="1060704"/>
-            <a:ext cx="4389120" cy="768096"/>
+            <a:off x="3991356" y="1060704"/>
+            <a:ext cx="4206240" cy="658368"/>
           </a:xfrm>
           <a:prstGeom prst="roundRect">
             <a:avLst>
-              <a:gd name="adj" fmla="val 7143"/>
+              <a:gd name="adj" fmla="val 8333"/>
             </a:avLst>
           </a:prstGeom>
           <a:solidFill>
@@ -5661,8 +5893,8 @@
         </p:nvSpPr>
         <p:spPr>
           <a:xfrm>
-            <a:off x="3973068" y="1106424"/>
-            <a:ext cx="4242816" cy="676656"/>
+            <a:off x="4064508" y="1106424"/>
+            <a:ext cx="4059936" cy="566928"/>
           </a:xfrm>
           <a:prstGeom prst="rect">
             <a:avLst/>
@@ -5743,8 +5975,8 @@
         </p:nvSpPr>
         <p:spPr>
           <a:xfrm>
-            <a:off x="6094476" y="1828800"/>
-            <a:ext cx="0" cy="54864"/>
+            <a:off x="6094476" y="1719072"/>
+            <a:ext cx="0" cy="91440"/>
           </a:xfrm>
           <a:prstGeom prst="line">
             <a:avLst/>
@@ -5766,8 +5998,8 @@
         </p:nvSpPr>
         <p:spPr>
           <a:xfrm>
-            <a:off x="3063240" y="1883664"/>
-            <a:ext cx="6062472" cy="0"/>
+            <a:off x="3017520" y="1810512"/>
+            <a:ext cx="6126480" cy="0"/>
           </a:xfrm>
           <a:prstGeom prst="line">
             <a:avLst/>
@@ -5789,8 +6021,8 @@
         </p:nvSpPr>
         <p:spPr>
           <a:xfrm>
-            <a:off x="3063240" y="1883664"/>
-            <a:ext cx="0" cy="219456"/>
+            <a:off x="3017520" y="1810512"/>
+            <a:ext cx="0" cy="201168"/>
           </a:xfrm>
           <a:prstGeom prst="line">
             <a:avLst/>
@@ -5812,8 +6044,8 @@
         </p:nvSpPr>
         <p:spPr>
           <a:xfrm>
-            <a:off x="9125712" y="1883664"/>
-            <a:ext cx="0" cy="219456"/>
+            <a:off x="9144000" y="1810512"/>
+            <a:ext cx="0" cy="201168"/>
           </a:xfrm>
           <a:prstGeom prst="line">
             <a:avLst/>
@@ -5835,12 +6067,12 @@
         </p:nvSpPr>
         <p:spPr>
           <a:xfrm>
-            <a:off x="822960" y="2103120"/>
-            <a:ext cx="4480560" cy="731520"/>
+            <a:off x="1005840" y="2011680"/>
+            <a:ext cx="4023360" cy="658368"/>
           </a:xfrm>
           <a:prstGeom prst="roundRect">
             <a:avLst>
-              <a:gd name="adj" fmla="val 7500"/>
+              <a:gd name="adj" fmla="val 8333"/>
             </a:avLst>
           </a:prstGeom>
           <a:solidFill>
@@ -5869,8 +6101,8 @@
         </p:nvSpPr>
         <p:spPr>
           <a:xfrm>
-            <a:off x="896112" y="2148840"/>
-            <a:ext cx="4334256" cy="640080"/>
+            <a:off x="1078992" y="2057400"/>
+            <a:ext cx="3877056" cy="566928"/>
           </a:xfrm>
           <a:prstGeom prst="rect">
             <a:avLst/>
@@ -5951,12 +6183,12 @@
         </p:nvSpPr>
         <p:spPr>
           <a:xfrm>
-            <a:off x="6885432" y="2103120"/>
-            <a:ext cx="4480560" cy="731520"/>
+            <a:off x="7498080" y="2011680"/>
+            <a:ext cx="3291840" cy="658368"/>
           </a:xfrm>
           <a:prstGeom prst="roundRect">
             <a:avLst>
-              <a:gd name="adj" fmla="val 7500"/>
+              <a:gd name="adj" fmla="val 8333"/>
             </a:avLst>
           </a:prstGeom>
           <a:solidFill>
@@ -5985,8 +6217,8 @@
         </p:nvSpPr>
         <p:spPr>
           <a:xfrm>
-            <a:off x="6958584" y="2148840"/>
-            <a:ext cx="4334256" cy="640080"/>
+            <a:off x="7571232" y="2057400"/>
+            <a:ext cx="3145536" cy="566928"/>
           </a:xfrm>
           <a:prstGeom prst="rect">
             <a:avLst/>
@@ -6061,14 +6293,92 @@
       </p:sp>
       <p:sp>
         <p:nvSpPr>
-          <p:cNvPr id="15" name="Shape 13"/>
-          <p:cNvSpPr/>
-          <p:nvPr/>
-        </p:nvSpPr>
-        <p:spPr>
-          <a:xfrm>
-            <a:off x="3063240" y="2834640"/>
-            <a:ext cx="0" cy="182880"/>
+          <p:cNvPr id="15" name="Text 13"/>
+          <p:cNvSpPr/>
+          <p:nvPr/>
+        </p:nvSpPr>
+        <p:spPr>
+          <a:xfrm>
+            <a:off x="1005840" y="2743200"/>
+            <a:ext cx="4023360" cy="256032"/>
+          </a:xfrm>
+          <a:prstGeom prst="rect">
+            <a:avLst/>
+          </a:prstGeom>
+          <a:noFill/>
+          <a:ln/>
+        </p:spPr>
+        <p:txBody>
+          <a:bodyPr wrap="square" lIns="0" tIns="0" rIns="0" bIns="0" rtlCol="0" anchor="ctr"/>
+          <a:lstStyle/>
+          <a:p>
+            <a:pPr algn="ctr" indent="0" marL="0">
+              <a:buNone/>
+            </a:pPr>
+            <a:r>
+              <a:rPr lang="en-US" sz="1200" b="1" dirty="0">
+                <a:solidFill>
+                  <a:srgbClr val="2E5C8A"/>
+                </a:solidFill>
+                <a:latin typeface="Arial" pitchFamily="34" charset="0"/>
+                <a:ea typeface="Arial" pitchFamily="34" charset="-122"/>
+                <a:cs typeface="Arial" pitchFamily="34" charset="-120"/>
+              </a:rPr>
+              <a:t>Design</a:t>
+            </a:r>
+            <a:endParaRPr lang="en-US" sz="1200" dirty="0"/>
+          </a:p>
+        </p:txBody>
+      </p:sp>
+      <p:sp>
+        <p:nvSpPr>
+          <p:cNvPr id="16" name="Text 14"/>
+          <p:cNvSpPr/>
+          <p:nvPr/>
+        </p:nvSpPr>
+        <p:spPr>
+          <a:xfrm>
+            <a:off x="7498080" y="2743200"/>
+            <a:ext cx="3291840" cy="256032"/>
+          </a:xfrm>
+          <a:prstGeom prst="rect">
+            <a:avLst/>
+          </a:prstGeom>
+          <a:noFill/>
+          <a:ln/>
+        </p:spPr>
+        <p:txBody>
+          <a:bodyPr wrap="square" lIns="0" tIns="0" rIns="0" bIns="0" rtlCol="0" anchor="ctr"/>
+          <a:lstStyle/>
+          <a:p>
+            <a:pPr algn="ctr" indent="0" marL="0">
+              <a:buNone/>
+            </a:pPr>
+            <a:r>
+              <a:rPr lang="en-US" sz="1200" b="1" dirty="0">
+                <a:solidFill>
+                  <a:srgbClr val="2E5C8A"/>
+                </a:solidFill>
+                <a:latin typeface="Arial" pitchFamily="34" charset="0"/>
+                <a:ea typeface="Arial" pitchFamily="34" charset="-122"/>
+                <a:cs typeface="Arial" pitchFamily="34" charset="-120"/>
+              </a:rPr>
+              <a:t>Video production</a:t>
+            </a:r>
+            <a:endParaRPr lang="en-US" sz="1200" dirty="0"/>
+          </a:p>
+        </p:txBody>
+      </p:sp>
+      <p:sp>
+        <p:nvSpPr>
+          <p:cNvPr id="17" name="Shape 15"/>
+          <p:cNvSpPr/>
+          <p:nvPr/>
+        </p:nvSpPr>
+        <p:spPr>
+          <a:xfrm>
+            <a:off x="3017520" y="2670048"/>
+            <a:ext cx="0" cy="292608"/>
           </a:xfrm>
           <a:prstGeom prst="line">
             <a:avLst/>
@@ -6084,18 +6394,87 @@
       </p:sp>
       <p:sp>
         <p:nvSpPr>
-          <p:cNvPr id="16" name="Shape 14"/>
-          <p:cNvSpPr/>
-          <p:nvPr/>
-        </p:nvSpPr>
-        <p:spPr>
-          <a:xfrm>
-            <a:off x="822960" y="3017520"/>
-            <a:ext cx="4480560" cy="621792"/>
+          <p:cNvPr id="18" name="Shape 16"/>
+          <p:cNvSpPr/>
+          <p:nvPr/>
+        </p:nvSpPr>
+        <p:spPr>
+          <a:xfrm>
+            <a:off x="1965960" y="2962656"/>
+            <a:ext cx="2103120" cy="0"/>
+          </a:xfrm>
+          <a:prstGeom prst="line">
+            <a:avLst/>
+          </a:prstGeom>
+          <a:noFill/>
+          <a:ln w="12700">
+            <a:solidFill>
+              <a:srgbClr val="C7D8EE"/>
+            </a:solidFill>
+            <a:prstDash val="solid"/>
+          </a:ln>
+        </p:spPr>
+      </p:sp>
+      <p:sp>
+        <p:nvSpPr>
+          <p:cNvPr id="19" name="Shape 17"/>
+          <p:cNvSpPr/>
+          <p:nvPr/>
+        </p:nvSpPr>
+        <p:spPr>
+          <a:xfrm>
+            <a:off x="1965960" y="2962656"/>
+            <a:ext cx="0" cy="146304"/>
+          </a:xfrm>
+          <a:prstGeom prst="line">
+            <a:avLst/>
+          </a:prstGeom>
+          <a:noFill/>
+          <a:ln w="12700">
+            <a:solidFill>
+              <a:srgbClr val="C7D8EE"/>
+            </a:solidFill>
+            <a:prstDash val="solid"/>
+          </a:ln>
+        </p:spPr>
+      </p:sp>
+      <p:sp>
+        <p:nvSpPr>
+          <p:cNvPr id="20" name="Shape 18"/>
+          <p:cNvSpPr/>
+          <p:nvPr/>
+        </p:nvSpPr>
+        <p:spPr>
+          <a:xfrm>
+            <a:off x="4069080" y="2962656"/>
+            <a:ext cx="0" cy="146304"/>
+          </a:xfrm>
+          <a:prstGeom prst="line">
+            <a:avLst/>
+          </a:prstGeom>
+          <a:noFill/>
+          <a:ln w="12700">
+            <a:solidFill>
+              <a:srgbClr val="C7D8EE"/>
+            </a:solidFill>
+            <a:prstDash val="solid"/>
+          </a:ln>
+        </p:spPr>
+      </p:sp>
+      <p:sp>
+        <p:nvSpPr>
+          <p:cNvPr id="21" name="Shape 19"/>
+          <p:cNvSpPr/>
+          <p:nvPr/>
+        </p:nvSpPr>
+        <p:spPr>
+          <a:xfrm>
+            <a:off x="1005840" y="3108960"/>
+            <a:ext cx="1920240" cy="658368"/>
           </a:xfrm>
           <a:prstGeom prst="roundRect">
             <a:avLst>
-              <a:gd name="adj" fmla="val 8824"/>
+              <a:gd name="adj" fmla="val 8333"/>
             </a:avLst>
           </a:prstGeom>
           <a:solidFill>
@@ -6118,14 +6497,14 @@
       </p:sp>
       <p:sp>
         <p:nvSpPr>
-          <p:cNvPr id="17" name="Text 15"/>
-          <p:cNvSpPr/>
-          <p:nvPr/>
-        </p:nvSpPr>
-        <p:spPr>
-          <a:xfrm>
-            <a:off x="896112" y="3063240"/>
-            <a:ext cx="4334256" cy="530352"/>
+          <p:cNvPr id="22" name="Text 20"/>
+          <p:cNvSpPr/>
+          <p:nvPr/>
+        </p:nvSpPr>
+        <p:spPr>
+          <a:xfrm>
+            <a:off x="1078992" y="3154680"/>
+            <a:ext cx="1773936" cy="566928"/>
           </a:xfrm>
           <a:prstGeom prst="rect">
             <a:avLst/>
@@ -6144,7 +6523,7 @@
               <a:buNone/>
             </a:pPr>
             <a:r>
-              <a:rPr lang="en-US" sz="1050" b="1" dirty="0">
+              <a:rPr lang="en-US" sz="998" b="1" dirty="0">
                 <a:solidFill>
                   <a:srgbClr val="1F2A37"/>
                 </a:solidFill>
@@ -6154,17 +6533,17 @@
               </a:rPr>
               <a:t>Graph</a:t>
             </a:r>
-            <a:endParaRPr lang="en-US" sz="1050" dirty="0"/>
-          </a:p>
-          <a:p>
-            <a:pPr algn="ctr" indent="0" marL="0">
-              <a:lnSpc>
-                <a:spcPct val="100000"/>
-              </a:lnSpc>
-              <a:buNone/>
-            </a:pPr>
-            <a:r>
-              <a:rPr lang="en-US" sz="800" i="1" dirty="0">
+            <a:endParaRPr lang="en-US" sz="998" dirty="0"/>
+          </a:p>
+          <a:p>
+            <a:pPr algn="ctr" indent="0" marL="0">
+              <a:lnSpc>
+                <a:spcPct val="100000"/>
+              </a:lnSpc>
+              <a:buNone/>
+            </a:pPr>
+            <a:r>
+              <a:rPr lang="en-US" sz="760" i="1" dirty="0">
                 <a:solidFill>
                   <a:srgbClr val="5B6B7C"/>
                 </a:solidFill>
@@ -6174,17 +6553,17 @@
               </a:rPr>
               <a:t>Дизайнер · имя н/д</a:t>
             </a:r>
-            <a:endParaRPr lang="en-US" sz="1050" dirty="0"/>
-          </a:p>
-          <a:p>
-            <a:pPr algn="ctr" indent="0" marL="0">
-              <a:lnSpc>
-                <a:spcPct val="100000"/>
-              </a:lnSpc>
-              <a:buNone/>
-            </a:pPr>
-            <a:r>
-              <a:rPr lang="en-US" sz="1100" b="1" dirty="0">
+            <a:endParaRPr lang="en-US" sz="998" dirty="0"/>
+          </a:p>
+          <a:p>
+            <a:pPr algn="ctr" indent="0" marL="0">
+              <a:lnSpc>
+                <a:spcPct val="100000"/>
+              </a:lnSpc>
+              <a:buNone/>
+            </a:pPr>
+            <a:r>
+              <a:rPr lang="en-US" sz="1045" b="1" dirty="0">
                 <a:solidFill>
                   <a:srgbClr val="B45309"/>
                 </a:solidFill>
@@ -6194,24 +6573,24 @@
               </a:rPr>
               <a:t>940 000 ₸  *</a:t>
             </a:r>
-            <a:endParaRPr lang="en-US" sz="1050" dirty="0"/>
-          </a:p>
-        </p:txBody>
-      </p:sp>
-      <p:sp>
-        <p:nvSpPr>
-          <p:cNvPr id="18" name="Shape 16"/>
-          <p:cNvSpPr/>
-          <p:nvPr/>
-        </p:nvSpPr>
-        <p:spPr>
-          <a:xfrm>
-            <a:off x="822960" y="3707892"/>
-            <a:ext cx="4480560" cy="621792"/>
+            <a:endParaRPr lang="en-US" sz="998" dirty="0"/>
+          </a:p>
+        </p:txBody>
+      </p:sp>
+      <p:sp>
+        <p:nvSpPr>
+          <p:cNvPr id="23" name="Shape 21"/>
+          <p:cNvSpPr/>
+          <p:nvPr/>
+        </p:nvSpPr>
+        <p:spPr>
+          <a:xfrm>
+            <a:off x="1005840" y="3895344"/>
+            <a:ext cx="1920240" cy="658368"/>
           </a:xfrm>
           <a:prstGeom prst="roundRect">
             <a:avLst>
-              <a:gd name="adj" fmla="val 8824"/>
+              <a:gd name="adj" fmla="val 8333"/>
             </a:avLst>
           </a:prstGeom>
           <a:solidFill>
@@ -6234,14 +6613,14 @@
       </p:sp>
       <p:sp>
         <p:nvSpPr>
-          <p:cNvPr id="19" name="Text 17"/>
-          <p:cNvSpPr/>
-          <p:nvPr/>
-        </p:nvSpPr>
-        <p:spPr>
-          <a:xfrm>
-            <a:off x="896112" y="3753612"/>
-            <a:ext cx="4334256" cy="530352"/>
+          <p:cNvPr id="24" name="Text 22"/>
+          <p:cNvSpPr/>
+          <p:nvPr/>
+        </p:nvSpPr>
+        <p:spPr>
+          <a:xfrm>
+            <a:off x="1078992" y="3941064"/>
+            <a:ext cx="1773936" cy="566928"/>
           </a:xfrm>
           <a:prstGeom prst="rect">
             <a:avLst/>
@@ -6260,7 +6639,7 @@
               <a:buNone/>
             </a:pPr>
             <a:r>
-              <a:rPr lang="en-US" sz="1050" b="1" dirty="0">
+              <a:rPr lang="en-US" sz="998" b="1" dirty="0">
                 <a:solidFill>
                   <a:srgbClr val="1F2A37"/>
                 </a:solidFill>
@@ -6270,17 +6649,17 @@
               </a:rPr>
               <a:t>Graph</a:t>
             </a:r>
-            <a:endParaRPr lang="en-US" sz="1050" dirty="0"/>
-          </a:p>
-          <a:p>
-            <a:pPr algn="ctr" indent="0" marL="0">
-              <a:lnSpc>
-                <a:spcPct val="100000"/>
-              </a:lnSpc>
-              <a:buNone/>
-            </a:pPr>
-            <a:r>
-              <a:rPr lang="en-US" sz="800" i="1" dirty="0">
+            <a:endParaRPr lang="en-US" sz="998" dirty="0"/>
+          </a:p>
+          <a:p>
+            <a:pPr algn="ctr" indent="0" marL="0">
+              <a:lnSpc>
+                <a:spcPct val="100000"/>
+              </a:lnSpc>
+              <a:buNone/>
+            </a:pPr>
+            <a:r>
+              <a:rPr lang="en-US" sz="760" i="1" dirty="0">
                 <a:solidFill>
                   <a:srgbClr val="5B6B7C"/>
                 </a:solidFill>
@@ -6290,17 +6669,17 @@
               </a:rPr>
               <a:t>Дизайнер · имя н/д</a:t>
             </a:r>
-            <a:endParaRPr lang="en-US" sz="1050" dirty="0"/>
-          </a:p>
-          <a:p>
-            <a:pPr algn="ctr" indent="0" marL="0">
-              <a:lnSpc>
-                <a:spcPct val="100000"/>
-              </a:lnSpc>
-              <a:buNone/>
-            </a:pPr>
-            <a:r>
-              <a:rPr lang="en-US" sz="1100" b="1" dirty="0">
+            <a:endParaRPr lang="en-US" sz="998" dirty="0"/>
+          </a:p>
+          <a:p>
+            <a:pPr algn="ctr" indent="0" marL="0">
+              <a:lnSpc>
+                <a:spcPct val="100000"/>
+              </a:lnSpc>
+              <a:buNone/>
+            </a:pPr>
+            <a:r>
+              <a:rPr lang="en-US" sz="1045" b="1" dirty="0">
                 <a:solidFill>
                   <a:srgbClr val="B45309"/>
                 </a:solidFill>
@@ -6310,24 +6689,24 @@
               </a:rPr>
               <a:t>940 000 ₸  *</a:t>
             </a:r>
-            <a:endParaRPr lang="en-US" sz="1050" dirty="0"/>
-          </a:p>
-        </p:txBody>
-      </p:sp>
-      <p:sp>
-        <p:nvSpPr>
-          <p:cNvPr id="20" name="Shape 18"/>
-          <p:cNvSpPr/>
-          <p:nvPr/>
-        </p:nvSpPr>
-        <p:spPr>
-          <a:xfrm>
-            <a:off x="822960" y="4398264"/>
-            <a:ext cx="4480560" cy="621792"/>
+            <a:endParaRPr lang="en-US" sz="998" dirty="0"/>
+          </a:p>
+        </p:txBody>
+      </p:sp>
+      <p:sp>
+        <p:nvSpPr>
+          <p:cNvPr id="25" name="Shape 23"/>
+          <p:cNvSpPr/>
+          <p:nvPr/>
+        </p:nvSpPr>
+        <p:spPr>
+          <a:xfrm>
+            <a:off x="1005840" y="4681728"/>
+            <a:ext cx="1920240" cy="658368"/>
           </a:xfrm>
           <a:prstGeom prst="roundRect">
             <a:avLst>
-              <a:gd name="adj" fmla="val 8824"/>
+              <a:gd name="adj" fmla="val 8333"/>
             </a:avLst>
           </a:prstGeom>
           <a:solidFill>
@@ -6350,14 +6729,14 @@
       </p:sp>
       <p:sp>
         <p:nvSpPr>
-          <p:cNvPr id="21" name="Text 19"/>
-          <p:cNvSpPr/>
-          <p:nvPr/>
-        </p:nvSpPr>
-        <p:spPr>
-          <a:xfrm>
-            <a:off x="896112" y="4443984"/>
-            <a:ext cx="4334256" cy="530352"/>
+          <p:cNvPr id="26" name="Text 24"/>
+          <p:cNvSpPr/>
+          <p:nvPr/>
+        </p:nvSpPr>
+        <p:spPr>
+          <a:xfrm>
+            <a:off x="1078992" y="4727448"/>
+            <a:ext cx="1773936" cy="566928"/>
           </a:xfrm>
           <a:prstGeom prst="rect">
             <a:avLst/>
@@ -6376,7 +6755,7 @@
               <a:buNone/>
             </a:pPr>
             <a:r>
-              <a:rPr lang="en-US" sz="1050" b="1" dirty="0">
+              <a:rPr lang="en-US" sz="998" b="1" dirty="0">
                 <a:solidFill>
                   <a:srgbClr val="1F2A37"/>
                 </a:solidFill>
@@ -6386,17 +6765,17 @@
               </a:rPr>
               <a:t>Graph Спорт</a:t>
             </a:r>
-            <a:endParaRPr lang="en-US" sz="1050" dirty="0"/>
-          </a:p>
-          <a:p>
-            <a:pPr algn="ctr" indent="0" marL="0">
-              <a:lnSpc>
-                <a:spcPct val="100000"/>
-              </a:lnSpc>
-              <a:buNone/>
-            </a:pPr>
-            <a:r>
-              <a:rPr lang="en-US" sz="800" i="1" dirty="0">
+            <a:endParaRPr lang="en-US" sz="998" dirty="0"/>
+          </a:p>
+          <a:p>
+            <a:pPr algn="ctr" indent="0" marL="0">
+              <a:lnSpc>
+                <a:spcPct val="100000"/>
+              </a:lnSpc>
+              <a:buNone/>
+            </a:pPr>
+            <a:r>
+              <a:rPr lang="en-US" sz="760" i="1" dirty="0">
                 <a:solidFill>
                   <a:srgbClr val="5B6B7C"/>
                 </a:solidFill>
@@ -6406,17 +6785,17 @@
               </a:rPr>
               <a:t>Дизайнер · имя н/д</a:t>
             </a:r>
-            <a:endParaRPr lang="en-US" sz="1050" dirty="0"/>
-          </a:p>
-          <a:p>
-            <a:pPr algn="ctr" indent="0" marL="0">
-              <a:lnSpc>
-                <a:spcPct val="100000"/>
-              </a:lnSpc>
-              <a:buNone/>
-            </a:pPr>
-            <a:r>
-              <a:rPr lang="en-US" sz="1100" b="1" dirty="0">
+            <a:endParaRPr lang="en-US" sz="998" dirty="0"/>
+          </a:p>
+          <a:p>
+            <a:pPr algn="ctr" indent="0" marL="0">
+              <a:lnSpc>
+                <a:spcPct val="100000"/>
+              </a:lnSpc>
+              <a:buNone/>
+            </a:pPr>
+            <a:r>
+              <a:rPr lang="en-US" sz="1045" b="1" dirty="0">
                 <a:solidFill>
                   <a:srgbClr val="B45309"/>
                 </a:solidFill>
@@ -6426,24 +6805,24 @@
               </a:rPr>
               <a:t>940 000 ₸  *</a:t>
             </a:r>
-            <a:endParaRPr lang="en-US" sz="1050" dirty="0"/>
-          </a:p>
-        </p:txBody>
-      </p:sp>
-      <p:sp>
-        <p:nvSpPr>
-          <p:cNvPr id="22" name="Shape 20"/>
-          <p:cNvSpPr/>
-          <p:nvPr/>
-        </p:nvSpPr>
-        <p:spPr>
-          <a:xfrm>
-            <a:off x="822960" y="5088636"/>
-            <a:ext cx="4480560" cy="621792"/>
+            <a:endParaRPr lang="en-US" sz="998" dirty="0"/>
+          </a:p>
+        </p:txBody>
+      </p:sp>
+      <p:sp>
+        <p:nvSpPr>
+          <p:cNvPr id="27" name="Shape 25"/>
+          <p:cNvSpPr/>
+          <p:nvPr/>
+        </p:nvSpPr>
+        <p:spPr>
+          <a:xfrm>
+            <a:off x="3108960" y="3108960"/>
+            <a:ext cx="1920240" cy="658368"/>
           </a:xfrm>
           <a:prstGeom prst="roundRect">
             <a:avLst>
-              <a:gd name="adj" fmla="val 8824"/>
+              <a:gd name="adj" fmla="val 8333"/>
             </a:avLst>
           </a:prstGeom>
           <a:solidFill>
@@ -6466,14 +6845,14 @@
       </p:sp>
       <p:sp>
         <p:nvSpPr>
-          <p:cNvPr id="23" name="Text 21"/>
-          <p:cNvSpPr/>
-          <p:nvPr/>
-        </p:nvSpPr>
-        <p:spPr>
-          <a:xfrm>
-            <a:off x="896112" y="5134356"/>
-            <a:ext cx="4334256" cy="530352"/>
+          <p:cNvPr id="28" name="Text 26"/>
+          <p:cNvSpPr/>
+          <p:nvPr/>
+        </p:nvSpPr>
+        <p:spPr>
+          <a:xfrm>
+            <a:off x="3182112" y="3154680"/>
+            <a:ext cx="1773936" cy="566928"/>
           </a:xfrm>
           <a:prstGeom prst="rect">
             <a:avLst/>
@@ -6492,7 +6871,7 @@
               <a:buNone/>
             </a:pPr>
             <a:r>
-              <a:rPr lang="en-US" sz="1050" b="1" dirty="0">
+              <a:rPr lang="en-US" sz="998" b="1" dirty="0">
                 <a:solidFill>
                   <a:srgbClr val="1F2A37"/>
                 </a:solidFill>
@@ -6502,17 +6881,17 @@
               </a:rPr>
               <a:t>Motion</a:t>
             </a:r>
-            <a:endParaRPr lang="en-US" sz="1050" dirty="0"/>
-          </a:p>
-          <a:p>
-            <a:pPr algn="ctr" indent="0" marL="0">
-              <a:lnSpc>
-                <a:spcPct val="100000"/>
-              </a:lnSpc>
-              <a:buNone/>
-            </a:pPr>
-            <a:r>
-              <a:rPr lang="en-US" sz="800" i="1" dirty="0">
+            <a:endParaRPr lang="en-US" sz="998" dirty="0"/>
+          </a:p>
+          <a:p>
+            <a:pPr algn="ctr" indent="0" marL="0">
+              <a:lnSpc>
+                <a:spcPct val="100000"/>
+              </a:lnSpc>
+              <a:buNone/>
+            </a:pPr>
+            <a:r>
+              <a:rPr lang="en-US" sz="760" i="1" dirty="0">
                 <a:solidFill>
                   <a:srgbClr val="5B6B7C"/>
                 </a:solidFill>
@@ -6522,17 +6901,17 @@
               </a:rPr>
               <a:t>Motion-дизайнер · имя н/д</a:t>
             </a:r>
-            <a:endParaRPr lang="en-US" sz="1050" dirty="0"/>
-          </a:p>
-          <a:p>
-            <a:pPr algn="ctr" indent="0" marL="0">
-              <a:lnSpc>
-                <a:spcPct val="100000"/>
-              </a:lnSpc>
-              <a:buNone/>
-            </a:pPr>
-            <a:r>
-              <a:rPr lang="en-US" sz="1100" b="1" dirty="0">
+            <a:endParaRPr lang="en-US" sz="998" dirty="0"/>
+          </a:p>
+          <a:p>
+            <a:pPr algn="ctr" indent="0" marL="0">
+              <a:lnSpc>
+                <a:spcPct val="100000"/>
+              </a:lnSpc>
+              <a:buNone/>
+            </a:pPr>
+            <a:r>
+              <a:rPr lang="en-US" sz="1045" b="1" dirty="0">
                 <a:solidFill>
                   <a:srgbClr val="B45309"/>
                 </a:solidFill>
@@ -6542,24 +6921,24 @@
               </a:rPr>
               <a:t>877 000 ₸  *</a:t>
             </a:r>
-            <a:endParaRPr lang="en-US" sz="1050" dirty="0"/>
-          </a:p>
-        </p:txBody>
-      </p:sp>
-      <p:sp>
-        <p:nvSpPr>
-          <p:cNvPr id="24" name="Shape 22"/>
-          <p:cNvSpPr/>
-          <p:nvPr/>
-        </p:nvSpPr>
-        <p:spPr>
-          <a:xfrm>
-            <a:off x="822960" y="5779008"/>
-            <a:ext cx="4480560" cy="621792"/>
+            <a:endParaRPr lang="en-US" sz="998" dirty="0"/>
+          </a:p>
+        </p:txBody>
+      </p:sp>
+      <p:sp>
+        <p:nvSpPr>
+          <p:cNvPr id="29" name="Shape 27"/>
+          <p:cNvSpPr/>
+          <p:nvPr/>
+        </p:nvSpPr>
+        <p:spPr>
+          <a:xfrm>
+            <a:off x="3108960" y="3895344"/>
+            <a:ext cx="1920240" cy="658368"/>
           </a:xfrm>
           <a:prstGeom prst="roundRect">
             <a:avLst>
-              <a:gd name="adj" fmla="val 8824"/>
+              <a:gd name="adj" fmla="val 8333"/>
             </a:avLst>
           </a:prstGeom>
           <a:solidFill>
@@ -6582,14 +6961,14 @@
       </p:sp>
       <p:sp>
         <p:nvSpPr>
-          <p:cNvPr id="25" name="Text 23"/>
-          <p:cNvSpPr/>
-          <p:nvPr/>
-        </p:nvSpPr>
-        <p:spPr>
-          <a:xfrm>
-            <a:off x="896112" y="5824728"/>
-            <a:ext cx="4334256" cy="530352"/>
+          <p:cNvPr id="30" name="Text 28"/>
+          <p:cNvSpPr/>
+          <p:nvPr/>
+        </p:nvSpPr>
+        <p:spPr>
+          <a:xfrm>
+            <a:off x="3182112" y="3941064"/>
+            <a:ext cx="1773936" cy="566928"/>
           </a:xfrm>
           <a:prstGeom prst="rect">
             <a:avLst/>
@@ -6608,7 +6987,7 @@
               <a:buNone/>
             </a:pPr>
             <a:r>
-              <a:rPr lang="en-US" sz="1050" b="1" dirty="0">
+              <a:rPr lang="en-US" sz="998" b="1" dirty="0">
                 <a:solidFill>
                   <a:srgbClr val="1F2A37"/>
                 </a:solidFill>
@@ -6618,17 +6997,17 @@
               </a:rPr>
               <a:t>Motion</a:t>
             </a:r>
-            <a:endParaRPr lang="en-US" sz="1050" dirty="0"/>
-          </a:p>
-          <a:p>
-            <a:pPr algn="ctr" indent="0" marL="0">
-              <a:lnSpc>
-                <a:spcPct val="100000"/>
-              </a:lnSpc>
-              <a:buNone/>
-            </a:pPr>
-            <a:r>
-              <a:rPr lang="en-US" sz="800" i="1" dirty="0">
+            <a:endParaRPr lang="en-US" sz="998" dirty="0"/>
+          </a:p>
+          <a:p>
+            <a:pPr algn="ctr" indent="0" marL="0">
+              <a:lnSpc>
+                <a:spcPct val="100000"/>
+              </a:lnSpc>
+              <a:buNone/>
+            </a:pPr>
+            <a:r>
+              <a:rPr lang="en-US" sz="760" i="1" dirty="0">
                 <a:solidFill>
                   <a:srgbClr val="5B6B7C"/>
                 </a:solidFill>
@@ -6638,17 +7017,17 @@
               </a:rPr>
               <a:t>Motion-дизайнер · имя н/д</a:t>
             </a:r>
-            <a:endParaRPr lang="en-US" sz="1050" dirty="0"/>
-          </a:p>
-          <a:p>
-            <a:pPr algn="ctr" indent="0" marL="0">
-              <a:lnSpc>
-                <a:spcPct val="100000"/>
-              </a:lnSpc>
-              <a:buNone/>
-            </a:pPr>
-            <a:r>
-              <a:rPr lang="en-US" sz="1100" b="1" dirty="0">
+            <a:endParaRPr lang="en-US" sz="998" dirty="0"/>
+          </a:p>
+          <a:p>
+            <a:pPr algn="ctr" indent="0" marL="0">
+              <a:lnSpc>
+                <a:spcPct val="100000"/>
+              </a:lnSpc>
+              <a:buNone/>
+            </a:pPr>
+            <a:r>
+              <a:rPr lang="en-US" sz="1045" b="1" dirty="0">
                 <a:solidFill>
                   <a:srgbClr val="B45309"/>
                 </a:solidFill>
@@ -6658,20 +7037,20 @@
               </a:rPr>
               <a:t>877 000 ₸  *</a:t>
             </a:r>
-            <a:endParaRPr lang="en-US" sz="1050" dirty="0"/>
-          </a:p>
-        </p:txBody>
-      </p:sp>
-      <p:sp>
-        <p:nvSpPr>
-          <p:cNvPr id="26" name="Shape 24"/>
-          <p:cNvSpPr/>
-          <p:nvPr/>
-        </p:nvSpPr>
-        <p:spPr>
-          <a:xfrm>
-            <a:off x="9125712" y="2834640"/>
-            <a:ext cx="0" cy="182880"/>
+            <a:endParaRPr lang="en-US" sz="998" dirty="0"/>
+          </a:p>
+        </p:txBody>
+      </p:sp>
+      <p:sp>
+        <p:nvSpPr>
+          <p:cNvPr id="31" name="Shape 29"/>
+          <p:cNvSpPr/>
+          <p:nvPr/>
+        </p:nvSpPr>
+        <p:spPr>
+          <a:xfrm>
+            <a:off x="9144000" y="2670048"/>
+            <a:ext cx="0" cy="384048"/>
           </a:xfrm>
           <a:prstGeom prst="line">
             <a:avLst/>
@@ -6687,18 +7066,18 @@
       </p:sp>
       <p:sp>
         <p:nvSpPr>
-          <p:cNvPr id="27" name="Shape 25"/>
-          <p:cNvSpPr/>
-          <p:nvPr/>
-        </p:nvSpPr>
-        <p:spPr>
-          <a:xfrm>
-            <a:off x="6885432" y="3017520"/>
-            <a:ext cx="4480560" cy="621792"/>
+          <p:cNvPr id="32" name="Shape 30"/>
+          <p:cNvSpPr/>
+          <p:nvPr/>
+        </p:nvSpPr>
+        <p:spPr>
+          <a:xfrm>
+            <a:off x="7498080" y="3108960"/>
+            <a:ext cx="3291840" cy="658368"/>
           </a:xfrm>
           <a:prstGeom prst="roundRect">
             <a:avLst>
-              <a:gd name="adj" fmla="val 8824"/>
+              <a:gd name="adj" fmla="val 8333"/>
             </a:avLst>
           </a:prstGeom>
           <a:solidFill>
@@ -6721,14 +7100,14 @@
       </p:sp>
       <p:sp>
         <p:nvSpPr>
-          <p:cNvPr id="28" name="Text 26"/>
-          <p:cNvSpPr/>
-          <p:nvPr/>
-        </p:nvSpPr>
-        <p:spPr>
-          <a:xfrm>
-            <a:off x="6958584" y="3063240"/>
-            <a:ext cx="4334256" cy="530352"/>
+          <p:cNvPr id="33" name="Text 31"/>
+          <p:cNvSpPr/>
+          <p:nvPr/>
+        </p:nvSpPr>
+        <p:spPr>
+          <a:xfrm>
+            <a:off x="7571232" y="3154680"/>
+            <a:ext cx="3145536" cy="566928"/>
           </a:xfrm>
           <a:prstGeom prst="rect">
             <a:avLst/>
@@ -6775,7 +7154,7 @@
                 <a:ea typeface="Arial" pitchFamily="34" charset="-122"/>
                 <a:cs typeface="Arial" pitchFamily="34" charset="-120"/>
               </a:rPr>
-              <a:t>Видеограф · имя н/д</a:t>
+              <a:t>Асанов Әділ Асанұлы</a:t>
             </a:r>
             <a:endParaRPr lang="en-US" sz="1050" dirty="0"/>
           </a:p>
@@ -6789,13 +7168,13 @@
             <a:r>
               <a:rPr lang="en-US" sz="1100" b="1" dirty="0">
                 <a:solidFill>
-                  <a:srgbClr val="B45309"/>
-                </a:solidFill>
-                <a:latin typeface="Arial" pitchFamily="34" charset="0"/>
-                <a:ea typeface="Arial" pitchFamily="34" charset="-122"/>
-                <a:cs typeface="Arial" pitchFamily="34" charset="-120"/>
-              </a:rPr>
-              <a:t>1 498 769 ₸  *</a:t>
+                  <a:srgbClr val="0F6E4F"/>
+                </a:solidFill>
+                <a:latin typeface="Arial" pitchFamily="34" charset="0"/>
+                <a:ea typeface="Arial" pitchFamily="34" charset="-122"/>
+                <a:cs typeface="Arial" pitchFamily="34" charset="-120"/>
+              </a:rPr>
+              <a:t>1 000 162 ₸</a:t>
             </a:r>
             <a:endParaRPr lang="en-US" sz="1050" dirty="0"/>
           </a:p>
@@ -6803,18 +7182,18 @@
       </p:sp>
       <p:sp>
         <p:nvSpPr>
-          <p:cNvPr id="29" name="Shape 27"/>
-          <p:cNvSpPr/>
-          <p:nvPr/>
-        </p:nvSpPr>
-        <p:spPr>
-          <a:xfrm>
-            <a:off x="6885432" y="3707892"/>
-            <a:ext cx="4480560" cy="621792"/>
+          <p:cNvPr id="34" name="Shape 32"/>
+          <p:cNvSpPr/>
+          <p:nvPr/>
+        </p:nvSpPr>
+        <p:spPr>
+          <a:xfrm>
+            <a:off x="7498080" y="3895344"/>
+            <a:ext cx="3291840" cy="658368"/>
           </a:xfrm>
           <a:prstGeom prst="roundRect">
             <a:avLst>
-              <a:gd name="adj" fmla="val 8824"/>
+              <a:gd name="adj" fmla="val 8333"/>
             </a:avLst>
           </a:prstGeom>
           <a:solidFill>
@@ -6837,14 +7216,14 @@
       </p:sp>
       <p:sp>
         <p:nvSpPr>
-          <p:cNvPr id="30" name="Text 28"/>
-          <p:cNvSpPr/>
-          <p:nvPr/>
-        </p:nvSpPr>
-        <p:spPr>
-          <a:xfrm>
-            <a:off x="6958584" y="3753612"/>
-            <a:ext cx="4334256" cy="530352"/>
+          <p:cNvPr id="35" name="Text 33"/>
+          <p:cNvSpPr/>
+          <p:nvPr/>
+        </p:nvSpPr>
+        <p:spPr>
+          <a:xfrm>
+            <a:off x="7571232" y="3941064"/>
+            <a:ext cx="3145536" cy="566928"/>
           </a:xfrm>
           <a:prstGeom prst="rect">
             <a:avLst/>
@@ -6891,7 +7270,7 @@
                 <a:ea typeface="Arial" pitchFamily="34" charset="-122"/>
                 <a:cs typeface="Arial" pitchFamily="34" charset="-120"/>
               </a:rPr>
-              <a:t>Видеограф · имя н/д</a:t>
+              <a:t>Шаймардан Мағжан Адилұлы</a:t>
             </a:r>
             <a:endParaRPr lang="en-US" sz="1050" dirty="0"/>
           </a:p>
@@ -6905,13 +7284,13 @@
             <a:r>
               <a:rPr lang="en-US" sz="1100" b="1" dirty="0">
                 <a:solidFill>
-                  <a:srgbClr val="B45309"/>
-                </a:solidFill>
-                <a:latin typeface="Arial" pitchFamily="34" charset="0"/>
-                <a:ea typeface="Arial" pitchFamily="34" charset="-122"/>
-                <a:cs typeface="Arial" pitchFamily="34" charset="-120"/>
-              </a:rPr>
-              <a:t>1 498 769 ₸  *</a:t>
+                  <a:srgbClr val="0F6E4F"/>
+                </a:solidFill>
+                <a:latin typeface="Arial" pitchFamily="34" charset="0"/>
+                <a:ea typeface="Arial" pitchFamily="34" charset="-122"/>
+                <a:cs typeface="Arial" pitchFamily="34" charset="-120"/>
+              </a:rPr>
+              <a:t>751 000 ₸</a:t>
             </a:r>
             <a:endParaRPr lang="en-US" sz="1050" dirty="0"/>
           </a:p>
@@ -6919,18 +7298,18 @@
       </p:sp>
       <p:sp>
         <p:nvSpPr>
-          <p:cNvPr id="31" name="Shape 29"/>
-          <p:cNvSpPr/>
-          <p:nvPr/>
-        </p:nvSpPr>
-        <p:spPr>
-          <a:xfrm>
-            <a:off x="6885432" y="4398264"/>
-            <a:ext cx="4480560" cy="621792"/>
+          <p:cNvPr id="36" name="Shape 34"/>
+          <p:cNvSpPr/>
+          <p:nvPr/>
+        </p:nvSpPr>
+        <p:spPr>
+          <a:xfrm>
+            <a:off x="7498080" y="4681728"/>
+            <a:ext cx="3291840" cy="658368"/>
           </a:xfrm>
           <a:prstGeom prst="roundRect">
             <a:avLst>
-              <a:gd name="adj" fmla="val 8824"/>
+              <a:gd name="adj" fmla="val 8333"/>
             </a:avLst>
           </a:prstGeom>
           <a:solidFill>
@@ -6953,14 +7332,14 @@
       </p:sp>
       <p:sp>
         <p:nvSpPr>
-          <p:cNvPr id="32" name="Text 30"/>
-          <p:cNvSpPr/>
-          <p:nvPr/>
-        </p:nvSpPr>
-        <p:spPr>
-          <a:xfrm>
-            <a:off x="6958584" y="4443984"/>
-            <a:ext cx="4334256" cy="530352"/>
+          <p:cNvPr id="37" name="Text 35"/>
+          <p:cNvSpPr/>
+          <p:nvPr/>
+        </p:nvSpPr>
+        <p:spPr>
+          <a:xfrm>
+            <a:off x="7571232" y="4727448"/>
+            <a:ext cx="3145536" cy="566928"/>
           </a:xfrm>
           <a:prstGeom prst="rect">
             <a:avLst/>
@@ -7007,7 +7386,7 @@
                 <a:ea typeface="Arial" pitchFamily="34" charset="-122"/>
                 <a:cs typeface="Arial" pitchFamily="34" charset="-120"/>
               </a:rPr>
-              <a:t>Видеограф · имя н/д</a:t>
+              <a:t>Жұмағали Әділжан Бауыржанұлы</a:t>
             </a:r>
             <a:endParaRPr lang="en-US" sz="1050" dirty="0"/>
           </a:p>
@@ -7021,13 +7400,13 @@
             <a:r>
               <a:rPr lang="en-US" sz="1100" b="1" dirty="0">
                 <a:solidFill>
-                  <a:srgbClr val="B45309"/>
-                </a:solidFill>
-                <a:latin typeface="Arial" pitchFamily="34" charset="0"/>
-                <a:ea typeface="Arial" pitchFamily="34" charset="-122"/>
-                <a:cs typeface="Arial" pitchFamily="34" charset="-120"/>
-              </a:rPr>
-              <a:t>1 498 769 ₸  *</a:t>
+                  <a:srgbClr val="0F6E4F"/>
+                </a:solidFill>
+                <a:latin typeface="Arial" pitchFamily="34" charset="0"/>
+                <a:ea typeface="Arial" pitchFamily="34" charset="-122"/>
+                <a:cs typeface="Arial" pitchFamily="34" charset="-120"/>
+              </a:rPr>
+              <a:t>804 324 ₸</a:t>
             </a:r>
             <a:endParaRPr lang="en-US" sz="1050" dirty="0"/>
           </a:p>
@@ -7035,18 +7414,18 @@
       </p:sp>
       <p:sp>
         <p:nvSpPr>
-          <p:cNvPr id="33" name="Shape 31"/>
-          <p:cNvSpPr/>
-          <p:nvPr/>
-        </p:nvSpPr>
-        <p:spPr>
-          <a:xfrm>
-            <a:off x="6885432" y="5088636"/>
-            <a:ext cx="4480560" cy="621792"/>
+          <p:cNvPr id="38" name="Shape 36"/>
+          <p:cNvSpPr/>
+          <p:nvPr/>
+        </p:nvSpPr>
+        <p:spPr>
+          <a:xfrm>
+            <a:off x="7498080" y="5468112"/>
+            <a:ext cx="3291840" cy="658368"/>
           </a:xfrm>
           <a:prstGeom prst="roundRect">
             <a:avLst>
-              <a:gd name="adj" fmla="val 8824"/>
+              <a:gd name="adj" fmla="val 8333"/>
             </a:avLst>
           </a:prstGeom>
           <a:solidFill>
@@ -7069,14 +7448,14 @@
       </p:sp>
       <p:sp>
         <p:nvSpPr>
-          <p:cNvPr id="34" name="Text 32"/>
-          <p:cNvSpPr/>
-          <p:nvPr/>
-        </p:nvSpPr>
-        <p:spPr>
-          <a:xfrm>
-            <a:off x="6958584" y="5134356"/>
-            <a:ext cx="4334256" cy="530352"/>
+          <p:cNvPr id="39" name="Text 37"/>
+          <p:cNvSpPr/>
+          <p:nvPr/>
+        </p:nvSpPr>
+        <p:spPr>
+          <a:xfrm>
+            <a:off x="7571232" y="5513832"/>
+            <a:ext cx="3145536" cy="566928"/>
           </a:xfrm>
           <a:prstGeom prst="rect">
             <a:avLst/>
@@ -7123,7 +7502,7 @@
                 <a:ea typeface="Arial" pitchFamily="34" charset="-122"/>
                 <a:cs typeface="Arial" pitchFamily="34" charset="-120"/>
               </a:rPr>
-              <a:t>Видеограф · имя н/д</a:t>
+              <a:t>Боровков Владимир Владимирович</a:t>
             </a:r>
             <a:endParaRPr lang="en-US" sz="1050" dirty="0"/>
           </a:p>
@@ -7137,13 +7516,13 @@
             <a:r>
               <a:rPr lang="en-US" sz="1100" b="1" dirty="0">
                 <a:solidFill>
-                  <a:srgbClr val="B45309"/>
-                </a:solidFill>
-                <a:latin typeface="Arial" pitchFamily="34" charset="0"/>
-                <a:ea typeface="Arial" pitchFamily="34" charset="-122"/>
-                <a:cs typeface="Arial" pitchFamily="34" charset="-120"/>
-              </a:rPr>
-              <a:t>1 498 769 ₸  *</a:t>
+                  <a:srgbClr val="0F6E4F"/>
+                </a:solidFill>
+                <a:latin typeface="Arial" pitchFamily="34" charset="0"/>
+                <a:ea typeface="Arial" pitchFamily="34" charset="-122"/>
+                <a:cs typeface="Arial" pitchFamily="34" charset="-120"/>
+              </a:rPr>
+              <a:t>523 000 ₸</a:t>
             </a:r>
             <a:endParaRPr lang="en-US" sz="1050" dirty="0"/>
           </a:p>
@@ -8755,7 +9134,7 @@
                 <a:ea typeface="Arial" pitchFamily="34" charset="-122"/>
                 <a:cs typeface="Arial" pitchFamily="34" charset="-120"/>
               </a:rPr>
-              <a:t>Мобилограф / монтажёр (4 позиции)</a:t>
+              <a:t>PPC (1)</a:t>
             </a:r>
             <a:endParaRPr lang="en-US" sz="1200" dirty="0"/>
           </a:p>
@@ -8794,7 +9173,7 @@
                 <a:ea typeface="Arial" pitchFamily="34" charset="-122"/>
                 <a:cs typeface="Arial" pitchFamily="34" charset="-120"/>
               </a:rPr>
-              <a:t>Видеограф — макс. из 5</a:t>
+              <a:t>Трафик менеджер — макс. из 2</a:t>
             </a:r>
             <a:endParaRPr lang="en-US" sz="1100" dirty="0"/>
           </a:p>
@@ -8833,7 +9212,7 @@
                 <a:ea typeface="Arial" pitchFamily="34" charset="-122"/>
                 <a:cs typeface="Arial" pitchFamily="34" charset="-120"/>
               </a:rPr>
-              <a:t>1 498 769 ₸</a:t>
+              <a:t>1 124 000 ₸</a:t>
             </a:r>
             <a:endParaRPr lang="en-US" sz="1300" dirty="0"/>
           </a:p>
@@ -8897,7 +9276,7 @@
                 <a:ea typeface="Arial" pitchFamily="34" charset="-122"/>
                 <a:cs typeface="Arial" pitchFamily="34" charset="-120"/>
               </a:rPr>
-              <a:t>PPC (1)</a:t>
+              <a:t>CVM (?) — планируемая позиция</a:t>
             </a:r>
             <a:endParaRPr lang="en-US" sz="1200" dirty="0"/>
           </a:p>
@@ -8936,7 +9315,7 @@
                 <a:ea typeface="Arial" pitchFamily="34" charset="-122"/>
                 <a:cs typeface="Arial" pitchFamily="34" charset="-120"/>
               </a:rPr>
-              <a:t>Трафик менеджер — макс. из 2</a:t>
+              <a:t>CVM ≈ CRM менеджер</a:t>
             </a:r>
             <a:endParaRPr lang="en-US" sz="1100" dirty="0"/>
           </a:p>
@@ -8975,7 +9354,7 @@
                 <a:ea typeface="Arial" pitchFamily="34" charset="-122"/>
                 <a:cs typeface="Arial" pitchFamily="34" charset="-120"/>
               </a:rPr>
-              <a:t>1 124 000 ₸</a:t>
+              <a:t>867 456 ₸</a:t>
             </a:r>
             <a:endParaRPr lang="en-US" sz="1300" dirty="0"/>
           </a:p>
@@ -8983,51 +9362,46 @@
       </p:sp>
       <p:sp>
         <p:nvSpPr>
-          <p:cNvPr id="28" name="Shape 26"/>
-          <p:cNvSpPr/>
-          <p:nvPr/>
-        </p:nvSpPr>
-        <p:spPr>
-          <a:xfrm>
-            <a:off x="548640" y="4690872"/>
-            <a:ext cx="11091672" cy="548640"/>
-          </a:xfrm>
-          <a:prstGeom prst="rect">
-            <a:avLst/>
-          </a:prstGeom>
-          <a:solidFill>
-            <a:srgbClr val="FFFFFF"/>
-          </a:solidFill>
-          <a:ln w="6350">
-            <a:solidFill>
-              <a:srgbClr val="C7D8EE"/>
-            </a:solidFill>
-            <a:prstDash val="solid"/>
-          </a:ln>
-        </p:spPr>
-      </p:sp>
-      <p:sp>
-        <p:nvSpPr>
-          <p:cNvPr id="29" name="Text 27"/>
-          <p:cNvSpPr/>
-          <p:nvPr/>
-        </p:nvSpPr>
-        <p:spPr>
-          <a:xfrm>
-            <a:off x="777240" y="4690872"/>
-            <a:ext cx="4937760" cy="548640"/>
-          </a:xfrm>
-          <a:prstGeom prst="rect">
-            <a:avLst/>
-          </a:prstGeom>
-          <a:noFill/>
-          <a:ln/>
-        </p:spPr>
-        <p:txBody>
-          <a:bodyPr wrap="square" lIns="0" tIns="0" rIns="0" bIns="0" rtlCol="0" anchor="ctr"/>
+          <p:cNvPr id="28" name="Text 26"/>
+          <p:cNvSpPr/>
+          <p:nvPr/>
+        </p:nvSpPr>
+        <p:spPr>
+          <a:xfrm>
+            <a:off x="548640" y="4965192"/>
+            <a:ext cx="11091672" cy="731520"/>
+          </a:xfrm>
+          <a:prstGeom prst="rect">
+            <a:avLst/>
+          </a:prstGeom>
+          <a:noFill/>
+          <a:ln/>
+        </p:spPr>
+        <p:txBody>
+          <a:bodyPr wrap="square" lIns="0" tIns="0" rIns="0" bIns="0" rtlCol="0" anchor="t"/>
           <a:lstStyle/>
           <a:p>
             <a:pPr algn="l" indent="0" marL="0">
+              <a:lnSpc>
+                <a:spcPct val="115000"/>
+              </a:lnSpc>
+              <a:buNone/>
+            </a:pPr>
+            <a:r>
+              <a:rPr lang="en-US" sz="1200" b="1" dirty="0">
+                <a:solidFill>
+                  <a:srgbClr val="1F3A5F"/>
+                </a:solidFill>
+                <a:latin typeface="Arial" pitchFamily="34" charset="0"/>
+                <a:ea typeface="Arial" pitchFamily="34" charset="-122"/>
+                <a:cs typeface="Arial" pitchFamily="34" charset="-120"/>
+              </a:rPr>
+              <a:t>Как считалось.  </a:t>
+            </a:r>
+            <a:pPr algn="l" indent="0" marL="0">
+              <a:lnSpc>
+                <a:spcPct val="115000"/>
+              </a:lnSpc>
               <a:buNone/>
             </a:pPr>
             <a:r>
@@ -9039,144 +9413,7 @@
                 <a:ea typeface="Arial" pitchFamily="34" charset="-122"/>
                 <a:cs typeface="Arial" pitchFamily="34" charset="-120"/>
               </a:rPr>
-              <a:t>CVM (?) — планируемая позиция</a:t>
-            </a:r>
-            <a:endParaRPr lang="en-US" sz="1200" dirty="0"/>
-          </a:p>
-        </p:txBody>
-      </p:sp>
-      <p:sp>
-        <p:nvSpPr>
-          <p:cNvPr id="30" name="Text 28"/>
-          <p:cNvSpPr/>
-          <p:nvPr/>
-        </p:nvSpPr>
-        <p:spPr>
-          <a:xfrm>
-            <a:off x="5852160" y="4690872"/>
-            <a:ext cx="4206240" cy="548640"/>
-          </a:xfrm>
-          <a:prstGeom prst="rect">
-            <a:avLst/>
-          </a:prstGeom>
-          <a:noFill/>
-          <a:ln/>
-        </p:spPr>
-        <p:txBody>
-          <a:bodyPr wrap="square" lIns="0" tIns="0" rIns="0" bIns="0" rtlCol="0" anchor="ctr"/>
-          <a:lstStyle/>
-          <a:p>
-            <a:pPr algn="l" indent="0" marL="0">
-              <a:buNone/>
-            </a:pPr>
-            <a:r>
-              <a:rPr lang="en-US" sz="1100" i="1" dirty="0">
-                <a:solidFill>
-                  <a:srgbClr val="5B6B7C"/>
-                </a:solidFill>
-                <a:latin typeface="Arial" pitchFamily="34" charset="0"/>
-                <a:ea typeface="Arial" pitchFamily="34" charset="-122"/>
-                <a:cs typeface="Arial" pitchFamily="34" charset="-120"/>
-              </a:rPr>
-              <a:t>CVM ≈ CRM менеджер</a:t>
-            </a:r>
-            <a:endParaRPr lang="en-US" sz="1100" dirty="0"/>
-          </a:p>
-        </p:txBody>
-      </p:sp>
-      <p:sp>
-        <p:nvSpPr>
-          <p:cNvPr id="31" name="Text 29"/>
-          <p:cNvSpPr/>
-          <p:nvPr/>
-        </p:nvSpPr>
-        <p:spPr>
-          <a:xfrm>
-            <a:off x="9171432" y="4690872"/>
-            <a:ext cx="2286000" cy="548640"/>
-          </a:xfrm>
-          <a:prstGeom prst="rect">
-            <a:avLst/>
-          </a:prstGeom>
-          <a:noFill/>
-          <a:ln/>
-        </p:spPr>
-        <p:txBody>
-          <a:bodyPr wrap="square" lIns="0" tIns="0" rIns="0" bIns="0" rtlCol="0" anchor="ctr"/>
-          <a:lstStyle/>
-          <a:p>
-            <a:pPr algn="r" indent="0" marL="0">
-              <a:buNone/>
-            </a:pPr>
-            <a:r>
-              <a:rPr lang="en-US" sz="1300" b="1" dirty="0">
-                <a:solidFill>
-                  <a:srgbClr val="B45309"/>
-                </a:solidFill>
-                <a:latin typeface="Arial" pitchFamily="34" charset="0"/>
-                <a:ea typeface="Arial" pitchFamily="34" charset="-122"/>
-                <a:cs typeface="Arial" pitchFamily="34" charset="-120"/>
-              </a:rPr>
-              <a:t>867 456 ₸</a:t>
-            </a:r>
-            <a:endParaRPr lang="en-US" sz="1300" dirty="0"/>
-          </a:p>
-        </p:txBody>
-      </p:sp>
-      <p:sp>
-        <p:nvSpPr>
-          <p:cNvPr id="32" name="Text 30"/>
-          <p:cNvSpPr/>
-          <p:nvPr/>
-        </p:nvSpPr>
-        <p:spPr>
-          <a:xfrm>
-            <a:off x="548640" y="5513832"/>
-            <a:ext cx="11091672" cy="731520"/>
-          </a:xfrm>
-          <a:prstGeom prst="rect">
-            <a:avLst/>
-          </a:prstGeom>
-          <a:noFill/>
-          <a:ln/>
-        </p:spPr>
-        <p:txBody>
-          <a:bodyPr wrap="square" lIns="0" tIns="0" rIns="0" bIns="0" rtlCol="0" anchor="t"/>
-          <a:lstStyle/>
-          <a:p>
-            <a:pPr algn="l" indent="0" marL="0">
-              <a:lnSpc>
-                <a:spcPct val="115000"/>
-              </a:lnSpc>
-              <a:buNone/>
-            </a:pPr>
-            <a:r>
-              <a:rPr lang="en-US" sz="1200" b="1" dirty="0">
-                <a:solidFill>
-                  <a:srgbClr val="1F3A5F"/>
-                </a:solidFill>
-                <a:latin typeface="Arial" pitchFamily="34" charset="0"/>
-                <a:ea typeface="Arial" pitchFamily="34" charset="-122"/>
-                <a:cs typeface="Arial" pitchFamily="34" charset="-120"/>
-              </a:rPr>
-              <a:t>Как считалось.  </a:t>
-            </a:r>
-            <a:pPr algn="l" indent="0" marL="0">
-              <a:lnSpc>
-                <a:spcPct val="115000"/>
-              </a:lnSpc>
-              <a:buNone/>
-            </a:pPr>
-            <a:r>
-              <a:rPr lang="en-US" sz="1200" dirty="0">
-                <a:solidFill>
-                  <a:srgbClr val="1F2A37"/>
-                </a:solidFill>
-                <a:latin typeface="Arial" pitchFamily="34" charset="0"/>
-                <a:ea typeface="Arial" pitchFamily="34" charset="-122"/>
-                <a:cs typeface="Arial" pitchFamily="34" charset="-120"/>
-              </a:rPr>
-              <a:t>ФОТ отдела = сумма должностных окладов (тотал) всех позиций отдела, включая руководителя. Суммы взяты из Excel; руководители и senior-роли — из отдельного блока стоимостей. Итог по 4 отделам: 44 050 321 ₸ в месяц.</a:t>
+              <a:t>ФОТ отдела = сумма должностных окладов (тотал) всех позиций отдела, включая руководителя. Суммы взяты из Excel; руководители и senior-роли — из отдельного блока стоимостей. Итог по 4 отделам: 41 133 731 ₸ в месяц.</a:t>
             </a:r>
             <a:endParaRPr lang="en-US" sz="1200" dirty="0"/>
           </a:p>

</xml_diff>

<commit_message>
Split Marcom Контент into Originals/Sport direction columns
Per the source structure, Контент now shows two labelled direction
columns: Originals (Аида А, Райлана, Чолпон, Аяулым) and Sport
(Александр К, Яков), mirroring the SMM Gen/Originals/Sport split.
Applied to the PowerPoint deck and the HTML presentation.

Co-Authored-By: Claude Opus 4.8 <noreply@anthropic.com>
Claude-Session: https://claude.ai/code/session_015FvdqNtbbJPjugTChUgZkw
</commit_message>
<xml_diff>
--- a/Структура маркетинга — отделы и ФОТ.pptx
+++ b/Структура маркетинга — отделы и ФОТ.pptx
@@ -2946,13 +2946,91 @@
       </p:sp>
       <p:sp>
         <p:nvSpPr>
-          <p:cNvPr id="15" name="Shape 13"/>
-          <p:cNvSpPr/>
-          <p:nvPr/>
-        </p:nvSpPr>
-        <p:spPr>
-          <a:xfrm>
-            <a:off x="457200" y="2340864"/>
+          <p:cNvPr id="15" name="Text 13"/>
+          <p:cNvSpPr/>
+          <p:nvPr/>
+        </p:nvSpPr>
+        <p:spPr>
+          <a:xfrm>
+            <a:off x="457200" y="2359152"/>
+            <a:ext cx="1691640" cy="201168"/>
+          </a:xfrm>
+          <a:prstGeom prst="rect">
+            <a:avLst/>
+          </a:prstGeom>
+          <a:noFill/>
+          <a:ln/>
+        </p:spPr>
+        <p:txBody>
+          <a:bodyPr wrap="square" lIns="0" tIns="0" rIns="0" bIns="0" rtlCol="0" anchor="ctr"/>
+          <a:lstStyle/>
+          <a:p>
+            <a:pPr algn="ctr" indent="0" marL="0">
+              <a:buNone/>
+            </a:pPr>
+            <a:r>
+              <a:rPr lang="en-US" sz="900" b="1" dirty="0">
+                <a:solidFill>
+                  <a:srgbClr val="5B6B7C"/>
+                </a:solidFill>
+                <a:latin typeface="Arial" pitchFamily="34" charset="0"/>
+                <a:ea typeface="Arial" pitchFamily="34" charset="-122"/>
+                <a:cs typeface="Arial" pitchFamily="34" charset="-120"/>
+              </a:rPr>
+              <a:t>Originals</a:t>
+            </a:r>
+            <a:endParaRPr lang="en-US" sz="900" dirty="0"/>
+          </a:p>
+        </p:txBody>
+      </p:sp>
+      <p:sp>
+        <p:nvSpPr>
+          <p:cNvPr id="16" name="Text 14"/>
+          <p:cNvSpPr/>
+          <p:nvPr/>
+        </p:nvSpPr>
+        <p:spPr>
+          <a:xfrm>
+            <a:off x="2258568" y="2359152"/>
+            <a:ext cx="1691640" cy="201168"/>
+          </a:xfrm>
+          <a:prstGeom prst="rect">
+            <a:avLst/>
+          </a:prstGeom>
+          <a:noFill/>
+          <a:ln/>
+        </p:spPr>
+        <p:txBody>
+          <a:bodyPr wrap="square" lIns="0" tIns="0" rIns="0" bIns="0" rtlCol="0" anchor="ctr"/>
+          <a:lstStyle/>
+          <a:p>
+            <a:pPr algn="ctr" indent="0" marL="0">
+              <a:buNone/>
+            </a:pPr>
+            <a:r>
+              <a:rPr lang="en-US" sz="900" b="1" dirty="0">
+                <a:solidFill>
+                  <a:srgbClr val="5B6B7C"/>
+                </a:solidFill>
+                <a:latin typeface="Arial" pitchFamily="34" charset="0"/>
+                <a:ea typeface="Arial" pitchFamily="34" charset="-122"/>
+                <a:cs typeface="Arial" pitchFamily="34" charset="-120"/>
+              </a:rPr>
+              <a:t>Sport</a:t>
+            </a:r>
+            <a:endParaRPr lang="en-US" sz="900" dirty="0"/>
+          </a:p>
+        </p:txBody>
+      </p:sp>
+      <p:sp>
+        <p:nvSpPr>
+          <p:cNvPr id="17" name="Shape 15"/>
+          <p:cNvSpPr/>
+          <p:nvPr/>
+        </p:nvSpPr>
+        <p:spPr>
+          <a:xfrm>
+            <a:off x="457200" y="2615184"/>
             <a:ext cx="1691640" cy="932688"/>
           </a:xfrm>
           <a:prstGeom prst="roundRect">
@@ -2980,13 +3058,13 @@
       </p:sp>
       <p:sp>
         <p:nvSpPr>
-          <p:cNvPr id="16" name="Text 14"/>
-          <p:cNvSpPr/>
-          <p:nvPr/>
-        </p:nvSpPr>
-        <p:spPr>
-          <a:xfrm>
-            <a:off x="530352" y="2386584"/>
+          <p:cNvPr id="18" name="Text 16"/>
+          <p:cNvSpPr/>
+          <p:nvPr/>
+        </p:nvSpPr>
+        <p:spPr>
+          <a:xfrm>
+            <a:off x="530352" y="2660904"/>
             <a:ext cx="1545336" cy="841248"/>
           </a:xfrm>
           <a:prstGeom prst="rect">
@@ -3062,13 +3140,13 @@
       </p:sp>
       <p:sp>
         <p:nvSpPr>
-          <p:cNvPr id="17" name="Shape 15"/>
-          <p:cNvSpPr/>
-          <p:nvPr/>
-        </p:nvSpPr>
-        <p:spPr>
-          <a:xfrm>
-            <a:off x="457200" y="3364992"/>
+          <p:cNvPr id="19" name="Shape 17"/>
+          <p:cNvSpPr/>
+          <p:nvPr/>
+        </p:nvSpPr>
+        <p:spPr>
+          <a:xfrm>
+            <a:off x="457200" y="3639312"/>
             <a:ext cx="1691640" cy="932688"/>
           </a:xfrm>
           <a:prstGeom prst="roundRect">
@@ -3096,13 +3174,13 @@
       </p:sp>
       <p:sp>
         <p:nvSpPr>
-          <p:cNvPr id="18" name="Text 16"/>
-          <p:cNvSpPr/>
-          <p:nvPr/>
-        </p:nvSpPr>
-        <p:spPr>
-          <a:xfrm>
-            <a:off x="530352" y="3410712"/>
+          <p:cNvPr id="20" name="Text 18"/>
+          <p:cNvSpPr/>
+          <p:nvPr/>
+        </p:nvSpPr>
+        <p:spPr>
+          <a:xfrm>
+            <a:off x="530352" y="3685032"/>
             <a:ext cx="1545336" cy="841248"/>
           </a:xfrm>
           <a:prstGeom prst="rect">
@@ -3178,13 +3256,13 @@
       </p:sp>
       <p:sp>
         <p:nvSpPr>
-          <p:cNvPr id="19" name="Shape 17"/>
-          <p:cNvSpPr/>
-          <p:nvPr/>
-        </p:nvSpPr>
-        <p:spPr>
-          <a:xfrm>
-            <a:off x="457200" y="4389120"/>
+          <p:cNvPr id="21" name="Shape 19"/>
+          <p:cNvSpPr/>
+          <p:nvPr/>
+        </p:nvSpPr>
+        <p:spPr>
+          <a:xfrm>
+            <a:off x="457200" y="4663440"/>
             <a:ext cx="1691640" cy="932688"/>
           </a:xfrm>
           <a:prstGeom prst="roundRect">
@@ -3212,13 +3290,13 @@
       </p:sp>
       <p:sp>
         <p:nvSpPr>
-          <p:cNvPr id="20" name="Text 18"/>
-          <p:cNvSpPr/>
-          <p:nvPr/>
-        </p:nvSpPr>
-        <p:spPr>
-          <a:xfrm>
-            <a:off x="530352" y="4434840"/>
+          <p:cNvPr id="22" name="Text 20"/>
+          <p:cNvSpPr/>
+          <p:nvPr/>
+        </p:nvSpPr>
+        <p:spPr>
+          <a:xfrm>
+            <a:off x="530352" y="4709160"/>
             <a:ext cx="1545336" cy="841248"/>
           </a:xfrm>
           <a:prstGeom prst="rect">
@@ -3294,13 +3372,13 @@
       </p:sp>
       <p:sp>
         <p:nvSpPr>
-          <p:cNvPr id="21" name="Shape 19"/>
-          <p:cNvSpPr/>
-          <p:nvPr/>
-        </p:nvSpPr>
-        <p:spPr>
-          <a:xfrm>
-            <a:off x="2258568" y="2340864"/>
+          <p:cNvPr id="23" name="Shape 21"/>
+          <p:cNvSpPr/>
+          <p:nvPr/>
+        </p:nvSpPr>
+        <p:spPr>
+          <a:xfrm>
+            <a:off x="457200" y="5687568"/>
             <a:ext cx="1691640" cy="932688"/>
           </a:xfrm>
           <a:prstGeom prst="roundRect">
@@ -3328,13 +3406,13 @@
       </p:sp>
       <p:sp>
         <p:nvSpPr>
-          <p:cNvPr id="22" name="Text 20"/>
-          <p:cNvSpPr/>
-          <p:nvPr/>
-        </p:nvSpPr>
-        <p:spPr>
-          <a:xfrm>
-            <a:off x="2331720" y="2386584"/>
+          <p:cNvPr id="24" name="Text 22"/>
+          <p:cNvSpPr/>
+          <p:nvPr/>
+        </p:nvSpPr>
+        <p:spPr>
+          <a:xfrm>
+            <a:off x="530352" y="5733288"/>
             <a:ext cx="1545336" cy="841248"/>
           </a:xfrm>
           <a:prstGeom prst="rect">
@@ -3362,7 +3440,7 @@
                 <a:ea typeface="Arial" pitchFamily="34" charset="-122"/>
                 <a:cs typeface="Arial" pitchFamily="34" charset="-120"/>
               </a:rPr>
-              <a:t>Promo · Александр К</a:t>
+              <a:t>Promo · Аяулым</a:t>
             </a:r>
             <a:endParaRPr lang="en-US" sz="945" dirty="0"/>
           </a:p>
@@ -3382,7 +3460,7 @@
                 <a:ea typeface="Arial" pitchFamily="34" charset="-122"/>
                 <a:cs typeface="Arial" pitchFamily="34" charset="-120"/>
               </a:rPr>
-              <a:t>Казачков Александр</a:t>
+              <a:t>Иманбаева Аяулым Маратовна</a:t>
             </a:r>
             <a:endParaRPr lang="en-US" sz="945" dirty="0"/>
           </a:p>
@@ -3402,7 +3480,7 @@
                 <a:ea typeface="Arial" pitchFamily="34" charset="-122"/>
                 <a:cs typeface="Arial" pitchFamily="34" charset="-120"/>
               </a:rPr>
-              <a:t>800 000 ₸</a:t>
+              <a:t>1 000 162 ₸</a:t>
             </a:r>
             <a:endParaRPr lang="en-US" sz="945" dirty="0"/>
           </a:p>
@@ -3410,13 +3488,13 @@
       </p:sp>
       <p:sp>
         <p:nvSpPr>
-          <p:cNvPr id="23" name="Shape 21"/>
-          <p:cNvSpPr/>
-          <p:nvPr/>
-        </p:nvSpPr>
-        <p:spPr>
-          <a:xfrm>
-            <a:off x="2258568" y="3364992"/>
+          <p:cNvPr id="25" name="Shape 23"/>
+          <p:cNvSpPr/>
+          <p:nvPr/>
+        </p:nvSpPr>
+        <p:spPr>
+          <a:xfrm>
+            <a:off x="2258568" y="2615184"/>
             <a:ext cx="1691640" cy="932688"/>
           </a:xfrm>
           <a:prstGeom prst="roundRect">
@@ -3444,13 +3522,13 @@
       </p:sp>
       <p:sp>
         <p:nvSpPr>
-          <p:cNvPr id="24" name="Text 22"/>
-          <p:cNvSpPr/>
-          <p:nvPr/>
-        </p:nvSpPr>
-        <p:spPr>
-          <a:xfrm>
-            <a:off x="2331720" y="3410712"/>
+          <p:cNvPr id="26" name="Text 24"/>
+          <p:cNvSpPr/>
+          <p:nvPr/>
+        </p:nvSpPr>
+        <p:spPr>
+          <a:xfrm>
+            <a:off x="2331720" y="2660904"/>
             <a:ext cx="1545336" cy="841248"/>
           </a:xfrm>
           <a:prstGeom prst="rect">
@@ -3478,7 +3556,7 @@
                 <a:ea typeface="Arial" pitchFamily="34" charset="-122"/>
                 <a:cs typeface="Arial" pitchFamily="34" charset="-120"/>
               </a:rPr>
-              <a:t>Promo · Яков</a:t>
+              <a:t>Promo · Александр К</a:t>
             </a:r>
             <a:endParaRPr lang="en-US" sz="945" dirty="0"/>
           </a:p>
@@ -3498,7 +3576,7 @@
                 <a:ea typeface="Arial" pitchFamily="34" charset="-122"/>
                 <a:cs typeface="Arial" pitchFamily="34" charset="-120"/>
               </a:rPr>
-              <a:t>Сорокин Яков Андреевич</a:t>
+              <a:t>Казачков Александр</a:t>
             </a:r>
             <a:endParaRPr lang="en-US" sz="945" dirty="0"/>
           </a:p>
@@ -3518,7 +3596,7 @@
                 <a:ea typeface="Arial" pitchFamily="34" charset="-122"/>
                 <a:cs typeface="Arial" pitchFamily="34" charset="-120"/>
               </a:rPr>
-              <a:t>614 931 ₸</a:t>
+              <a:t>800 000 ₸</a:t>
             </a:r>
             <a:endParaRPr lang="en-US" sz="945" dirty="0"/>
           </a:p>
@@ -3526,13 +3604,13 @@
       </p:sp>
       <p:sp>
         <p:nvSpPr>
-          <p:cNvPr id="25" name="Shape 23"/>
-          <p:cNvSpPr/>
-          <p:nvPr/>
-        </p:nvSpPr>
-        <p:spPr>
-          <a:xfrm>
-            <a:off x="2258568" y="4389120"/>
+          <p:cNvPr id="27" name="Shape 25"/>
+          <p:cNvSpPr/>
+          <p:nvPr/>
+        </p:nvSpPr>
+        <p:spPr>
+          <a:xfrm>
+            <a:off x="2258568" y="3639312"/>
             <a:ext cx="1691640" cy="932688"/>
           </a:xfrm>
           <a:prstGeom prst="roundRect">
@@ -3560,13 +3638,13 @@
       </p:sp>
       <p:sp>
         <p:nvSpPr>
-          <p:cNvPr id="26" name="Text 24"/>
-          <p:cNvSpPr/>
-          <p:nvPr/>
-        </p:nvSpPr>
-        <p:spPr>
-          <a:xfrm>
-            <a:off x="2331720" y="4434840"/>
+          <p:cNvPr id="28" name="Text 26"/>
+          <p:cNvSpPr/>
+          <p:nvPr/>
+        </p:nvSpPr>
+        <p:spPr>
+          <a:xfrm>
+            <a:off x="2331720" y="3685032"/>
             <a:ext cx="1545336" cy="841248"/>
           </a:xfrm>
           <a:prstGeom prst="rect">
@@ -3594,7 +3672,7 @@
                 <a:ea typeface="Arial" pitchFamily="34" charset="-122"/>
                 <a:cs typeface="Arial" pitchFamily="34" charset="-120"/>
               </a:rPr>
-              <a:t>Promo · Аяулым</a:t>
+              <a:t>Promo · Яков</a:t>
             </a:r>
             <a:endParaRPr lang="en-US" sz="945" dirty="0"/>
           </a:p>
@@ -3614,7 +3692,7 @@
                 <a:ea typeface="Arial" pitchFamily="34" charset="-122"/>
                 <a:cs typeface="Arial" pitchFamily="34" charset="-120"/>
               </a:rPr>
-              <a:t>Иманбаева Аяулым Маратовна</a:t>
+              <a:t>Сорокин Яков Андреевич</a:t>
             </a:r>
             <a:endParaRPr lang="en-US" sz="945" dirty="0"/>
           </a:p>
@@ -3634,7 +3712,7 @@
                 <a:ea typeface="Arial" pitchFamily="34" charset="-122"/>
                 <a:cs typeface="Arial" pitchFamily="34" charset="-120"/>
               </a:rPr>
-              <a:t>1 000 162 ₸</a:t>
+              <a:t>614 931 ₸</a:t>
             </a:r>
             <a:endParaRPr lang="en-US" sz="945" dirty="0"/>
           </a:p>
@@ -3642,7 +3720,7 @@
       </p:sp>
       <p:sp>
         <p:nvSpPr>
-          <p:cNvPr id="27" name="Shape 25"/>
+          <p:cNvPr id="29" name="Shape 27"/>
           <p:cNvSpPr/>
           <p:nvPr/>
         </p:nvSpPr>
@@ -3676,7 +3754,7 @@
       </p:sp>
       <p:sp>
         <p:nvSpPr>
-          <p:cNvPr id="28" name="Text 26"/>
+          <p:cNvPr id="30" name="Text 28"/>
           <p:cNvSpPr/>
           <p:nvPr/>
         </p:nvSpPr>
@@ -3758,7 +3836,7 @@
       </p:sp>
       <p:sp>
         <p:nvSpPr>
-          <p:cNvPr id="29" name="Text 27"/>
+          <p:cNvPr id="31" name="Text 29"/>
           <p:cNvSpPr/>
           <p:nvPr/>
         </p:nvSpPr>
@@ -3797,7 +3875,7 @@
       </p:sp>
       <p:sp>
         <p:nvSpPr>
-          <p:cNvPr id="30" name="Text 28"/>
+          <p:cNvPr id="32" name="Text 30"/>
           <p:cNvSpPr/>
           <p:nvPr/>
         </p:nvSpPr>
@@ -3836,7 +3914,7 @@
       </p:sp>
       <p:sp>
         <p:nvSpPr>
-          <p:cNvPr id="31" name="Text 29"/>
+          <p:cNvPr id="33" name="Text 31"/>
           <p:cNvSpPr/>
           <p:nvPr/>
         </p:nvSpPr>
@@ -3875,7 +3953,7 @@
       </p:sp>
       <p:sp>
         <p:nvSpPr>
-          <p:cNvPr id="32" name="Shape 30"/>
+          <p:cNvPr id="34" name="Shape 32"/>
           <p:cNvSpPr/>
           <p:nvPr/>
         </p:nvSpPr>
@@ -3898,7 +3976,7 @@
       </p:sp>
       <p:sp>
         <p:nvSpPr>
-          <p:cNvPr id="33" name="Shape 31"/>
+          <p:cNvPr id="35" name="Shape 33"/>
           <p:cNvSpPr/>
           <p:nvPr/>
         </p:nvSpPr>
@@ -3921,7 +3999,7 @@
       </p:sp>
       <p:sp>
         <p:nvSpPr>
-          <p:cNvPr id="34" name="Shape 32"/>
+          <p:cNvPr id="36" name="Shape 34"/>
           <p:cNvSpPr/>
           <p:nvPr/>
         </p:nvSpPr>
@@ -3944,7 +4022,7 @@
       </p:sp>
       <p:sp>
         <p:nvSpPr>
-          <p:cNvPr id="35" name="Shape 33"/>
+          <p:cNvPr id="37" name="Shape 35"/>
           <p:cNvSpPr/>
           <p:nvPr/>
         </p:nvSpPr>
@@ -3967,7 +4045,7 @@
       </p:sp>
       <p:sp>
         <p:nvSpPr>
-          <p:cNvPr id="36" name="Shape 34"/>
+          <p:cNvPr id="38" name="Shape 36"/>
           <p:cNvSpPr/>
           <p:nvPr/>
         </p:nvSpPr>
@@ -3990,7 +4068,7 @@
       </p:sp>
       <p:sp>
         <p:nvSpPr>
-          <p:cNvPr id="37" name="Shape 35"/>
+          <p:cNvPr id="39" name="Shape 37"/>
           <p:cNvSpPr/>
           <p:nvPr/>
         </p:nvSpPr>
@@ -4024,7 +4102,7 @@
       </p:sp>
       <p:sp>
         <p:nvSpPr>
-          <p:cNvPr id="38" name="Text 36"/>
+          <p:cNvPr id="40" name="Text 38"/>
           <p:cNvSpPr/>
           <p:nvPr/>
         </p:nvSpPr>
@@ -4106,7 +4184,7 @@
       </p:sp>
       <p:sp>
         <p:nvSpPr>
-          <p:cNvPr id="39" name="Shape 37"/>
+          <p:cNvPr id="41" name="Shape 39"/>
           <p:cNvSpPr/>
           <p:nvPr/>
         </p:nvSpPr>
@@ -4140,7 +4218,7 @@
       </p:sp>
       <p:sp>
         <p:nvSpPr>
-          <p:cNvPr id="40" name="Text 38"/>
+          <p:cNvPr id="42" name="Text 40"/>
           <p:cNvSpPr/>
           <p:nvPr/>
         </p:nvSpPr>
@@ -4222,7 +4300,7 @@
       </p:sp>
       <p:sp>
         <p:nvSpPr>
-          <p:cNvPr id="41" name="Shape 39"/>
+          <p:cNvPr id="43" name="Shape 41"/>
           <p:cNvSpPr/>
           <p:nvPr/>
         </p:nvSpPr>
@@ -4256,7 +4334,7 @@
       </p:sp>
       <p:sp>
         <p:nvSpPr>
-          <p:cNvPr id="42" name="Text 40"/>
+          <p:cNvPr id="44" name="Text 42"/>
           <p:cNvSpPr/>
           <p:nvPr/>
         </p:nvSpPr>
@@ -4338,7 +4416,7 @@
       </p:sp>
       <p:sp>
         <p:nvSpPr>
-          <p:cNvPr id="43" name="Shape 41"/>
+          <p:cNvPr id="45" name="Shape 43"/>
           <p:cNvSpPr/>
           <p:nvPr/>
         </p:nvSpPr>
@@ -4372,7 +4450,7 @@
       </p:sp>
       <p:sp>
         <p:nvSpPr>
-          <p:cNvPr id="44" name="Text 42"/>
+          <p:cNvPr id="46" name="Text 44"/>
           <p:cNvSpPr/>
           <p:nvPr/>
         </p:nvSpPr>
@@ -4454,7 +4532,7 @@
       </p:sp>
       <p:sp>
         <p:nvSpPr>
-          <p:cNvPr id="45" name="Shape 43"/>
+          <p:cNvPr id="47" name="Shape 45"/>
           <p:cNvSpPr/>
           <p:nvPr/>
         </p:nvSpPr>
@@ -4488,7 +4566,7 @@
       </p:sp>
       <p:sp>
         <p:nvSpPr>
-          <p:cNvPr id="46" name="Text 44"/>
+          <p:cNvPr id="48" name="Text 46"/>
           <p:cNvSpPr/>
           <p:nvPr/>
         </p:nvSpPr>
@@ -4570,7 +4648,7 @@
       </p:sp>
       <p:sp>
         <p:nvSpPr>
-          <p:cNvPr id="47" name="Shape 45"/>
+          <p:cNvPr id="49" name="Shape 47"/>
           <p:cNvSpPr/>
           <p:nvPr/>
         </p:nvSpPr>
@@ -4604,7 +4682,7 @@
       </p:sp>
       <p:sp>
         <p:nvSpPr>
-          <p:cNvPr id="48" name="Text 46"/>
+          <p:cNvPr id="50" name="Text 48"/>
           <p:cNvSpPr/>
           <p:nvPr/>
         </p:nvSpPr>

</xml_diff>

<commit_message>
Nest PPC under Senior PPC and CVM under Media manager in Каналы
Rebuild the Каналы коммуникации layout to match the source screen: three
managers report to the head (Senior PPC, Media manager, Внут. маркетинг),
with PPC (1) nested under Senior PPC and CVM (?) under Media manager.
Applied to the PowerPoint deck and the HTML presentation.

Co-Authored-By: Claude Opus 4.8 <noreply@anthropic.com>
Claude-Session: https://claude.ai/code/session_015FvdqNtbbJPjugTChUgZkw
</commit_message>
<xml_diff>
--- a/Структура маркетинга — отделы и ФОТ.pptx
+++ b/Структура маркетинга — отделы и ФОТ.pptx
@@ -4925,12 +4925,12 @@
         </p:nvSpPr>
         <p:spPr>
           <a:xfrm>
-            <a:off x="3991356" y="1417320"/>
-            <a:ext cx="4206240" cy="841248"/>
+            <a:off x="3991356" y="1051560"/>
+            <a:ext cx="4206240" cy="731520"/>
           </a:xfrm>
           <a:prstGeom prst="roundRect">
             <a:avLst>
-              <a:gd name="adj" fmla="val 6522"/>
+              <a:gd name="adj" fmla="val 7500"/>
             </a:avLst>
           </a:prstGeom>
           <a:solidFill>
@@ -4959,8 +4959,8 @@
         </p:nvSpPr>
         <p:spPr>
           <a:xfrm>
-            <a:off x="4064508" y="1463040"/>
-            <a:ext cx="4059936" cy="749808"/>
+            <a:off x="4064508" y="1097280"/>
+            <a:ext cx="4059936" cy="640080"/>
           </a:xfrm>
           <a:prstGeom prst="rect">
             <a:avLst/>
@@ -5041,8 +5041,8 @@
         </p:nvSpPr>
         <p:spPr>
           <a:xfrm>
-            <a:off x="6094476" y="2258568"/>
-            <a:ext cx="0" cy="987552"/>
+            <a:off x="6094476" y="1783080"/>
+            <a:ext cx="0" cy="182880"/>
           </a:xfrm>
           <a:prstGeom prst="line">
             <a:avLst/>
@@ -5064,8 +5064,8 @@
         </p:nvSpPr>
         <p:spPr>
           <a:xfrm>
-            <a:off x="1482242" y="3246120"/>
-            <a:ext cx="9224467" cy="0"/>
+            <a:off x="2702052" y="1965960"/>
+            <a:ext cx="6784848" cy="0"/>
           </a:xfrm>
           <a:prstGeom prst="line">
             <a:avLst/>
@@ -5087,7 +5087,7 @@
         </p:nvSpPr>
         <p:spPr>
           <a:xfrm>
-            <a:off x="1482242" y="3246120"/>
+            <a:off x="2702052" y="1965960"/>
             <a:ext cx="0" cy="411480"/>
           </a:xfrm>
           <a:prstGeom prst="line">
@@ -5110,12 +5110,12 @@
         </p:nvSpPr>
         <p:spPr>
           <a:xfrm>
-            <a:off x="457200" y="3657600"/>
-            <a:ext cx="2050085" cy="1554480"/>
+            <a:off x="1280160" y="2377440"/>
+            <a:ext cx="2843784" cy="1234440"/>
           </a:xfrm>
           <a:prstGeom prst="roundRect">
             <a:avLst>
-              <a:gd name="adj" fmla="val 3529"/>
+              <a:gd name="adj" fmla="val 4444"/>
             </a:avLst>
           </a:prstGeom>
           <a:solidFill>
@@ -5144,8 +5144,8 @@
         </p:nvSpPr>
         <p:spPr>
           <a:xfrm>
-            <a:off x="530352" y="3703320"/>
-            <a:ext cx="1903781" cy="1463040"/>
+            <a:off x="1353312" y="2423160"/>
+            <a:ext cx="2697480" cy="1143000"/>
           </a:xfrm>
           <a:prstGeom prst="rect">
             <a:avLst/>
@@ -5226,7 +5226,7 @@
         </p:nvSpPr>
         <p:spPr>
           <a:xfrm>
-            <a:off x="3788359" y="3246120"/>
+            <a:off x="6094476" y="1965960"/>
             <a:ext cx="0" cy="411480"/>
           </a:xfrm>
           <a:prstGeom prst="line">
@@ -5249,12 +5249,12 @@
         </p:nvSpPr>
         <p:spPr>
           <a:xfrm>
-            <a:off x="2763317" y="3657600"/>
-            <a:ext cx="2050085" cy="1554480"/>
+            <a:off x="4672584" y="2377440"/>
+            <a:ext cx="2843784" cy="1234440"/>
           </a:xfrm>
           <a:prstGeom prst="roundRect">
             <a:avLst>
-              <a:gd name="adj" fmla="val 3529"/>
+              <a:gd name="adj" fmla="val 4444"/>
             </a:avLst>
           </a:prstGeom>
           <a:solidFill>
@@ -5283,8 +5283,8 @@
         </p:nvSpPr>
         <p:spPr>
           <a:xfrm>
-            <a:off x="2836469" y="3703320"/>
-            <a:ext cx="1903781" cy="1463040"/>
+            <a:off x="4745736" y="2423160"/>
+            <a:ext cx="2697480" cy="1143000"/>
           </a:xfrm>
           <a:prstGeom prst="rect">
             <a:avLst/>
@@ -5365,7 +5365,7 @@
         </p:nvSpPr>
         <p:spPr>
           <a:xfrm>
-            <a:off x="6094476" y="3246120"/>
+            <a:off x="9486900" y="1965960"/>
             <a:ext cx="0" cy="411480"/>
           </a:xfrm>
           <a:prstGeom prst="line">
@@ -5388,12 +5388,12 @@
         </p:nvSpPr>
         <p:spPr>
           <a:xfrm>
-            <a:off x="5069434" y="3657600"/>
-            <a:ext cx="2050085" cy="1554480"/>
+            <a:off x="8065008" y="2377440"/>
+            <a:ext cx="2843784" cy="1234440"/>
           </a:xfrm>
           <a:prstGeom prst="roundRect">
             <a:avLst>
-              <a:gd name="adj" fmla="val 3529"/>
+              <a:gd name="adj" fmla="val 4444"/>
             </a:avLst>
           </a:prstGeom>
           <a:solidFill>
@@ -5422,8 +5422,8 @@
         </p:nvSpPr>
         <p:spPr>
           <a:xfrm>
-            <a:off x="5142586" y="3703320"/>
-            <a:ext cx="1903781" cy="1463040"/>
+            <a:off x="8138160" y="2423160"/>
+            <a:ext cx="2697480" cy="1143000"/>
           </a:xfrm>
           <a:prstGeom prst="rect">
             <a:avLst/>
@@ -5504,8 +5504,8 @@
         </p:nvSpPr>
         <p:spPr>
           <a:xfrm>
-            <a:off x="8400593" y="3246120"/>
-            <a:ext cx="0" cy="411480"/>
+            <a:off x="2702052" y="3611880"/>
+            <a:ext cx="0" cy="457200"/>
           </a:xfrm>
           <a:prstGeom prst="line">
             <a:avLst/>
@@ -5527,12 +5527,12 @@
         </p:nvSpPr>
         <p:spPr>
           <a:xfrm>
-            <a:off x="7375550" y="3657600"/>
-            <a:ext cx="2050085" cy="1554480"/>
+            <a:off x="1280160" y="4069080"/>
+            <a:ext cx="2843784" cy="1234440"/>
           </a:xfrm>
           <a:prstGeom prst="roundRect">
             <a:avLst>
-              <a:gd name="adj" fmla="val 3529"/>
+              <a:gd name="adj" fmla="val 4444"/>
             </a:avLst>
           </a:prstGeom>
           <a:solidFill>
@@ -5561,8 +5561,8 @@
         </p:nvSpPr>
         <p:spPr>
           <a:xfrm>
-            <a:off x="7448702" y="3703320"/>
-            <a:ext cx="1903781" cy="1463040"/>
+            <a:off x="1353312" y="4114800"/>
+            <a:ext cx="2697480" cy="1143000"/>
           </a:xfrm>
           <a:prstGeom prst="rect">
             <a:avLst/>
@@ -5643,8 +5643,8 @@
         </p:nvSpPr>
         <p:spPr>
           <a:xfrm>
-            <a:off x="10706710" y="3246120"/>
-            <a:ext cx="0" cy="411480"/>
+            <a:off x="6094476" y="3611880"/>
+            <a:ext cx="0" cy="457200"/>
           </a:xfrm>
           <a:prstGeom prst="line">
             <a:avLst/>
@@ -5666,12 +5666,12 @@
         </p:nvSpPr>
         <p:spPr>
           <a:xfrm>
-            <a:off x="9681667" y="3657600"/>
-            <a:ext cx="2050085" cy="1554480"/>
+            <a:off x="4672584" y="4069080"/>
+            <a:ext cx="2843784" cy="1234440"/>
           </a:xfrm>
           <a:prstGeom prst="roundRect">
             <a:avLst>
-              <a:gd name="adj" fmla="val 3529"/>
+              <a:gd name="adj" fmla="val 4444"/>
             </a:avLst>
           </a:prstGeom>
           <a:solidFill>
@@ -5700,8 +5700,8 @@
         </p:nvSpPr>
         <p:spPr>
           <a:xfrm>
-            <a:off x="9754819" y="3703320"/>
-            <a:ext cx="1903781" cy="1463040"/>
+            <a:off x="4745736" y="4114800"/>
+            <a:ext cx="2697480" cy="1143000"/>
           </a:xfrm>
           <a:prstGeom prst="rect">
             <a:avLst/>

</xml_diff>

<commit_message>
Fix Video production: remove Боровков, tag real videographers by direction
Боровков was not part of the team — remove him everywhere. Video
production now lists the three actual videographers with their directions:
Асанов Әділ (Originals, 1 000 162), Шаймардан Мағжан (Originals, 751 000)
and Жұмағали Әділжан (Sport, 804 324). Продакшн is now 11 people, ФОТ
12 407 047 ₸; grand total 40 610 731 ₸. Applied to Excel, PowerPoint, HTML.

Co-Authored-By: Claude Opus 4.8 <noreply@anthropic.com>
Claude-Session: https://claude.ai/code/session_015FvdqNtbbJPjugTChUgZkw
</commit_message>
<xml_diff>
--- a/Структура маркетинга — отделы и ФОТ.pptx
+++ b/Структура маркетинга — отделы и ФОТ.pptx
@@ -1939,7 +1939,7 @@
                 <a:ea typeface="Arial" pitchFamily="34" charset="-122"/>
                 <a:cs typeface="Arial" pitchFamily="34" charset="-120"/>
               </a:rPr>
-              <a:t>12</a:t>
+              <a:t>11</a:t>
             </a:r>
             <a:endParaRPr lang="en-US" sz="2900" dirty="0"/>
           </a:p>
@@ -2070,7 +2070,7 @@
                 <a:ea typeface="Arial" pitchFamily="34" charset="-122"/>
                 <a:cs typeface="Arial" pitchFamily="34" charset="-120"/>
               </a:rPr>
-              <a:t>12 930 047 ₸</a:t>
+              <a:t>12 407 047 ₸</a:t>
             </a:r>
             <a:endParaRPr lang="en-US" sz="1200" dirty="0"/>
           </a:p>
@@ -2396,7 +2396,7 @@
                 <a:ea typeface="Arial" pitchFamily="34" charset="-122"/>
                 <a:cs typeface="Arial" pitchFamily="34" charset="-120"/>
               </a:rPr>
-              <a:t>41 133 731 ₸</a:t>
+              <a:t>40 610 731 ₸</a:t>
             </a:r>
             <a:endParaRPr lang="en-US" sz="2600" dirty="0"/>
           </a:p>
@@ -5903,7 +5903,7 @@
                 <a:ea typeface="Arial" pitchFamily="34" charset="-122"/>
                 <a:cs typeface="Arial" pitchFamily="34" charset="-120"/>
               </a:rPr>
-              <a:t>12 930 047 ₸</a:t>
+              <a:t>12 407 047 ₸</a:t>
             </a:r>
             <a:endParaRPr lang="en-US" sz="1900" dirty="0"/>
           </a:p>
@@ -5923,7 +5923,7 @@
                 <a:ea typeface="Arial" pitchFamily="34" charset="-122"/>
                 <a:cs typeface="Arial" pitchFamily="34" charset="-120"/>
               </a:rPr>
-              <a:t>ФОТ отдела · 12 чел. · оклады/мес</a:t>
+              <a:t>ФОТ отдела · 11 чел. · оклады/мес</a:t>
             </a:r>
             <a:endParaRPr lang="en-US" sz="1900" dirty="0"/>
           </a:p>
@@ -7232,7 +7232,7 @@
                 <a:ea typeface="Arial" pitchFamily="34" charset="-122"/>
                 <a:cs typeface="Arial" pitchFamily="34" charset="-120"/>
               </a:rPr>
-              <a:t>Асанов Әділ Асанұлы</a:t>
+              <a:t>Асанов Әділ · Originals</a:t>
             </a:r>
             <a:endParaRPr lang="en-US" sz="1050" dirty="0"/>
           </a:p>
@@ -7348,7 +7348,7 @@
                 <a:ea typeface="Arial" pitchFamily="34" charset="-122"/>
                 <a:cs typeface="Arial" pitchFamily="34" charset="-120"/>
               </a:rPr>
-              <a:t>Шаймардан Мағжан Адилұлы</a:t>
+              <a:t>Шаймардан Мағжан · Originals</a:t>
             </a:r>
             <a:endParaRPr lang="en-US" sz="1050" dirty="0"/>
           </a:p>
@@ -7464,7 +7464,7 @@
                 <a:ea typeface="Arial" pitchFamily="34" charset="-122"/>
                 <a:cs typeface="Arial" pitchFamily="34" charset="-120"/>
               </a:rPr>
-              <a:t>Жұмағали Әділжан Бауыржанұлы</a:t>
+              <a:t>Жұмағали Әділжан · Sport</a:t>
             </a:r>
             <a:endParaRPr lang="en-US" sz="1050" dirty="0"/>
           </a:p>
@@ -7485,122 +7485,6 @@
                 <a:cs typeface="Arial" pitchFamily="34" charset="-120"/>
               </a:rPr>
               <a:t>804 324 ₸</a:t>
-            </a:r>
-            <a:endParaRPr lang="en-US" sz="1050" dirty="0"/>
-          </a:p>
-        </p:txBody>
-      </p:sp>
-      <p:sp>
-        <p:nvSpPr>
-          <p:cNvPr id="38" name="Shape 36"/>
-          <p:cNvSpPr/>
-          <p:nvPr/>
-        </p:nvSpPr>
-        <p:spPr>
-          <a:xfrm>
-            <a:off x="7498080" y="5468112"/>
-            <a:ext cx="3291840" cy="658368"/>
-          </a:xfrm>
-          <a:prstGeom prst="roundRect">
-            <a:avLst>
-              <a:gd name="adj" fmla="val 8333"/>
-            </a:avLst>
-          </a:prstGeom>
-          <a:solidFill>
-            <a:srgbClr val="EAF1FB"/>
-          </a:solidFill>
-          <a:ln w="12700">
-            <a:solidFill>
-              <a:srgbClr val="C7D8EE"/>
-            </a:solidFill>
-            <a:prstDash val="solid"/>
-          </a:ln>
-          <a:effectLst>
-            <a:outerShdw sx="100000" sy="100000" kx="0" ky="0" algn="bl" rotWithShape="0" blurRad="50800" dist="25400" dir="5400000">
-              <a:srgbClr val="9AA7B4">
-                <a:alpha val="28000"/>
-              </a:srgbClr>
-            </a:outerShdw>
-          </a:effectLst>
-        </p:spPr>
-      </p:sp>
-      <p:sp>
-        <p:nvSpPr>
-          <p:cNvPr id="39" name="Text 37"/>
-          <p:cNvSpPr/>
-          <p:nvPr/>
-        </p:nvSpPr>
-        <p:spPr>
-          <a:xfrm>
-            <a:off x="7571232" y="5513832"/>
-            <a:ext cx="3145536" cy="566928"/>
-          </a:xfrm>
-          <a:prstGeom prst="rect">
-            <a:avLst/>
-          </a:prstGeom>
-          <a:noFill/>
-          <a:ln/>
-        </p:spPr>
-        <p:txBody>
-          <a:bodyPr wrap="square" lIns="0" tIns="0" rIns="0" bIns="0" rtlCol="0" anchor="ctr"/>
-          <a:lstStyle/>
-          <a:p>
-            <a:pPr algn="ctr" indent="0" marL="0">
-              <a:lnSpc>
-                <a:spcPct val="100000"/>
-              </a:lnSpc>
-              <a:buNone/>
-            </a:pPr>
-            <a:r>
-              <a:rPr lang="en-US" sz="1050" b="1" dirty="0">
-                <a:solidFill>
-                  <a:srgbClr val="1F2A37"/>
-                </a:solidFill>
-                <a:latin typeface="Arial" pitchFamily="34" charset="0"/>
-                <a:ea typeface="Arial" pitchFamily="34" charset="-122"/>
-                <a:cs typeface="Arial" pitchFamily="34" charset="-120"/>
-              </a:rPr>
-              <a:t>Мобилограф / монтажёр Sport</a:t>
-            </a:r>
-            <a:endParaRPr lang="en-US" sz="1050" dirty="0"/>
-          </a:p>
-          <a:p>
-            <a:pPr algn="ctr" indent="0" marL="0">
-              <a:lnSpc>
-                <a:spcPct val="100000"/>
-              </a:lnSpc>
-              <a:buNone/>
-            </a:pPr>
-            <a:r>
-              <a:rPr lang="en-US" sz="800" i="1" dirty="0">
-                <a:solidFill>
-                  <a:srgbClr val="5B6B7C"/>
-                </a:solidFill>
-                <a:latin typeface="Arial" pitchFamily="34" charset="0"/>
-                <a:ea typeface="Arial" pitchFamily="34" charset="-122"/>
-                <a:cs typeface="Arial" pitchFamily="34" charset="-120"/>
-              </a:rPr>
-              <a:t>Боровков Владимир Владимирович</a:t>
-            </a:r>
-            <a:endParaRPr lang="en-US" sz="1050" dirty="0"/>
-          </a:p>
-          <a:p>
-            <a:pPr algn="ctr" indent="0" marL="0">
-              <a:lnSpc>
-                <a:spcPct val="100000"/>
-              </a:lnSpc>
-              <a:buNone/>
-            </a:pPr>
-            <a:r>
-              <a:rPr lang="en-US" sz="1100" b="1" dirty="0">
-                <a:solidFill>
-                  <a:srgbClr val="0F6E4F"/>
-                </a:solidFill>
-                <a:latin typeface="Arial" pitchFamily="34" charset="0"/>
-                <a:ea typeface="Arial" pitchFamily="34" charset="-122"/>
-                <a:cs typeface="Arial" pitchFamily="34" charset="-120"/>
-              </a:rPr>
-              <a:t>523 000 ₸</a:t>
             </a:r>
             <a:endParaRPr lang="en-US" sz="1050" dirty="0"/>
           </a:p>
@@ -9491,7 +9375,7 @@
                 <a:ea typeface="Arial" pitchFamily="34" charset="-122"/>
                 <a:cs typeface="Arial" pitchFamily="34" charset="-120"/>
               </a:rPr>
-              <a:t>ФОТ отдела = сумма должностных окладов (тотал) всех позиций отдела, включая руководителя. Суммы взяты из Excel; руководители и senior-роли — из отдельного блока стоимостей. Итог по 4 отделам: 41 133 731 ₸ в месяц.</a:t>
+              <a:t>ФОТ отдела = сумма должностных окладов (тотал) всех позиций отдела, включая руководителя. Суммы взяты из Excel; руководители и senior-роли — из отдельного блока стоимостей. Итог по 4 отделам: 40 610 731 ₸ в месяц.</a:t>
             </a:r>
             <a:endParaRPr lang="en-US" sz="1200" dirty="0"/>
           </a:p>

</xml_diff>

<commit_message>
Sync real names from user's edited PDF; swap Боровков for Жанабеков
Bring the source in line with the user's edited export: fill in the real
SMM names (Шафкат Дария, Жандильдина Сабина, Шакрат Темірлан, Кулбаева
Салтанат) and design names (Ахметова, Ли Яна, Аркениязов, Мкпо Майкл, plus
a «Граф дизайнер» placeholder), and set the Senior production subtitle.
Per instruction, replace Боровков with Жанабеков Кудайберген (1 498 769) in
Video production. Marcom 15 496 844 ₸, Продакшн 13 581 877 ₸ (12 people),
grand total 41 605 842 ₸. Applied to Excel, PowerPoint and HTML.

Co-Authored-By: Claude Opus 4.8 <noreply@anthropic.com>
Claude-Session: https://claude.ai/code/session_015FvdqNtbbJPjugTChUgZkw
</commit_message>
<xml_diff>
--- a/Структура маркетинга — отделы и ФОТ.pptx
+++ b/Структура маркетинга — отделы и ФОТ.pptx
@@ -1618,7 +1618,7 @@
                 <a:ea typeface="Arial" pitchFamily="34" charset="-122"/>
                 <a:cs typeface="Arial" pitchFamily="34" charset="-120"/>
               </a:rPr>
-              <a:t>15 676 563 ₸</a:t>
+              <a:t>15 496 844 ₸</a:t>
             </a:r>
             <a:endParaRPr lang="en-US" sz="1200" dirty="0"/>
           </a:p>
@@ -1939,7 +1939,7 @@
                 <a:ea typeface="Arial" pitchFamily="34" charset="-122"/>
                 <a:cs typeface="Arial" pitchFamily="34" charset="-120"/>
               </a:rPr>
-              <a:t>11</a:t>
+              <a:t>12</a:t>
             </a:r>
             <a:endParaRPr lang="en-US" sz="2900" dirty="0"/>
           </a:p>
@@ -2070,7 +2070,7 @@
                 <a:ea typeface="Arial" pitchFamily="34" charset="-122"/>
                 <a:cs typeface="Arial" pitchFamily="34" charset="-120"/>
               </a:rPr>
-              <a:t>12 407 047 ₸</a:t>
+              <a:t>13 581 877 ₸</a:t>
             </a:r>
             <a:endParaRPr lang="en-US" sz="1200" dirty="0"/>
           </a:p>
@@ -2396,7 +2396,7 @@
                 <a:ea typeface="Arial" pitchFamily="34" charset="-122"/>
                 <a:cs typeface="Arial" pitchFamily="34" charset="-120"/>
               </a:rPr>
-              <a:t>40 610 731 ₸</a:t>
+              <a:t>41 605 842 ₸</a:t>
             </a:r>
             <a:endParaRPr lang="en-US" sz="2600" dirty="0"/>
           </a:p>
@@ -2570,7 +2570,7 @@
                 <a:ea typeface="Arial" pitchFamily="34" charset="-122"/>
                 <a:cs typeface="Arial" pitchFamily="34" charset="-120"/>
               </a:rPr>
-              <a:t>15 676 563 ₸</a:t>
+              <a:t>15 496 844 ₸</a:t>
             </a:r>
             <a:endParaRPr lang="en-US" sz="1900" dirty="0"/>
           </a:p>
@@ -4156,7 +4156,7 @@
                 <a:ea typeface="Arial" pitchFamily="34" charset="-122"/>
                 <a:cs typeface="Arial" pitchFamily="34" charset="-120"/>
               </a:rPr>
-              <a:t>SMM менеджер · имя н/д</a:t>
+              <a:t>Шафкат Дария</a:t>
             </a:r>
             <a:endParaRPr lang="en-US" sz="945" dirty="0"/>
           </a:p>
@@ -4170,13 +4170,13 @@
             <a:r>
               <a:rPr lang="en-US" sz="990" b="1" dirty="0">
                 <a:solidFill>
-                  <a:srgbClr val="B45309"/>
-                </a:solidFill>
-                <a:latin typeface="Arial" pitchFamily="34" charset="0"/>
-                <a:ea typeface="Arial" pitchFamily="34" charset="-122"/>
-                <a:cs typeface="Arial" pitchFamily="34" charset="-120"/>
-              </a:rPr>
-              <a:t>867 456 ₸  *</a:t>
+                  <a:srgbClr val="0F6E4F"/>
+                </a:solidFill>
+                <a:latin typeface="Arial" pitchFamily="34" charset="0"/>
+                <a:ea typeface="Arial" pitchFamily="34" charset="-122"/>
+                <a:cs typeface="Arial" pitchFamily="34" charset="-120"/>
+              </a:rPr>
+              <a:t>741 193 ₸</a:t>
             </a:r>
             <a:endParaRPr lang="en-US" sz="945" dirty="0"/>
           </a:p>
@@ -4272,7 +4272,7 @@
                 <a:ea typeface="Arial" pitchFamily="34" charset="-122"/>
                 <a:cs typeface="Arial" pitchFamily="34" charset="-120"/>
               </a:rPr>
-              <a:t>SMM менеджер · имя н/д</a:t>
+              <a:t>Кулбаева Салтанат Фархатқызы</a:t>
             </a:r>
             <a:endParaRPr lang="en-US" sz="945" dirty="0"/>
           </a:p>
@@ -4388,7 +4388,7 @@
                 <a:ea typeface="Arial" pitchFamily="34" charset="-122"/>
                 <a:cs typeface="Arial" pitchFamily="34" charset="-120"/>
               </a:rPr>
-              <a:t>SMM менеджер · имя н/д</a:t>
+              <a:t>Жандильдина Сабина Канатовна</a:t>
             </a:r>
             <a:endParaRPr lang="en-US" sz="945" dirty="0"/>
           </a:p>
@@ -4402,13 +4402,13 @@
             <a:r>
               <a:rPr lang="en-US" sz="990" b="1" dirty="0">
                 <a:solidFill>
-                  <a:srgbClr val="B45309"/>
-                </a:solidFill>
-                <a:latin typeface="Arial" pitchFamily="34" charset="0"/>
-                <a:ea typeface="Arial" pitchFamily="34" charset="-122"/>
-                <a:cs typeface="Arial" pitchFamily="34" charset="-120"/>
-              </a:rPr>
-              <a:t>867 456 ₸  *</a:t>
+                  <a:srgbClr val="0F6E4F"/>
+                </a:solidFill>
+                <a:latin typeface="Arial" pitchFamily="34" charset="0"/>
+                <a:ea typeface="Arial" pitchFamily="34" charset="-122"/>
+                <a:cs typeface="Arial" pitchFamily="34" charset="-120"/>
+              </a:rPr>
+              <a:t>814 000 ₸</a:t>
             </a:r>
             <a:endParaRPr lang="en-US" sz="945" dirty="0"/>
           </a:p>
@@ -4504,7 +4504,7 @@
                 <a:ea typeface="Arial" pitchFamily="34" charset="-122"/>
                 <a:cs typeface="Arial" pitchFamily="34" charset="-120"/>
               </a:rPr>
-              <a:t>SMM менеджер · имя н/д</a:t>
+              <a:t>Шакрат Темірлан Талғатұлы</a:t>
             </a:r>
             <a:endParaRPr lang="en-US" sz="945" dirty="0"/>
           </a:p>
@@ -5903,7 +5903,7 @@
                 <a:ea typeface="Arial" pitchFamily="34" charset="-122"/>
                 <a:cs typeface="Arial" pitchFamily="34" charset="-120"/>
               </a:rPr>
-              <a:t>12 407 047 ₸</a:t>
+              <a:t>13 581 877 ₸</a:t>
             </a:r>
             <a:endParaRPr lang="en-US" sz="1900" dirty="0"/>
           </a:p>
@@ -5923,7 +5923,7 @@
                 <a:ea typeface="Arial" pitchFamily="34" charset="-122"/>
                 <a:cs typeface="Arial" pitchFamily="34" charset="-120"/>
               </a:rPr>
-              <a:t>ФОТ отдела · 11 чел. · оклады/мес</a:t>
+              <a:t>ФОТ отдела · 12 чел. · оклады/мес</a:t>
             </a:r>
             <a:endParaRPr lang="en-US" sz="1900" dirty="0"/>
           </a:p>
@@ -6343,7 +6343,7 @@
                 <a:ea typeface="Arial" pitchFamily="34" charset="-122"/>
                 <a:cs typeface="Arial" pitchFamily="34" charset="-120"/>
               </a:rPr>
-              <a:t>Senior production</a:t>
+              <a:t>Александр Е</a:t>
             </a:r>
             <a:endParaRPr lang="en-US" sz="1200" dirty="0"/>
           </a:p>
@@ -6629,7 +6629,7 @@
                 <a:ea typeface="Arial" pitchFamily="34" charset="-122"/>
                 <a:cs typeface="Arial" pitchFamily="34" charset="-120"/>
               </a:rPr>
-              <a:t>Дизайнер · имя н/д</a:t>
+              <a:t>Ахметова Раушан Нұрланқызы</a:t>
             </a:r>
             <a:endParaRPr lang="en-US" sz="998" dirty="0"/>
           </a:p>
@@ -6643,13 +6643,13 @@
             <a:r>
               <a:rPr lang="en-US" sz="1045" b="1" dirty="0">
                 <a:solidFill>
-                  <a:srgbClr val="B45309"/>
-                </a:solidFill>
-                <a:latin typeface="Arial" pitchFamily="34" charset="0"/>
-                <a:ea typeface="Arial" pitchFamily="34" charset="-122"/>
-                <a:cs typeface="Arial" pitchFamily="34" charset="-120"/>
-              </a:rPr>
-              <a:t>940 000 ₸  *</a:t>
+                  <a:srgbClr val="0F6E4F"/>
+                </a:solidFill>
+                <a:latin typeface="Arial" pitchFamily="34" charset="0"/>
+                <a:ea typeface="Arial" pitchFamily="34" charset="-122"/>
+                <a:cs typeface="Arial" pitchFamily="34" charset="-120"/>
+              </a:rPr>
+              <a:t>815 000 ₸</a:t>
             </a:r>
             <a:endParaRPr lang="en-US" sz="998" dirty="0"/>
           </a:p>
@@ -6745,7 +6745,7 @@
                 <a:ea typeface="Arial" pitchFamily="34" charset="-122"/>
                 <a:cs typeface="Arial" pitchFamily="34" charset="-120"/>
               </a:rPr>
-              <a:t>Дизайнер · имя н/д</a:t>
+              <a:t>Ли Яна Вячеславовна</a:t>
             </a:r>
             <a:endParaRPr lang="en-US" sz="998" dirty="0"/>
           </a:p>
@@ -6861,7 +6861,7 @@
                 <a:ea typeface="Arial" pitchFamily="34" charset="-122"/>
                 <a:cs typeface="Arial" pitchFamily="34" charset="-120"/>
               </a:rPr>
-              <a:t>Дизайнер · имя н/д</a:t>
+              <a:t>Аркениязов Ильяс Юлдашевич</a:t>
             </a:r>
             <a:endParaRPr lang="en-US" sz="998" dirty="0"/>
           </a:p>
@@ -6875,13 +6875,13 @@
             <a:r>
               <a:rPr lang="en-US" sz="1045" b="1" dirty="0">
                 <a:solidFill>
-                  <a:srgbClr val="B45309"/>
-                </a:solidFill>
-                <a:latin typeface="Arial" pitchFamily="34" charset="0"/>
-                <a:ea typeface="Arial" pitchFamily="34" charset="-122"/>
-                <a:cs typeface="Arial" pitchFamily="34" charset="-120"/>
-              </a:rPr>
-              <a:t>940 000 ₸  *</a:t>
+                  <a:srgbClr val="0F6E4F"/>
+                </a:solidFill>
+                <a:latin typeface="Arial" pitchFamily="34" charset="0"/>
+                <a:ea typeface="Arial" pitchFamily="34" charset="-122"/>
+                <a:cs typeface="Arial" pitchFamily="34" charset="-120"/>
+              </a:rPr>
+              <a:t>678 061 ₸</a:t>
             </a:r>
             <a:endParaRPr lang="en-US" sz="998" dirty="0"/>
           </a:p>
@@ -6957,7 +6957,7 @@
                 <a:ea typeface="Arial" pitchFamily="34" charset="-122"/>
                 <a:cs typeface="Arial" pitchFamily="34" charset="-120"/>
               </a:rPr>
-              <a:t>Motion</a:t>
+              <a:t>Graph</a:t>
             </a:r>
             <a:endParaRPr lang="en-US" sz="998" dirty="0"/>
           </a:p>
@@ -6977,7 +6977,7 @@
                 <a:ea typeface="Arial" pitchFamily="34" charset="-122"/>
                 <a:cs typeface="Arial" pitchFamily="34" charset="-120"/>
               </a:rPr>
-              <a:t>Motion-дизайнер · имя н/д</a:t>
+              <a:t>Граф дизайнер</a:t>
             </a:r>
             <a:endParaRPr lang="en-US" sz="998" dirty="0"/>
           </a:p>
@@ -6997,7 +6997,7 @@
                 <a:ea typeface="Arial" pitchFamily="34" charset="-122"/>
                 <a:cs typeface="Arial" pitchFamily="34" charset="-120"/>
               </a:rPr>
-              <a:t>877 000 ₸  *</a:t>
+              <a:t>940 000 ₸  *</a:t>
             </a:r>
             <a:endParaRPr lang="en-US" sz="998" dirty="0"/>
           </a:p>
@@ -7093,7 +7093,7 @@
                 <a:ea typeface="Arial" pitchFamily="34" charset="-122"/>
                 <a:cs typeface="Arial" pitchFamily="34" charset="-120"/>
               </a:rPr>
-              <a:t>Motion-дизайнер · имя н/д</a:t>
+              <a:t>Мкпо Майкл Жозеф</a:t>
             </a:r>
             <a:endParaRPr lang="en-US" sz="998" dirty="0"/>
           </a:p>
@@ -7107,13 +7107,13 @@
             <a:r>
               <a:rPr lang="en-US" sz="1045" b="1" dirty="0">
                 <a:solidFill>
-                  <a:srgbClr val="B45309"/>
-                </a:solidFill>
-                <a:latin typeface="Arial" pitchFamily="34" charset="0"/>
-                <a:ea typeface="Arial" pitchFamily="34" charset="-122"/>
-                <a:cs typeface="Arial" pitchFamily="34" charset="-120"/>
-              </a:rPr>
-              <a:t>877 000 ₸  *</a:t>
+                  <a:srgbClr val="0F6E4F"/>
+                </a:solidFill>
+                <a:latin typeface="Arial" pitchFamily="34" charset="0"/>
+                <a:ea typeface="Arial" pitchFamily="34" charset="-122"/>
+                <a:cs typeface="Arial" pitchFamily="34" charset="-120"/>
+              </a:rPr>
+              <a:t>877 000 ₸</a:t>
             </a:r>
             <a:endParaRPr lang="en-US" sz="998" dirty="0"/>
           </a:p>
@@ -7232,7 +7232,7 @@
                 <a:ea typeface="Arial" pitchFamily="34" charset="-122"/>
                 <a:cs typeface="Arial" pitchFamily="34" charset="-120"/>
               </a:rPr>
-              <a:t>Асанов Әділ · Originals</a:t>
+              <a:t>Асанов Әділ Асанұлы</a:t>
             </a:r>
             <a:endParaRPr lang="en-US" sz="1050" dirty="0"/>
           </a:p>
@@ -7348,7 +7348,7 @@
                 <a:ea typeface="Arial" pitchFamily="34" charset="-122"/>
                 <a:cs typeface="Arial" pitchFamily="34" charset="-120"/>
               </a:rPr>
-              <a:t>Шаймардан Мағжан · Originals</a:t>
+              <a:t>Шаймардан Мағжан Адилұлы</a:t>
             </a:r>
             <a:endParaRPr lang="en-US" sz="1050" dirty="0"/>
           </a:p>
@@ -7464,7 +7464,7 @@
                 <a:ea typeface="Arial" pitchFamily="34" charset="-122"/>
                 <a:cs typeface="Arial" pitchFamily="34" charset="-120"/>
               </a:rPr>
-              <a:t>Жұмағали Әділжан · Sport</a:t>
+              <a:t>Жұмағали Әділжан Бауыржанұлы</a:t>
             </a:r>
             <a:endParaRPr lang="en-US" sz="1050" dirty="0"/>
           </a:p>
@@ -7485,6 +7485,122 @@
                 <a:cs typeface="Arial" pitchFamily="34" charset="-120"/>
               </a:rPr>
               <a:t>804 324 ₸</a:t>
+            </a:r>
+            <a:endParaRPr lang="en-US" sz="1050" dirty="0"/>
+          </a:p>
+        </p:txBody>
+      </p:sp>
+      <p:sp>
+        <p:nvSpPr>
+          <p:cNvPr id="38" name="Shape 36"/>
+          <p:cNvSpPr/>
+          <p:nvPr/>
+        </p:nvSpPr>
+        <p:spPr>
+          <a:xfrm>
+            <a:off x="7498080" y="5468112"/>
+            <a:ext cx="3291840" cy="658368"/>
+          </a:xfrm>
+          <a:prstGeom prst="roundRect">
+            <a:avLst>
+              <a:gd name="adj" fmla="val 8333"/>
+            </a:avLst>
+          </a:prstGeom>
+          <a:solidFill>
+            <a:srgbClr val="EAF1FB"/>
+          </a:solidFill>
+          <a:ln w="12700">
+            <a:solidFill>
+              <a:srgbClr val="C7D8EE"/>
+            </a:solidFill>
+            <a:prstDash val="solid"/>
+          </a:ln>
+          <a:effectLst>
+            <a:outerShdw sx="100000" sy="100000" kx="0" ky="0" algn="bl" rotWithShape="0" blurRad="50800" dist="25400" dir="5400000">
+              <a:srgbClr val="9AA7B4">
+                <a:alpha val="28000"/>
+              </a:srgbClr>
+            </a:outerShdw>
+          </a:effectLst>
+        </p:spPr>
+      </p:sp>
+      <p:sp>
+        <p:nvSpPr>
+          <p:cNvPr id="39" name="Text 37"/>
+          <p:cNvSpPr/>
+          <p:nvPr/>
+        </p:nvSpPr>
+        <p:spPr>
+          <a:xfrm>
+            <a:off x="7571232" y="5513832"/>
+            <a:ext cx="3145536" cy="566928"/>
+          </a:xfrm>
+          <a:prstGeom prst="rect">
+            <a:avLst/>
+          </a:prstGeom>
+          <a:noFill/>
+          <a:ln/>
+        </p:spPr>
+        <p:txBody>
+          <a:bodyPr wrap="square" lIns="0" tIns="0" rIns="0" bIns="0" rtlCol="0" anchor="ctr"/>
+          <a:lstStyle/>
+          <a:p>
+            <a:pPr algn="ctr" indent="0" marL="0">
+              <a:lnSpc>
+                <a:spcPct val="100000"/>
+              </a:lnSpc>
+              <a:buNone/>
+            </a:pPr>
+            <a:r>
+              <a:rPr lang="en-US" sz="1050" b="1" dirty="0">
+                <a:solidFill>
+                  <a:srgbClr val="1F2A37"/>
+                </a:solidFill>
+                <a:latin typeface="Arial" pitchFamily="34" charset="0"/>
+                <a:ea typeface="Arial" pitchFamily="34" charset="-122"/>
+                <a:cs typeface="Arial" pitchFamily="34" charset="-120"/>
+              </a:rPr>
+              <a:t>Мобилограф / монтажёр Sport</a:t>
+            </a:r>
+            <a:endParaRPr lang="en-US" sz="1050" dirty="0"/>
+          </a:p>
+          <a:p>
+            <a:pPr algn="ctr" indent="0" marL="0">
+              <a:lnSpc>
+                <a:spcPct val="100000"/>
+              </a:lnSpc>
+              <a:buNone/>
+            </a:pPr>
+            <a:r>
+              <a:rPr lang="en-US" sz="800" i="1" dirty="0">
+                <a:solidFill>
+                  <a:srgbClr val="5B6B7C"/>
+                </a:solidFill>
+                <a:latin typeface="Arial" pitchFamily="34" charset="0"/>
+                <a:ea typeface="Arial" pitchFamily="34" charset="-122"/>
+                <a:cs typeface="Arial" pitchFamily="34" charset="-120"/>
+              </a:rPr>
+              <a:t>Жанабеков Кудайберген Канатович</a:t>
+            </a:r>
+            <a:endParaRPr lang="en-US" sz="1050" dirty="0"/>
+          </a:p>
+          <a:p>
+            <a:pPr algn="ctr" indent="0" marL="0">
+              <a:lnSpc>
+                <a:spcPct val="100000"/>
+              </a:lnSpc>
+              <a:buNone/>
+            </a:pPr>
+            <a:r>
+              <a:rPr lang="en-US" sz="1100" b="1" dirty="0">
+                <a:solidFill>
+                  <a:srgbClr val="0F6E4F"/>
+                </a:solidFill>
+                <a:latin typeface="Arial" pitchFamily="34" charset="0"/>
+                <a:ea typeface="Arial" pitchFamily="34" charset="-122"/>
+                <a:cs typeface="Arial" pitchFamily="34" charset="-120"/>
+              </a:rPr>
+              <a:t>1 498 769 ₸</a:t>
             </a:r>
             <a:endParaRPr lang="en-US" sz="1050" dirty="0"/>
           </a:p>
@@ -9375,7 +9491,7 @@
                 <a:ea typeface="Arial" pitchFamily="34" charset="-122"/>
                 <a:cs typeface="Arial" pitchFamily="34" charset="-120"/>
               </a:rPr>
-              <a:t>ФОТ отдела = сумма должностных окладов (тотал) всех позиций отдела, включая руководителя. Суммы взяты из Excel; руководители и senior-роли — из отдельного блока стоимостей. Итог по 4 отделам: 40 610 731 ₸ в месяц.</a:t>
+              <a:t>ФОТ отдела = сумма должностных окладов (тотал) всех позиций отдела, включая руководителя. Суммы взяты из Excel; руководители и senior-роли — из отдельного блока стоимостей. Итог по 4 отделам: 41 605 842 ₸ в месяц.</a:t>
             </a:r>
             <a:endParaRPr lang="en-US" sz="1200" dirty="0"/>
           </a:p>

</xml_diff>

<commit_message>
Leave the fourth Graph position empty (open role, 940 000 ₸ *)
Clear the «Граф дизайнер» placeholder name per request; the box stays an
open Graph position with the max cost 940 000 ₸ and its * marker. The
existing * markers on the named SMM/Graph rows are kept as-is. Totals
unchanged (Продакшн 13 581 877 ₸, grand 41 605 842 ₸).

Co-Authored-By: Claude Opus 4.8 <noreply@anthropic.com>
Claude-Session: https://claude.ai/code/session_015FvdqNtbbJPjugTChUgZkw
</commit_message>
<xml_diff>
--- a/Структура маркетинга — отделы и ФОТ.pptx
+++ b/Структура маркетинга — отделы и ФОТ.pptx
@@ -6968,17 +6968,6 @@
               </a:lnSpc>
               <a:buNone/>
             </a:pPr>
-            <a:r>
-              <a:rPr lang="en-US" sz="760" i="1" dirty="0">
-                <a:solidFill>
-                  <a:srgbClr val="5B6B7C"/>
-                </a:solidFill>
-                <a:latin typeface="Arial" pitchFamily="34" charset="0"/>
-                <a:ea typeface="Arial" pitchFamily="34" charset="-122"/>
-                <a:cs typeface="Arial" pitchFamily="34" charset="-120"/>
-              </a:rPr>
-              <a:t>Граф дизайнер</a:t>
-            </a:r>
             <a:endParaRPr lang="en-US" sz="998" dirty="0"/>
           </a:p>
           <a:p>

</xml_diff>

<commit_message>
Add optimized (post-layoff) variant of the deck, Excel and HTML
Add a second «оптимизация» set built from the layoff list: drop Шафкат
Дария and Кулбаева Салтанат (SMM), Асанов, Шаймардан and Жұмағали
(videographers) and the empty Graph slot, while keeping Ахметова Раушан
per instruction. The optimized structure is 31 people, ФОТ 36 501 707 ₸.

Make the generator robust to removed positions: M() skips missing keys and
empty direction columns are dropped (no orphan headers); make_xlsx.py takes
a REMOVE env of keys and gen.js a DECK_DATA path, so both variants come
from one pipeline. Full version output is unchanged.

Co-Authored-By: Claude Opus 4.8 <noreply@anthropic.com>
Claude-Session: https://claude.ai/code/session_015FvdqNtbbJPjugTChUgZkw
</commit_message>
<xml_diff>
--- a/Структура маркетинга — отделы и ФОТ.pptx
+++ b/Структура маркетинга — отделы и ФОТ.pptx
@@ -2985,46 +2985,7 @@
       </p:sp>
       <p:sp>
         <p:nvSpPr>
-          <p:cNvPr id="16" name="Text 14"/>
-          <p:cNvSpPr/>
-          <p:nvPr/>
-        </p:nvSpPr>
-        <p:spPr>
-          <a:xfrm>
-            <a:off x="2258568" y="2359152"/>
-            <a:ext cx="1691640" cy="201168"/>
-          </a:xfrm>
-          <a:prstGeom prst="rect">
-            <a:avLst/>
-          </a:prstGeom>
-          <a:noFill/>
-          <a:ln/>
-        </p:spPr>
-        <p:txBody>
-          <a:bodyPr wrap="square" lIns="0" tIns="0" rIns="0" bIns="0" rtlCol="0" anchor="ctr"/>
-          <a:lstStyle/>
-          <a:p>
-            <a:pPr algn="ctr" indent="0" marL="0">
-              <a:buNone/>
-            </a:pPr>
-            <a:r>
-              <a:rPr lang="en-US" sz="900" b="1" dirty="0">
-                <a:solidFill>
-                  <a:srgbClr val="5B6B7C"/>
-                </a:solidFill>
-                <a:latin typeface="Arial" pitchFamily="34" charset="0"/>
-                <a:ea typeface="Arial" pitchFamily="34" charset="-122"/>
-                <a:cs typeface="Arial" pitchFamily="34" charset="-120"/>
-              </a:rPr>
-              <a:t>Sport</a:t>
-            </a:r>
-            <a:endParaRPr lang="en-US" sz="900" dirty="0"/>
-          </a:p>
-        </p:txBody>
-      </p:sp>
-      <p:sp>
-        <p:nvSpPr>
-          <p:cNvPr id="17" name="Shape 15"/>
+          <p:cNvPr id="16" name="Shape 14"/>
           <p:cNvSpPr/>
           <p:nvPr/>
         </p:nvSpPr>
@@ -3058,7 +3019,7 @@
       </p:sp>
       <p:sp>
         <p:nvSpPr>
-          <p:cNvPr id="18" name="Text 16"/>
+          <p:cNvPr id="17" name="Text 15"/>
           <p:cNvSpPr/>
           <p:nvPr/>
         </p:nvSpPr>
@@ -3140,7 +3101,7 @@
       </p:sp>
       <p:sp>
         <p:nvSpPr>
-          <p:cNvPr id="19" name="Shape 17"/>
+          <p:cNvPr id="18" name="Shape 16"/>
           <p:cNvSpPr/>
           <p:nvPr/>
         </p:nvSpPr>
@@ -3174,7 +3135,7 @@
       </p:sp>
       <p:sp>
         <p:nvSpPr>
-          <p:cNvPr id="20" name="Text 18"/>
+          <p:cNvPr id="19" name="Text 17"/>
           <p:cNvSpPr/>
           <p:nvPr/>
         </p:nvSpPr>
@@ -3256,7 +3217,7 @@
       </p:sp>
       <p:sp>
         <p:nvSpPr>
-          <p:cNvPr id="21" name="Shape 19"/>
+          <p:cNvPr id="20" name="Shape 18"/>
           <p:cNvSpPr/>
           <p:nvPr/>
         </p:nvSpPr>
@@ -3290,7 +3251,7 @@
       </p:sp>
       <p:sp>
         <p:nvSpPr>
-          <p:cNvPr id="22" name="Text 20"/>
+          <p:cNvPr id="21" name="Text 19"/>
           <p:cNvSpPr/>
           <p:nvPr/>
         </p:nvSpPr>
@@ -3372,7 +3333,7 @@
       </p:sp>
       <p:sp>
         <p:nvSpPr>
-          <p:cNvPr id="23" name="Shape 21"/>
+          <p:cNvPr id="22" name="Shape 20"/>
           <p:cNvSpPr/>
           <p:nvPr/>
         </p:nvSpPr>
@@ -3406,7 +3367,7 @@
       </p:sp>
       <p:sp>
         <p:nvSpPr>
-          <p:cNvPr id="24" name="Text 22"/>
+          <p:cNvPr id="23" name="Text 21"/>
           <p:cNvSpPr/>
           <p:nvPr/>
         </p:nvSpPr>
@@ -3483,6 +3444,45 @@
               <a:t>1 000 162 ₸</a:t>
             </a:r>
             <a:endParaRPr lang="en-US" sz="945" dirty="0"/>
+          </a:p>
+        </p:txBody>
+      </p:sp>
+      <p:sp>
+        <p:nvSpPr>
+          <p:cNvPr id="24" name="Text 22"/>
+          <p:cNvSpPr/>
+          <p:nvPr/>
+        </p:nvSpPr>
+        <p:spPr>
+          <a:xfrm>
+            <a:off x="2258568" y="2359152"/>
+            <a:ext cx="1691640" cy="201168"/>
+          </a:xfrm>
+          <a:prstGeom prst="rect">
+            <a:avLst/>
+          </a:prstGeom>
+          <a:noFill/>
+          <a:ln/>
+        </p:spPr>
+        <p:txBody>
+          <a:bodyPr wrap="square" lIns="0" tIns="0" rIns="0" bIns="0" rtlCol="0" anchor="ctr"/>
+          <a:lstStyle/>
+          <a:p>
+            <a:pPr algn="ctr" indent="0" marL="0">
+              <a:buNone/>
+            </a:pPr>
+            <a:r>
+              <a:rPr lang="en-US" sz="900" b="1" dirty="0">
+                <a:solidFill>
+                  <a:srgbClr val="5B6B7C"/>
+                </a:solidFill>
+                <a:latin typeface="Arial" pitchFamily="34" charset="0"/>
+                <a:ea typeface="Arial" pitchFamily="34" charset="-122"/>
+                <a:cs typeface="Arial" pitchFamily="34" charset="-120"/>
+              </a:rPr>
+              <a:t>Sport</a:t>
+            </a:r>
+            <a:endParaRPr lang="en-US" sz="900" dirty="0"/>
           </a:p>
         </p:txBody>
       </p:sp>
@@ -3836,124 +3836,7 @@
       </p:sp>
       <p:sp>
         <p:nvSpPr>
-          <p:cNvPr id="31" name="Text 29"/>
-          <p:cNvSpPr/>
-          <p:nvPr/>
-        </p:nvSpPr>
-        <p:spPr>
-          <a:xfrm>
-            <a:off x="4315968" y="3090672"/>
-            <a:ext cx="1691640" cy="201168"/>
-          </a:xfrm>
-          <a:prstGeom prst="rect">
-            <a:avLst/>
-          </a:prstGeom>
-          <a:noFill/>
-          <a:ln/>
-        </p:spPr>
-        <p:txBody>
-          <a:bodyPr wrap="square" lIns="0" tIns="0" rIns="0" bIns="0" rtlCol="0" anchor="ctr"/>
-          <a:lstStyle/>
-          <a:p>
-            <a:pPr algn="ctr" indent="0" marL="0">
-              <a:buNone/>
-            </a:pPr>
-            <a:r>
-              <a:rPr lang="en-US" sz="900" b="1" dirty="0">
-                <a:solidFill>
-                  <a:srgbClr val="5B6B7C"/>
-                </a:solidFill>
-                <a:latin typeface="Arial" pitchFamily="34" charset="0"/>
-                <a:ea typeface="Arial" pitchFamily="34" charset="-122"/>
-                <a:cs typeface="Arial" pitchFamily="34" charset="-120"/>
-              </a:rPr>
-              <a:t>Originals</a:t>
-            </a:r>
-            <a:endParaRPr lang="en-US" sz="900" dirty="0"/>
-          </a:p>
-        </p:txBody>
-      </p:sp>
-      <p:sp>
-        <p:nvSpPr>
-          <p:cNvPr id="32" name="Text 30"/>
-          <p:cNvSpPr/>
-          <p:nvPr/>
-        </p:nvSpPr>
-        <p:spPr>
-          <a:xfrm>
-            <a:off x="6117336" y="3090672"/>
-            <a:ext cx="1691640" cy="201168"/>
-          </a:xfrm>
-          <a:prstGeom prst="rect">
-            <a:avLst/>
-          </a:prstGeom>
-          <a:noFill/>
-          <a:ln/>
-        </p:spPr>
-        <p:txBody>
-          <a:bodyPr wrap="square" lIns="0" tIns="0" rIns="0" bIns="0" rtlCol="0" anchor="ctr"/>
-          <a:lstStyle/>
-          <a:p>
-            <a:pPr algn="ctr" indent="0" marL="0">
-              <a:buNone/>
-            </a:pPr>
-            <a:r>
-              <a:rPr lang="en-US" sz="900" b="1" dirty="0">
-                <a:solidFill>
-                  <a:srgbClr val="5B6B7C"/>
-                </a:solidFill>
-                <a:latin typeface="Arial" pitchFamily="34" charset="0"/>
-                <a:ea typeface="Arial" pitchFamily="34" charset="-122"/>
-                <a:cs typeface="Arial" pitchFamily="34" charset="-120"/>
-              </a:rPr>
-              <a:t>Gen</a:t>
-            </a:r>
-            <a:endParaRPr lang="en-US" sz="900" dirty="0"/>
-          </a:p>
-        </p:txBody>
-      </p:sp>
-      <p:sp>
-        <p:nvSpPr>
-          <p:cNvPr id="33" name="Text 31"/>
-          <p:cNvSpPr/>
-          <p:nvPr/>
-        </p:nvSpPr>
-        <p:spPr>
-          <a:xfrm>
-            <a:off x="7918704" y="3090672"/>
-            <a:ext cx="1691640" cy="201168"/>
-          </a:xfrm>
-          <a:prstGeom prst="rect">
-            <a:avLst/>
-          </a:prstGeom>
-          <a:noFill/>
-          <a:ln/>
-        </p:spPr>
-        <p:txBody>
-          <a:bodyPr wrap="square" lIns="0" tIns="0" rIns="0" bIns="0" rtlCol="0" anchor="ctr"/>
-          <a:lstStyle/>
-          <a:p>
-            <a:pPr algn="ctr" indent="0" marL="0">
-              <a:buNone/>
-            </a:pPr>
-            <a:r>
-              <a:rPr lang="en-US" sz="900" b="1" dirty="0">
-                <a:solidFill>
-                  <a:srgbClr val="5B6B7C"/>
-                </a:solidFill>
-                <a:latin typeface="Arial" pitchFamily="34" charset="0"/>
-                <a:ea typeface="Arial" pitchFamily="34" charset="-122"/>
-                <a:cs typeface="Arial" pitchFamily="34" charset="-120"/>
-              </a:rPr>
-              <a:t>Sport</a:t>
-            </a:r>
-            <a:endParaRPr lang="en-US" sz="900" dirty="0"/>
-          </a:p>
-        </p:txBody>
-      </p:sp>
-      <p:sp>
-        <p:nvSpPr>
-          <p:cNvPr id="34" name="Shape 32"/>
+          <p:cNvPr id="31" name="Shape 29"/>
           <p:cNvSpPr/>
           <p:nvPr/>
         </p:nvSpPr>
@@ -3976,7 +3859,7 @@
       </p:sp>
       <p:sp>
         <p:nvSpPr>
-          <p:cNvPr id="35" name="Shape 33"/>
+          <p:cNvPr id="32" name="Shape 30"/>
           <p:cNvSpPr/>
           <p:nvPr/>
         </p:nvSpPr>
@@ -3999,7 +3882,46 @@
       </p:sp>
       <p:sp>
         <p:nvSpPr>
-          <p:cNvPr id="36" name="Shape 34"/>
+          <p:cNvPr id="33" name="Text 31"/>
+          <p:cNvSpPr/>
+          <p:nvPr/>
+        </p:nvSpPr>
+        <p:spPr>
+          <a:xfrm>
+            <a:off x="4315968" y="3090672"/>
+            <a:ext cx="1691640" cy="201168"/>
+          </a:xfrm>
+          <a:prstGeom prst="rect">
+            <a:avLst/>
+          </a:prstGeom>
+          <a:noFill/>
+          <a:ln/>
+        </p:spPr>
+        <p:txBody>
+          <a:bodyPr wrap="square" lIns="0" tIns="0" rIns="0" bIns="0" rtlCol="0" anchor="ctr"/>
+          <a:lstStyle/>
+          <a:p>
+            <a:pPr algn="ctr" indent="0" marL="0">
+              <a:buNone/>
+            </a:pPr>
+            <a:r>
+              <a:rPr lang="en-US" sz="900" b="1" dirty="0">
+                <a:solidFill>
+                  <a:srgbClr val="5B6B7C"/>
+                </a:solidFill>
+                <a:latin typeface="Arial" pitchFamily="34" charset="0"/>
+                <a:ea typeface="Arial" pitchFamily="34" charset="-122"/>
+                <a:cs typeface="Arial" pitchFamily="34" charset="-120"/>
+              </a:rPr>
+              <a:t>Originals</a:t>
+            </a:r>
+            <a:endParaRPr lang="en-US" sz="900" dirty="0"/>
+          </a:p>
+        </p:txBody>
+      </p:sp>
+      <p:sp>
+        <p:nvSpPr>
+          <p:cNvPr id="34" name="Shape 32"/>
           <p:cNvSpPr/>
           <p:nvPr/>
         </p:nvSpPr>
@@ -4022,53 +3944,7 @@
       </p:sp>
       <p:sp>
         <p:nvSpPr>
-          <p:cNvPr id="37" name="Shape 35"/>
-          <p:cNvSpPr/>
-          <p:nvPr/>
-        </p:nvSpPr>
-        <p:spPr>
-          <a:xfrm>
-            <a:off x="6963156" y="3145536"/>
-            <a:ext cx="0" cy="182880"/>
-          </a:xfrm>
-          <a:prstGeom prst="line">
-            <a:avLst/>
-          </a:prstGeom>
-          <a:noFill/>
-          <a:ln w="12700">
-            <a:solidFill>
-              <a:srgbClr val="C7D8EE"/>
-            </a:solidFill>
-            <a:prstDash val="solid"/>
-          </a:ln>
-        </p:spPr>
-      </p:sp>
-      <p:sp>
-        <p:nvSpPr>
-          <p:cNvPr id="38" name="Shape 36"/>
-          <p:cNvSpPr/>
-          <p:nvPr/>
-        </p:nvSpPr>
-        <p:spPr>
-          <a:xfrm>
-            <a:off x="8764524" y="3145536"/>
-            <a:ext cx="0" cy="182880"/>
-          </a:xfrm>
-          <a:prstGeom prst="line">
-            <a:avLst/>
-          </a:prstGeom>
-          <a:noFill/>
-          <a:ln w="12700">
-            <a:solidFill>
-              <a:srgbClr val="C7D8EE"/>
-            </a:solidFill>
-            <a:prstDash val="solid"/>
-          </a:ln>
-        </p:spPr>
-      </p:sp>
-      <p:sp>
-        <p:nvSpPr>
-          <p:cNvPr id="39" name="Shape 37"/>
+          <p:cNvPr id="35" name="Shape 33"/>
           <p:cNvSpPr/>
           <p:nvPr/>
         </p:nvSpPr>
@@ -4102,7 +3978,7 @@
       </p:sp>
       <p:sp>
         <p:nvSpPr>
-          <p:cNvPr id="40" name="Text 38"/>
+          <p:cNvPr id="36" name="Text 34"/>
           <p:cNvSpPr/>
           <p:nvPr/>
         </p:nvSpPr>
@@ -4184,7 +4060,7 @@
       </p:sp>
       <p:sp>
         <p:nvSpPr>
-          <p:cNvPr id="41" name="Shape 39"/>
+          <p:cNvPr id="37" name="Shape 35"/>
           <p:cNvSpPr/>
           <p:nvPr/>
         </p:nvSpPr>
@@ -4218,7 +4094,7 @@
       </p:sp>
       <p:sp>
         <p:nvSpPr>
-          <p:cNvPr id="42" name="Text 40"/>
+          <p:cNvPr id="38" name="Text 36"/>
           <p:cNvSpPr/>
           <p:nvPr/>
         </p:nvSpPr>
@@ -4300,7 +4176,69 @@
       </p:sp>
       <p:sp>
         <p:nvSpPr>
-          <p:cNvPr id="43" name="Shape 41"/>
+          <p:cNvPr id="39" name="Text 37"/>
+          <p:cNvSpPr/>
+          <p:nvPr/>
+        </p:nvSpPr>
+        <p:spPr>
+          <a:xfrm>
+            <a:off x="6117336" y="3090672"/>
+            <a:ext cx="1691640" cy="201168"/>
+          </a:xfrm>
+          <a:prstGeom prst="rect">
+            <a:avLst/>
+          </a:prstGeom>
+          <a:noFill/>
+          <a:ln/>
+        </p:spPr>
+        <p:txBody>
+          <a:bodyPr wrap="square" lIns="0" tIns="0" rIns="0" bIns="0" rtlCol="0" anchor="ctr"/>
+          <a:lstStyle/>
+          <a:p>
+            <a:pPr algn="ctr" indent="0" marL="0">
+              <a:buNone/>
+            </a:pPr>
+            <a:r>
+              <a:rPr lang="en-US" sz="900" b="1" dirty="0">
+                <a:solidFill>
+                  <a:srgbClr val="5B6B7C"/>
+                </a:solidFill>
+                <a:latin typeface="Arial" pitchFamily="34" charset="0"/>
+                <a:ea typeface="Arial" pitchFamily="34" charset="-122"/>
+                <a:cs typeface="Arial" pitchFamily="34" charset="-120"/>
+              </a:rPr>
+              <a:t>Gen</a:t>
+            </a:r>
+            <a:endParaRPr lang="en-US" sz="900" dirty="0"/>
+          </a:p>
+        </p:txBody>
+      </p:sp>
+      <p:sp>
+        <p:nvSpPr>
+          <p:cNvPr id="40" name="Shape 38"/>
+          <p:cNvSpPr/>
+          <p:nvPr/>
+        </p:nvSpPr>
+        <p:spPr>
+          <a:xfrm>
+            <a:off x="6963156" y="3145536"/>
+            <a:ext cx="0" cy="182880"/>
+          </a:xfrm>
+          <a:prstGeom prst="line">
+            <a:avLst/>
+          </a:prstGeom>
+          <a:noFill/>
+          <a:ln w="12700">
+            <a:solidFill>
+              <a:srgbClr val="C7D8EE"/>
+            </a:solidFill>
+            <a:prstDash val="solid"/>
+          </a:ln>
+        </p:spPr>
+      </p:sp>
+      <p:sp>
+        <p:nvSpPr>
+          <p:cNvPr id="41" name="Shape 39"/>
           <p:cNvSpPr/>
           <p:nvPr/>
         </p:nvSpPr>
@@ -4334,7 +4272,7 @@
       </p:sp>
       <p:sp>
         <p:nvSpPr>
-          <p:cNvPr id="44" name="Text 42"/>
+          <p:cNvPr id="42" name="Text 40"/>
           <p:cNvSpPr/>
           <p:nvPr/>
         </p:nvSpPr>
@@ -4413,6 +4351,68 @@
             <a:endParaRPr lang="en-US" sz="945" dirty="0"/>
           </a:p>
         </p:txBody>
+      </p:sp>
+      <p:sp>
+        <p:nvSpPr>
+          <p:cNvPr id="43" name="Text 41"/>
+          <p:cNvSpPr/>
+          <p:nvPr/>
+        </p:nvSpPr>
+        <p:spPr>
+          <a:xfrm>
+            <a:off x="7918704" y="3090672"/>
+            <a:ext cx="1691640" cy="201168"/>
+          </a:xfrm>
+          <a:prstGeom prst="rect">
+            <a:avLst/>
+          </a:prstGeom>
+          <a:noFill/>
+          <a:ln/>
+        </p:spPr>
+        <p:txBody>
+          <a:bodyPr wrap="square" lIns="0" tIns="0" rIns="0" bIns="0" rtlCol="0" anchor="ctr"/>
+          <a:lstStyle/>
+          <a:p>
+            <a:pPr algn="ctr" indent="0" marL="0">
+              <a:buNone/>
+            </a:pPr>
+            <a:r>
+              <a:rPr lang="en-US" sz="900" b="1" dirty="0">
+                <a:solidFill>
+                  <a:srgbClr val="5B6B7C"/>
+                </a:solidFill>
+                <a:latin typeface="Arial" pitchFamily="34" charset="0"/>
+                <a:ea typeface="Arial" pitchFamily="34" charset="-122"/>
+                <a:cs typeface="Arial" pitchFamily="34" charset="-120"/>
+              </a:rPr>
+              <a:t>Sport</a:t>
+            </a:r>
+            <a:endParaRPr lang="en-US" sz="900" dirty="0"/>
+          </a:p>
+        </p:txBody>
+      </p:sp>
+      <p:sp>
+        <p:nvSpPr>
+          <p:cNvPr id="44" name="Shape 42"/>
+          <p:cNvSpPr/>
+          <p:nvPr/>
+        </p:nvSpPr>
+        <p:spPr>
+          <a:xfrm>
+            <a:off x="8764524" y="3145536"/>
+            <a:ext cx="0" cy="182880"/>
+          </a:xfrm>
+          <a:prstGeom prst="line">
+            <a:avLst/>
+          </a:prstGeom>
+          <a:noFill/>
+          <a:ln w="12700">
+            <a:solidFill>
+              <a:srgbClr val="C7D8EE"/>
+            </a:solidFill>
+            <a:prstDash val="solid"/>
+          </a:ln>
+        </p:spPr>
       </p:sp>
       <p:sp>
         <p:nvSpPr>

</xml_diff>